<commit_message>
Arbeitsblatt: Kopfzeile mit Cleverbox-Wortmarke und QR-Code zu www.cleverbox.co.at
Co-Authored-By: Claude Sonnet 5.5 <noreply@anthropic.com>
Claude-Session: https://claude.ai/code/session_0139kriXJ67p3UvpR2gsSR9G
</commit_message>
<xml_diff>
--- a/videoslides/arbeitsblatt-textgleichungen-a4.pptx
+++ b/videoslides/arbeitsblatt-textgleichungen-a4.pptx
@@ -1448,7 +1448,169 @@
         </p:nvSpPr>
         <p:spPr>
           <a:xfrm>
-            <a:off x="548640" y="502920"/>
+            <a:off x="548640" y="274320"/>
+            <a:ext cx="2926080" cy="731520"/>
+          </a:xfrm>
+          <a:prstGeom prst="rect">
+            <a:avLst/>
+          </a:prstGeom>
+          <a:noFill/>
+          <a:ln/>
+        </p:spPr>
+        <p:txBody>
+          <a:bodyPr wrap="square" lIns="0" tIns="0" rIns="0" bIns="0" rtlCol="0" anchor="ctr"/>
+          <a:lstStyle/>
+          <a:p>
+            <a:pPr indent="0" marL="0">
+              <a:buNone/>
+            </a:pPr>
+            <a:r>
+              <a:rPr lang="en-US" sz="3000" b="1" dirty="0">
+                <a:solidFill>
+                  <a:srgbClr val="475BA6"/>
+                </a:solidFill>
+                <a:latin typeface="Poppins" pitchFamily="34" charset="0"/>
+                <a:ea typeface="Poppins" pitchFamily="34" charset="-122"/>
+                <a:cs typeface="Poppins" pitchFamily="34" charset="-120"/>
+              </a:rPr>
+              <a:t>clever</a:t>
+            </a:r>
+            <a:pPr indent="0" marL="0">
+              <a:buNone/>
+            </a:pPr>
+            <a:r>
+              <a:rPr lang="en-US" sz="3000" b="1" dirty="0">
+                <a:solidFill>
+                  <a:srgbClr val="36448A"/>
+                </a:solidFill>
+                <a:latin typeface="Poppins" pitchFamily="34" charset="0"/>
+                <a:ea typeface="Poppins" pitchFamily="34" charset="-122"/>
+                <a:cs typeface="Poppins" pitchFamily="34" charset="-120"/>
+              </a:rPr>
+              <a:t>box</a:t>
+            </a:r>
+            <a:endParaRPr lang="en-US" sz="3000" dirty="0"/>
+          </a:p>
+        </p:txBody>
+      </p:sp>
+      <p:pic>
+        <p:nvPicPr>
+          <p:cNvPr id="4" name="Image 0" descr="QR-Code zu www.cleverbox.co.at">    </p:cNvPr>
+          <p:cNvPicPr>
+            <a:picLocks noChangeAspect="1"/>
+          </p:cNvPicPr>
+          <p:nvPr/>
+        </p:nvPicPr>
+        <p:blipFill>
+          <a:blip r:embed="rId1"/>
+          <a:stretch>
+            <a:fillRect/>
+          </a:stretch>
+        </p:blipFill>
+        <p:spPr>
+          <a:xfrm>
+            <a:off x="6144768" y="228600"/>
+            <a:ext cx="868680" cy="868680"/>
+          </a:xfrm>
+          <a:prstGeom prst="rect">
+            <a:avLst/>
+          </a:prstGeom>
+        </p:spPr>
+      </p:pic>
+      <p:sp>
+        <p:nvSpPr>
+          <p:cNvPr id="5" name="Text 1"/>
+          <p:cNvSpPr txBox="1"/>
+          <p:nvPr/>
+        </p:nvSpPr>
+        <p:spPr>
+          <a:xfrm>
+            <a:off x="3767328" y="274320"/>
+            <a:ext cx="2286000" cy="777240"/>
+          </a:xfrm>
+          <a:prstGeom prst="rect">
+            <a:avLst/>
+          </a:prstGeom>
+          <a:noFill/>
+          <a:ln/>
+        </p:spPr>
+        <p:txBody>
+          <a:bodyPr wrap="square" lIns="0" tIns="0" rIns="0" bIns="0" rtlCol="0" anchor="ctr"/>
+          <a:lstStyle/>
+          <a:p>
+            <a:pPr algn="r" indent="0" marL="0">
+              <a:lnSpc>
+                <a:spcPct val="120000"/>
+              </a:lnSpc>
+              <a:buNone/>
+            </a:pPr>
+            <a:r>
+              <a:rPr lang="en-US" sz="1000" dirty="0">
+                <a:solidFill>
+                  <a:srgbClr val="4A5F7A"/>
+                </a:solidFill>
+                <a:latin typeface="Poppins" pitchFamily="34" charset="0"/>
+                <a:ea typeface="Poppins" pitchFamily="34" charset="-122"/>
+                <a:cs typeface="Poppins" pitchFamily="34" charset="-120"/>
+              </a:rPr>
+              <a:t>Mehr Material:</a:t>
+            </a:r>
+            <a:endParaRPr lang="en-US" sz="1000" dirty="0"/>
+          </a:p>
+          <a:p>
+            <a:pPr algn="r" indent="0" marL="0">
+              <a:lnSpc>
+                <a:spcPct val="120000"/>
+              </a:lnSpc>
+              <a:buNone/>
+            </a:pPr>
+            <a:r>
+              <a:rPr lang="en-US" sz="1000" dirty="0">
+                <a:solidFill>
+                  <a:srgbClr val="4A5F7A"/>
+                </a:solidFill>
+                <a:latin typeface="Poppins" pitchFamily="34" charset="0"/>
+                <a:ea typeface="Poppins" pitchFamily="34" charset="-122"/>
+                <a:cs typeface="Poppins" pitchFamily="34" charset="-120"/>
+              </a:rPr>
+              <a:t>www.cleverbox.co.at</a:t>
+            </a:r>
+            <a:endParaRPr lang="en-US" sz="1000" dirty="0"/>
+          </a:p>
+        </p:txBody>
+      </p:sp>
+      <p:sp>
+        <p:nvSpPr>
+          <p:cNvPr id="6" name="Shape 2"/>
+          <p:cNvSpPr/>
+          <p:nvPr/>
+        </p:nvSpPr>
+        <p:spPr>
+          <a:xfrm>
+            <a:off x="548640" y="1188720"/>
+            <a:ext cx="6464808" cy="0"/>
+          </a:xfrm>
+          <a:prstGeom prst="line">
+            <a:avLst/>
+          </a:prstGeom>
+          <a:noFill/>
+          <a:ln w="15875">
+            <a:solidFill>
+              <a:srgbClr val="8DBBF2"/>
+            </a:solidFill>
+            <a:prstDash val="solid"/>
+          </a:ln>
+        </p:spPr>
+      </p:sp>
+      <p:sp>
+        <p:nvSpPr>
+          <p:cNvPr id="7" name="Text 3"/>
+          <p:cNvSpPr txBox="1"/>
+          <p:nvPr/>
+        </p:nvSpPr>
+        <p:spPr>
+          <a:xfrm>
+            <a:off x="548640" y="1371600"/>
             <a:ext cx="5486400" cy="365760"/>
           </a:xfrm>
           <a:prstGeom prst="rect">
@@ -1481,13 +1643,13 @@
       </p:sp>
       <p:sp>
         <p:nvSpPr>
-          <p:cNvPr id="4" name="Text 1"/>
-          <p:cNvSpPr txBox="1"/>
-          <p:nvPr/>
-        </p:nvSpPr>
-        <p:spPr>
-          <a:xfrm>
-            <a:off x="548640" y="868680"/>
+          <p:cNvPr id="8" name="Text 4"/>
+          <p:cNvSpPr txBox="1"/>
+          <p:nvPr/>
+        </p:nvSpPr>
+        <p:spPr>
+          <a:xfrm>
+            <a:off x="548640" y="1737360"/>
             <a:ext cx="6464808" cy="731520"/>
           </a:xfrm>
           <a:prstGeom prst="rect">
@@ -1543,13 +1705,13 @@
       </p:sp>
       <p:sp>
         <p:nvSpPr>
-          <p:cNvPr id="5" name="Text 2"/>
-          <p:cNvSpPr txBox="1"/>
-          <p:nvPr/>
-        </p:nvSpPr>
-        <p:spPr>
-          <a:xfrm>
-            <a:off x="548640" y="1783080"/>
+          <p:cNvPr id="9" name="Text 5"/>
+          <p:cNvSpPr txBox="1"/>
+          <p:nvPr/>
+        </p:nvSpPr>
+        <p:spPr>
+          <a:xfrm>
+            <a:off x="548640" y="2651760"/>
             <a:ext cx="822960" cy="365760"/>
           </a:xfrm>
           <a:prstGeom prst="rect">
@@ -1582,13 +1744,13 @@
       </p:sp>
       <p:sp>
         <p:nvSpPr>
-          <p:cNvPr id="6" name="Shape 3"/>
-          <p:cNvSpPr/>
-          <p:nvPr/>
-        </p:nvSpPr>
-        <p:spPr>
-          <a:xfrm>
-            <a:off x="1371600" y="2103120"/>
+          <p:cNvPr id="10" name="Shape 6"/>
+          <p:cNvSpPr/>
+          <p:nvPr/>
+        </p:nvSpPr>
+        <p:spPr>
+          <a:xfrm>
+            <a:off x="1371600" y="2971800"/>
             <a:ext cx="2743200" cy="0"/>
           </a:xfrm>
           <a:prstGeom prst="line">
@@ -1605,13 +1767,13 @@
       </p:sp>
       <p:sp>
         <p:nvSpPr>
-          <p:cNvPr id="7" name="Text 4"/>
-          <p:cNvSpPr txBox="1"/>
-          <p:nvPr/>
-        </p:nvSpPr>
-        <p:spPr>
-          <a:xfrm>
-            <a:off x="4389120" y="1783080"/>
+          <p:cNvPr id="11" name="Text 7"/>
+          <p:cNvSpPr txBox="1"/>
+          <p:nvPr/>
+        </p:nvSpPr>
+        <p:spPr>
+          <a:xfrm>
+            <a:off x="4389120" y="2651760"/>
             <a:ext cx="914400" cy="365760"/>
           </a:xfrm>
           <a:prstGeom prst="rect">
@@ -1644,13 +1806,13 @@
       </p:sp>
       <p:sp>
         <p:nvSpPr>
-          <p:cNvPr id="8" name="Shape 5"/>
-          <p:cNvSpPr/>
-          <p:nvPr/>
-        </p:nvSpPr>
-        <p:spPr>
-          <a:xfrm>
-            <a:off x="5303520" y="2103120"/>
+          <p:cNvPr id="12" name="Shape 8"/>
+          <p:cNvSpPr/>
+          <p:nvPr/>
+        </p:nvSpPr>
+        <p:spPr>
+          <a:xfrm>
+            <a:off x="5303520" y="2971800"/>
             <a:ext cx="1709928" cy="0"/>
           </a:xfrm>
           <a:prstGeom prst="line">
@@ -1667,13 +1829,13 @@
       </p:sp>
       <p:sp>
         <p:nvSpPr>
-          <p:cNvPr id="9" name="Text 6"/>
-          <p:cNvSpPr txBox="1"/>
-          <p:nvPr/>
-        </p:nvSpPr>
-        <p:spPr>
-          <a:xfrm>
-            <a:off x="548640" y="2286000"/>
+          <p:cNvPr id="13" name="Text 9"/>
+          <p:cNvSpPr txBox="1"/>
+          <p:nvPr/>
+        </p:nvSpPr>
+        <p:spPr>
+          <a:xfrm>
+            <a:off x="548640" y="3154680"/>
             <a:ext cx="6464808" cy="365760"/>
           </a:xfrm>
           <a:prstGeom prst="rect">
@@ -1706,13 +1868,13 @@
       </p:sp>
       <p:sp>
         <p:nvSpPr>
-          <p:cNvPr id="10" name="Shape 7"/>
-          <p:cNvSpPr/>
-          <p:nvPr/>
-        </p:nvSpPr>
-        <p:spPr>
-          <a:xfrm>
-            <a:off x="548640" y="2834640"/>
+          <p:cNvPr id="14" name="Shape 10"/>
+          <p:cNvSpPr/>
+          <p:nvPr/>
+        </p:nvSpPr>
+        <p:spPr>
+          <a:xfrm>
+            <a:off x="548640" y="3703320"/>
             <a:ext cx="6464808" cy="1956816"/>
           </a:xfrm>
           <a:prstGeom prst="roundRect">
@@ -1733,13 +1895,13 @@
       </p:sp>
       <p:sp>
         <p:nvSpPr>
-          <p:cNvPr id="11" name="Shape 8"/>
-          <p:cNvSpPr/>
-          <p:nvPr/>
-        </p:nvSpPr>
-        <p:spPr>
-          <a:xfrm>
-            <a:off x="749808" y="3035808"/>
+          <p:cNvPr id="15" name="Shape 11"/>
+          <p:cNvSpPr/>
+          <p:nvPr/>
+        </p:nvSpPr>
+        <p:spPr>
+          <a:xfrm>
+            <a:off x="749808" y="3904488"/>
             <a:ext cx="457200" cy="457200"/>
           </a:xfrm>
           <a:prstGeom prst="ellipse">
@@ -1758,13 +1920,13 @@
       </p:sp>
       <p:sp>
         <p:nvSpPr>
-          <p:cNvPr id="12" name="Text 9"/>
-          <p:cNvSpPr txBox="1"/>
-          <p:nvPr/>
-        </p:nvSpPr>
-        <p:spPr>
-          <a:xfrm>
-            <a:off x="749808" y="3035808"/>
+          <p:cNvPr id="16" name="Text 12"/>
+          <p:cNvSpPr txBox="1"/>
+          <p:nvPr/>
+        </p:nvSpPr>
+        <p:spPr>
+          <a:xfrm>
+            <a:off x="749808" y="3904488"/>
             <a:ext cx="457200" cy="457200"/>
           </a:xfrm>
           <a:prstGeom prst="rect">
@@ -1797,13 +1959,13 @@
       </p:sp>
       <p:sp>
         <p:nvSpPr>
-          <p:cNvPr id="13" name="Text 10"/>
-          <p:cNvSpPr txBox="1"/>
-          <p:nvPr/>
-        </p:nvSpPr>
-        <p:spPr>
-          <a:xfrm>
-            <a:off x="1417320" y="3017520"/>
+          <p:cNvPr id="17" name="Text 13"/>
+          <p:cNvSpPr txBox="1"/>
+          <p:nvPr/>
+        </p:nvSpPr>
+        <p:spPr>
+          <a:xfrm>
+            <a:off x="1417320" y="3886200"/>
             <a:ext cx="5367528" cy="585216"/>
           </a:xfrm>
           <a:prstGeom prst="rect">
@@ -1839,13 +2001,13 @@
       </p:sp>
       <p:sp>
         <p:nvSpPr>
-          <p:cNvPr id="14" name="Text 11"/>
-          <p:cNvSpPr txBox="1"/>
-          <p:nvPr/>
-        </p:nvSpPr>
-        <p:spPr>
-          <a:xfrm>
-            <a:off x="1417320" y="3739896"/>
+          <p:cNvPr id="18" name="Text 14"/>
+          <p:cNvSpPr txBox="1"/>
+          <p:nvPr/>
+        </p:nvSpPr>
+        <p:spPr>
+          <a:xfrm>
+            <a:off x="1417320" y="4608576"/>
             <a:ext cx="1188720" cy="365760"/>
           </a:xfrm>
           <a:prstGeom prst="rect">
@@ -1878,13 +2040,13 @@
       </p:sp>
       <p:sp>
         <p:nvSpPr>
-          <p:cNvPr id="15" name="Shape 12"/>
-          <p:cNvSpPr/>
-          <p:nvPr/>
-        </p:nvSpPr>
-        <p:spPr>
-          <a:xfrm>
-            <a:off x="2606040" y="4059936"/>
+          <p:cNvPr id="19" name="Shape 15"/>
+          <p:cNvSpPr/>
+          <p:nvPr/>
+        </p:nvSpPr>
+        <p:spPr>
+          <a:xfrm>
+            <a:off x="2606040" y="4928616"/>
             <a:ext cx="4178808" cy="0"/>
           </a:xfrm>
           <a:prstGeom prst="line">
@@ -1901,13 +2063,13 @@
       </p:sp>
       <p:sp>
         <p:nvSpPr>
-          <p:cNvPr id="16" name="Text 13"/>
-          <p:cNvSpPr txBox="1"/>
-          <p:nvPr/>
-        </p:nvSpPr>
-        <p:spPr>
-          <a:xfrm>
-            <a:off x="1417320" y="4197096"/>
+          <p:cNvPr id="20" name="Text 16"/>
+          <p:cNvSpPr txBox="1"/>
+          <p:nvPr/>
+        </p:nvSpPr>
+        <p:spPr>
+          <a:xfrm>
+            <a:off x="1417320" y="5065776"/>
             <a:ext cx="1188720" cy="365760"/>
           </a:xfrm>
           <a:prstGeom prst="rect">
@@ -1940,13 +2102,13 @@
       </p:sp>
       <p:sp>
         <p:nvSpPr>
-          <p:cNvPr id="17" name="Shape 14"/>
-          <p:cNvSpPr/>
-          <p:nvPr/>
-        </p:nvSpPr>
-        <p:spPr>
-          <a:xfrm>
-            <a:off x="2606040" y="4517136"/>
+          <p:cNvPr id="21" name="Shape 17"/>
+          <p:cNvSpPr/>
+          <p:nvPr/>
+        </p:nvSpPr>
+        <p:spPr>
+          <a:xfrm>
+            <a:off x="2606040" y="5385816"/>
             <a:ext cx="2743200" cy="0"/>
           </a:xfrm>
           <a:prstGeom prst="line">
@@ -1963,13 +2125,13 @@
       </p:sp>
       <p:sp>
         <p:nvSpPr>
-          <p:cNvPr id="18" name="Shape 15"/>
-          <p:cNvSpPr/>
-          <p:nvPr/>
-        </p:nvSpPr>
-        <p:spPr>
-          <a:xfrm>
-            <a:off x="548640" y="4928616"/>
+          <p:cNvPr id="22" name="Shape 18"/>
+          <p:cNvSpPr/>
+          <p:nvPr/>
+        </p:nvSpPr>
+        <p:spPr>
+          <a:xfrm>
+            <a:off x="548640" y="5797296"/>
             <a:ext cx="6464808" cy="1956816"/>
           </a:xfrm>
           <a:prstGeom prst="roundRect">
@@ -1990,13 +2152,13 @@
       </p:sp>
       <p:sp>
         <p:nvSpPr>
-          <p:cNvPr id="19" name="Shape 16"/>
-          <p:cNvSpPr/>
-          <p:nvPr/>
-        </p:nvSpPr>
-        <p:spPr>
-          <a:xfrm>
-            <a:off x="749808" y="5129784"/>
+          <p:cNvPr id="23" name="Shape 19"/>
+          <p:cNvSpPr/>
+          <p:nvPr/>
+        </p:nvSpPr>
+        <p:spPr>
+          <a:xfrm>
+            <a:off x="749808" y="5998464"/>
             <a:ext cx="457200" cy="457200"/>
           </a:xfrm>
           <a:prstGeom prst="ellipse">
@@ -2015,13 +2177,13 @@
       </p:sp>
       <p:sp>
         <p:nvSpPr>
-          <p:cNvPr id="20" name="Text 17"/>
-          <p:cNvSpPr txBox="1"/>
-          <p:nvPr/>
-        </p:nvSpPr>
-        <p:spPr>
-          <a:xfrm>
-            <a:off x="749808" y="5129784"/>
+          <p:cNvPr id="24" name="Text 20"/>
+          <p:cNvSpPr txBox="1"/>
+          <p:nvPr/>
+        </p:nvSpPr>
+        <p:spPr>
+          <a:xfrm>
+            <a:off x="749808" y="5998464"/>
             <a:ext cx="457200" cy="457200"/>
           </a:xfrm>
           <a:prstGeom prst="rect">
@@ -2054,13 +2216,13 @@
       </p:sp>
       <p:sp>
         <p:nvSpPr>
-          <p:cNvPr id="21" name="Text 18"/>
-          <p:cNvSpPr txBox="1"/>
-          <p:nvPr/>
-        </p:nvSpPr>
-        <p:spPr>
-          <a:xfrm>
-            <a:off x="1417320" y="5111496"/>
+          <p:cNvPr id="25" name="Text 21"/>
+          <p:cNvSpPr txBox="1"/>
+          <p:nvPr/>
+        </p:nvSpPr>
+        <p:spPr>
+          <a:xfrm>
+            <a:off x="1417320" y="5980176"/>
             <a:ext cx="5367528" cy="585216"/>
           </a:xfrm>
           <a:prstGeom prst="rect">
@@ -2096,13 +2258,13 @@
       </p:sp>
       <p:sp>
         <p:nvSpPr>
-          <p:cNvPr id="22" name="Text 19"/>
-          <p:cNvSpPr txBox="1"/>
-          <p:nvPr/>
-        </p:nvSpPr>
-        <p:spPr>
-          <a:xfrm>
-            <a:off x="1417320" y="5833872"/>
+          <p:cNvPr id="26" name="Text 22"/>
+          <p:cNvSpPr txBox="1"/>
+          <p:nvPr/>
+        </p:nvSpPr>
+        <p:spPr>
+          <a:xfrm>
+            <a:off x="1417320" y="6702552"/>
             <a:ext cx="1188720" cy="365760"/>
           </a:xfrm>
           <a:prstGeom prst="rect">
@@ -2135,13 +2297,13 @@
       </p:sp>
       <p:sp>
         <p:nvSpPr>
-          <p:cNvPr id="23" name="Shape 20"/>
-          <p:cNvSpPr/>
-          <p:nvPr/>
-        </p:nvSpPr>
-        <p:spPr>
-          <a:xfrm>
-            <a:off x="2606040" y="6153912"/>
+          <p:cNvPr id="27" name="Shape 23"/>
+          <p:cNvSpPr/>
+          <p:nvPr/>
+        </p:nvSpPr>
+        <p:spPr>
+          <a:xfrm>
+            <a:off x="2606040" y="7022592"/>
             <a:ext cx="4178808" cy="0"/>
           </a:xfrm>
           <a:prstGeom prst="line">
@@ -2158,13 +2320,13 @@
       </p:sp>
       <p:sp>
         <p:nvSpPr>
-          <p:cNvPr id="24" name="Text 21"/>
-          <p:cNvSpPr txBox="1"/>
-          <p:nvPr/>
-        </p:nvSpPr>
-        <p:spPr>
-          <a:xfrm>
-            <a:off x="1417320" y="6291072"/>
+          <p:cNvPr id="28" name="Text 24"/>
+          <p:cNvSpPr txBox="1"/>
+          <p:nvPr/>
+        </p:nvSpPr>
+        <p:spPr>
+          <a:xfrm>
+            <a:off x="1417320" y="7159752"/>
             <a:ext cx="1188720" cy="365760"/>
           </a:xfrm>
           <a:prstGeom prst="rect">
@@ -2197,13 +2359,13 @@
       </p:sp>
       <p:sp>
         <p:nvSpPr>
-          <p:cNvPr id="25" name="Shape 22"/>
-          <p:cNvSpPr/>
-          <p:nvPr/>
-        </p:nvSpPr>
-        <p:spPr>
-          <a:xfrm>
-            <a:off x="2606040" y="6611112"/>
+          <p:cNvPr id="29" name="Shape 25"/>
+          <p:cNvSpPr/>
+          <p:nvPr/>
+        </p:nvSpPr>
+        <p:spPr>
+          <a:xfrm>
+            <a:off x="2606040" y="7479792"/>
             <a:ext cx="2743200" cy="0"/>
           </a:xfrm>
           <a:prstGeom prst="line">
@@ -2220,13 +2382,13 @@
       </p:sp>
       <p:sp>
         <p:nvSpPr>
-          <p:cNvPr id="26" name="Shape 23"/>
-          <p:cNvSpPr/>
-          <p:nvPr/>
-        </p:nvSpPr>
-        <p:spPr>
-          <a:xfrm>
-            <a:off x="548640" y="7022592"/>
+          <p:cNvPr id="30" name="Shape 26"/>
+          <p:cNvSpPr/>
+          <p:nvPr/>
+        </p:nvSpPr>
+        <p:spPr>
+          <a:xfrm>
+            <a:off x="548640" y="7891272"/>
             <a:ext cx="6464808" cy="1956816"/>
           </a:xfrm>
           <a:prstGeom prst="roundRect">
@@ -2247,13 +2409,13 @@
       </p:sp>
       <p:sp>
         <p:nvSpPr>
-          <p:cNvPr id="27" name="Shape 24"/>
-          <p:cNvSpPr/>
-          <p:nvPr/>
-        </p:nvSpPr>
-        <p:spPr>
-          <a:xfrm>
-            <a:off x="749808" y="7223760"/>
+          <p:cNvPr id="31" name="Shape 27"/>
+          <p:cNvSpPr/>
+          <p:nvPr/>
+        </p:nvSpPr>
+        <p:spPr>
+          <a:xfrm>
+            <a:off x="749808" y="8092440"/>
             <a:ext cx="457200" cy="457200"/>
           </a:xfrm>
           <a:prstGeom prst="ellipse">
@@ -2272,13 +2434,13 @@
       </p:sp>
       <p:sp>
         <p:nvSpPr>
-          <p:cNvPr id="28" name="Text 25"/>
-          <p:cNvSpPr txBox="1"/>
-          <p:nvPr/>
-        </p:nvSpPr>
-        <p:spPr>
-          <a:xfrm>
-            <a:off x="749808" y="7223760"/>
+          <p:cNvPr id="32" name="Text 28"/>
+          <p:cNvSpPr txBox="1"/>
+          <p:nvPr/>
+        </p:nvSpPr>
+        <p:spPr>
+          <a:xfrm>
+            <a:off x="749808" y="8092440"/>
             <a:ext cx="457200" cy="457200"/>
           </a:xfrm>
           <a:prstGeom prst="rect">
@@ -2311,13 +2473,13 @@
       </p:sp>
       <p:sp>
         <p:nvSpPr>
-          <p:cNvPr id="29" name="Text 26"/>
-          <p:cNvSpPr txBox="1"/>
-          <p:nvPr/>
-        </p:nvSpPr>
-        <p:spPr>
-          <a:xfrm>
-            <a:off x="1417320" y="7205472"/>
+          <p:cNvPr id="33" name="Text 29"/>
+          <p:cNvSpPr txBox="1"/>
+          <p:nvPr/>
+        </p:nvSpPr>
+        <p:spPr>
+          <a:xfrm>
+            <a:off x="1417320" y="8074152"/>
             <a:ext cx="5367528" cy="585216"/>
           </a:xfrm>
           <a:prstGeom prst="rect">
@@ -2353,13 +2515,13 @@
       </p:sp>
       <p:sp>
         <p:nvSpPr>
-          <p:cNvPr id="30" name="Text 27"/>
-          <p:cNvSpPr txBox="1"/>
-          <p:nvPr/>
-        </p:nvSpPr>
-        <p:spPr>
-          <a:xfrm>
-            <a:off x="1417320" y="7927848"/>
+          <p:cNvPr id="34" name="Text 30"/>
+          <p:cNvSpPr txBox="1"/>
+          <p:nvPr/>
+        </p:nvSpPr>
+        <p:spPr>
+          <a:xfrm>
+            <a:off x="1417320" y="8796528"/>
             <a:ext cx="1188720" cy="365760"/>
           </a:xfrm>
           <a:prstGeom prst="rect">
@@ -2392,13 +2554,13 @@
       </p:sp>
       <p:sp>
         <p:nvSpPr>
-          <p:cNvPr id="31" name="Shape 28"/>
-          <p:cNvSpPr/>
-          <p:nvPr/>
-        </p:nvSpPr>
-        <p:spPr>
-          <a:xfrm>
-            <a:off x="2606040" y="8247888"/>
+          <p:cNvPr id="35" name="Shape 31"/>
+          <p:cNvSpPr/>
+          <p:nvPr/>
+        </p:nvSpPr>
+        <p:spPr>
+          <a:xfrm>
+            <a:off x="2606040" y="9116568"/>
             <a:ext cx="4178808" cy="0"/>
           </a:xfrm>
           <a:prstGeom prst="line">
@@ -2415,13 +2577,13 @@
       </p:sp>
       <p:sp>
         <p:nvSpPr>
-          <p:cNvPr id="32" name="Text 29"/>
-          <p:cNvSpPr txBox="1"/>
-          <p:nvPr/>
-        </p:nvSpPr>
-        <p:spPr>
-          <a:xfrm>
-            <a:off x="1417320" y="8385048"/>
+          <p:cNvPr id="36" name="Text 32"/>
+          <p:cNvSpPr txBox="1"/>
+          <p:nvPr/>
+        </p:nvSpPr>
+        <p:spPr>
+          <a:xfrm>
+            <a:off x="1417320" y="9253728"/>
             <a:ext cx="1188720" cy="365760"/>
           </a:xfrm>
           <a:prstGeom prst="rect">
@@ -2454,13 +2616,13 @@
       </p:sp>
       <p:sp>
         <p:nvSpPr>
-          <p:cNvPr id="33" name="Shape 30"/>
-          <p:cNvSpPr/>
-          <p:nvPr/>
-        </p:nvSpPr>
-        <p:spPr>
-          <a:xfrm>
-            <a:off x="2606040" y="8705088"/>
+          <p:cNvPr id="37" name="Shape 33"/>
+          <p:cNvSpPr/>
+          <p:nvPr/>
+        </p:nvSpPr>
+        <p:spPr>
+          <a:xfrm>
+            <a:off x="2606040" y="9573768"/>
             <a:ext cx="2743200" cy="0"/>
           </a:xfrm>
           <a:prstGeom prst="line">
@@ -2508,7 +2670,169 @@
         </p:nvSpPr>
         <p:spPr>
           <a:xfrm>
-            <a:off x="548640" y="502920"/>
+            <a:off x="548640" y="274320"/>
+            <a:ext cx="2926080" cy="731520"/>
+          </a:xfrm>
+          <a:prstGeom prst="rect">
+            <a:avLst/>
+          </a:prstGeom>
+          <a:noFill/>
+          <a:ln/>
+        </p:spPr>
+        <p:txBody>
+          <a:bodyPr wrap="square" lIns="0" tIns="0" rIns="0" bIns="0" rtlCol="0" anchor="ctr"/>
+          <a:lstStyle/>
+          <a:p>
+            <a:pPr indent="0" marL="0">
+              <a:buNone/>
+            </a:pPr>
+            <a:r>
+              <a:rPr lang="en-US" sz="3000" b="1" dirty="0">
+                <a:solidFill>
+                  <a:srgbClr val="475BA6"/>
+                </a:solidFill>
+                <a:latin typeface="Poppins" pitchFamily="34" charset="0"/>
+                <a:ea typeface="Poppins" pitchFamily="34" charset="-122"/>
+                <a:cs typeface="Poppins" pitchFamily="34" charset="-120"/>
+              </a:rPr>
+              <a:t>clever</a:t>
+            </a:r>
+            <a:pPr indent="0" marL="0">
+              <a:buNone/>
+            </a:pPr>
+            <a:r>
+              <a:rPr lang="en-US" sz="3000" b="1" dirty="0">
+                <a:solidFill>
+                  <a:srgbClr val="36448A"/>
+                </a:solidFill>
+                <a:latin typeface="Poppins" pitchFamily="34" charset="0"/>
+                <a:ea typeface="Poppins" pitchFamily="34" charset="-122"/>
+                <a:cs typeface="Poppins" pitchFamily="34" charset="-120"/>
+              </a:rPr>
+              <a:t>box</a:t>
+            </a:r>
+            <a:endParaRPr lang="en-US" sz="3000" dirty="0"/>
+          </a:p>
+        </p:txBody>
+      </p:sp>
+      <p:pic>
+        <p:nvPicPr>
+          <p:cNvPr id="4" name="Image 0" descr="QR-Code zu www.cleverbox.co.at">    </p:cNvPr>
+          <p:cNvPicPr>
+            <a:picLocks noChangeAspect="1"/>
+          </p:cNvPicPr>
+          <p:nvPr/>
+        </p:nvPicPr>
+        <p:blipFill>
+          <a:blip r:embed="rId1"/>
+          <a:stretch>
+            <a:fillRect/>
+          </a:stretch>
+        </p:blipFill>
+        <p:spPr>
+          <a:xfrm>
+            <a:off x="6144768" y="228600"/>
+            <a:ext cx="868680" cy="868680"/>
+          </a:xfrm>
+          <a:prstGeom prst="rect">
+            <a:avLst/>
+          </a:prstGeom>
+        </p:spPr>
+      </p:pic>
+      <p:sp>
+        <p:nvSpPr>
+          <p:cNvPr id="5" name="Text 1"/>
+          <p:cNvSpPr txBox="1"/>
+          <p:nvPr/>
+        </p:nvSpPr>
+        <p:spPr>
+          <a:xfrm>
+            <a:off x="3767328" y="274320"/>
+            <a:ext cx="2286000" cy="777240"/>
+          </a:xfrm>
+          <a:prstGeom prst="rect">
+            <a:avLst/>
+          </a:prstGeom>
+          <a:noFill/>
+          <a:ln/>
+        </p:spPr>
+        <p:txBody>
+          <a:bodyPr wrap="square" lIns="0" tIns="0" rIns="0" bIns="0" rtlCol="0" anchor="ctr"/>
+          <a:lstStyle/>
+          <a:p>
+            <a:pPr algn="r" indent="0" marL="0">
+              <a:lnSpc>
+                <a:spcPct val="120000"/>
+              </a:lnSpc>
+              <a:buNone/>
+            </a:pPr>
+            <a:r>
+              <a:rPr lang="en-US" sz="1000" dirty="0">
+                <a:solidFill>
+                  <a:srgbClr val="4A5F7A"/>
+                </a:solidFill>
+                <a:latin typeface="Poppins" pitchFamily="34" charset="0"/>
+                <a:ea typeface="Poppins" pitchFamily="34" charset="-122"/>
+                <a:cs typeface="Poppins" pitchFamily="34" charset="-120"/>
+              </a:rPr>
+              <a:t>Mehr Material:</a:t>
+            </a:r>
+            <a:endParaRPr lang="en-US" sz="1000" dirty="0"/>
+          </a:p>
+          <a:p>
+            <a:pPr algn="r" indent="0" marL="0">
+              <a:lnSpc>
+                <a:spcPct val="120000"/>
+              </a:lnSpc>
+              <a:buNone/>
+            </a:pPr>
+            <a:r>
+              <a:rPr lang="en-US" sz="1000" dirty="0">
+                <a:solidFill>
+                  <a:srgbClr val="4A5F7A"/>
+                </a:solidFill>
+                <a:latin typeface="Poppins" pitchFamily="34" charset="0"/>
+                <a:ea typeface="Poppins" pitchFamily="34" charset="-122"/>
+                <a:cs typeface="Poppins" pitchFamily="34" charset="-120"/>
+              </a:rPr>
+              <a:t>www.cleverbox.co.at</a:t>
+            </a:r>
+            <a:endParaRPr lang="en-US" sz="1000" dirty="0"/>
+          </a:p>
+        </p:txBody>
+      </p:sp>
+      <p:sp>
+        <p:nvSpPr>
+          <p:cNvPr id="6" name="Shape 2"/>
+          <p:cNvSpPr/>
+          <p:nvPr/>
+        </p:nvSpPr>
+        <p:spPr>
+          <a:xfrm>
+            <a:off x="548640" y="1188720"/>
+            <a:ext cx="6464808" cy="0"/>
+          </a:xfrm>
+          <a:prstGeom prst="line">
+            <a:avLst/>
+          </a:prstGeom>
+          <a:noFill/>
+          <a:ln w="15875">
+            <a:solidFill>
+              <a:srgbClr val="8DBBF2"/>
+            </a:solidFill>
+            <a:prstDash val="solid"/>
+          </a:ln>
+        </p:spPr>
+      </p:sp>
+      <p:sp>
+        <p:nvSpPr>
+          <p:cNvPr id="7" name="Text 3"/>
+          <p:cNvSpPr txBox="1"/>
+          <p:nvPr/>
+        </p:nvSpPr>
+        <p:spPr>
+          <a:xfrm>
+            <a:off x="548640" y="1371600"/>
             <a:ext cx="6400800" cy="365760"/>
           </a:xfrm>
           <a:prstGeom prst="rect">
@@ -2541,13 +2865,13 @@
       </p:sp>
       <p:sp>
         <p:nvSpPr>
-          <p:cNvPr id="4" name="Shape 1"/>
-          <p:cNvSpPr/>
-          <p:nvPr/>
-        </p:nvSpPr>
-        <p:spPr>
-          <a:xfrm>
-            <a:off x="548640" y="1097280"/>
+          <p:cNvPr id="8" name="Shape 4"/>
+          <p:cNvSpPr/>
+          <p:nvPr/>
+        </p:nvSpPr>
+        <p:spPr>
+          <a:xfrm>
+            <a:off x="548640" y="1965960"/>
             <a:ext cx="6464808" cy="1709928"/>
           </a:xfrm>
           <a:prstGeom prst="roundRect">
@@ -2568,13 +2892,13 @@
       </p:sp>
       <p:sp>
         <p:nvSpPr>
-          <p:cNvPr id="5" name="Shape 2"/>
-          <p:cNvSpPr/>
-          <p:nvPr/>
-        </p:nvSpPr>
-        <p:spPr>
-          <a:xfrm>
-            <a:off x="749808" y="1298448"/>
+          <p:cNvPr id="9" name="Shape 5"/>
+          <p:cNvSpPr/>
+          <p:nvPr/>
+        </p:nvSpPr>
+        <p:spPr>
+          <a:xfrm>
+            <a:off x="749808" y="2167128"/>
             <a:ext cx="457200" cy="457200"/>
           </a:xfrm>
           <a:prstGeom prst="ellipse">
@@ -2593,13 +2917,13 @@
       </p:sp>
       <p:sp>
         <p:nvSpPr>
-          <p:cNvPr id="6" name="Text 3"/>
-          <p:cNvSpPr txBox="1"/>
-          <p:nvPr/>
-        </p:nvSpPr>
-        <p:spPr>
-          <a:xfrm>
-            <a:off x="749808" y="1298448"/>
+          <p:cNvPr id="10" name="Text 6"/>
+          <p:cNvSpPr txBox="1"/>
+          <p:nvPr/>
+        </p:nvSpPr>
+        <p:spPr>
+          <a:xfrm>
+            <a:off x="749808" y="2167128"/>
             <a:ext cx="457200" cy="457200"/>
           </a:xfrm>
           <a:prstGeom prst="rect">
@@ -2632,13 +2956,13 @@
       </p:sp>
       <p:sp>
         <p:nvSpPr>
-          <p:cNvPr id="7" name="Text 4"/>
-          <p:cNvSpPr txBox="1"/>
-          <p:nvPr/>
-        </p:nvSpPr>
-        <p:spPr>
-          <a:xfrm>
-            <a:off x="1417320" y="1280160"/>
+          <p:cNvPr id="11" name="Text 7"/>
+          <p:cNvSpPr txBox="1"/>
+          <p:nvPr/>
+        </p:nvSpPr>
+        <p:spPr>
+          <a:xfrm>
+            <a:off x="1417320" y="2148840"/>
             <a:ext cx="5367528" cy="338328"/>
           </a:xfrm>
           <a:prstGeom prst="rect">
@@ -2674,13 +2998,13 @@
       </p:sp>
       <p:sp>
         <p:nvSpPr>
-          <p:cNvPr id="8" name="Text 5"/>
-          <p:cNvSpPr txBox="1"/>
-          <p:nvPr/>
-        </p:nvSpPr>
-        <p:spPr>
-          <a:xfrm>
-            <a:off x="1417320" y="1755648"/>
+          <p:cNvPr id="12" name="Text 8"/>
+          <p:cNvSpPr txBox="1"/>
+          <p:nvPr/>
+        </p:nvSpPr>
+        <p:spPr>
+          <a:xfrm>
+            <a:off x="1417320" y="2624328"/>
             <a:ext cx="1188720" cy="365760"/>
           </a:xfrm>
           <a:prstGeom prst="rect">
@@ -2713,13 +3037,13 @@
       </p:sp>
       <p:sp>
         <p:nvSpPr>
-          <p:cNvPr id="9" name="Shape 6"/>
-          <p:cNvSpPr/>
-          <p:nvPr/>
-        </p:nvSpPr>
-        <p:spPr>
-          <a:xfrm>
-            <a:off x="2606040" y="2075688"/>
+          <p:cNvPr id="13" name="Shape 9"/>
+          <p:cNvSpPr/>
+          <p:nvPr/>
+        </p:nvSpPr>
+        <p:spPr>
+          <a:xfrm>
+            <a:off x="2606040" y="2944368"/>
             <a:ext cx="4178808" cy="0"/>
           </a:xfrm>
           <a:prstGeom prst="line">
@@ -2736,13 +3060,13 @@
       </p:sp>
       <p:sp>
         <p:nvSpPr>
-          <p:cNvPr id="10" name="Text 7"/>
-          <p:cNvSpPr txBox="1"/>
-          <p:nvPr/>
-        </p:nvSpPr>
-        <p:spPr>
-          <a:xfrm>
-            <a:off x="1417320" y="2212848"/>
+          <p:cNvPr id="14" name="Text 10"/>
+          <p:cNvSpPr txBox="1"/>
+          <p:nvPr/>
+        </p:nvSpPr>
+        <p:spPr>
+          <a:xfrm>
+            <a:off x="1417320" y="3081528"/>
             <a:ext cx="1188720" cy="365760"/>
           </a:xfrm>
           <a:prstGeom prst="rect">
@@ -2775,13 +3099,13 @@
       </p:sp>
       <p:sp>
         <p:nvSpPr>
-          <p:cNvPr id="11" name="Shape 8"/>
-          <p:cNvSpPr/>
-          <p:nvPr/>
-        </p:nvSpPr>
-        <p:spPr>
-          <a:xfrm>
-            <a:off x="2606040" y="2532888"/>
+          <p:cNvPr id="15" name="Shape 11"/>
+          <p:cNvSpPr/>
+          <p:nvPr/>
+        </p:nvSpPr>
+        <p:spPr>
+          <a:xfrm>
+            <a:off x="2606040" y="3401568"/>
             <a:ext cx="2743200" cy="0"/>
           </a:xfrm>
           <a:prstGeom prst="line">
@@ -2798,13 +3122,13 @@
       </p:sp>
       <p:sp>
         <p:nvSpPr>
-          <p:cNvPr id="12" name="Shape 9"/>
-          <p:cNvSpPr/>
-          <p:nvPr/>
-        </p:nvSpPr>
-        <p:spPr>
-          <a:xfrm>
-            <a:off x="548640" y="2944368"/>
+          <p:cNvPr id="16" name="Shape 12"/>
+          <p:cNvSpPr/>
+          <p:nvPr/>
+        </p:nvSpPr>
+        <p:spPr>
+          <a:xfrm>
+            <a:off x="548640" y="3813048"/>
             <a:ext cx="6464808" cy="1709928"/>
           </a:xfrm>
           <a:prstGeom prst="roundRect">
@@ -2825,13 +3149,13 @@
       </p:sp>
       <p:sp>
         <p:nvSpPr>
-          <p:cNvPr id="13" name="Shape 10"/>
-          <p:cNvSpPr/>
-          <p:nvPr/>
-        </p:nvSpPr>
-        <p:spPr>
-          <a:xfrm>
-            <a:off x="749808" y="3145536"/>
+          <p:cNvPr id="17" name="Shape 13"/>
+          <p:cNvSpPr/>
+          <p:nvPr/>
+        </p:nvSpPr>
+        <p:spPr>
+          <a:xfrm>
+            <a:off x="749808" y="4014216"/>
             <a:ext cx="457200" cy="457200"/>
           </a:xfrm>
           <a:prstGeom prst="ellipse">
@@ -2850,13 +3174,13 @@
       </p:sp>
       <p:sp>
         <p:nvSpPr>
-          <p:cNvPr id="14" name="Text 11"/>
-          <p:cNvSpPr txBox="1"/>
-          <p:nvPr/>
-        </p:nvSpPr>
-        <p:spPr>
-          <a:xfrm>
-            <a:off x="749808" y="3145536"/>
+          <p:cNvPr id="18" name="Text 14"/>
+          <p:cNvSpPr txBox="1"/>
+          <p:nvPr/>
+        </p:nvSpPr>
+        <p:spPr>
+          <a:xfrm>
+            <a:off x="749808" y="4014216"/>
             <a:ext cx="457200" cy="457200"/>
           </a:xfrm>
           <a:prstGeom prst="rect">
@@ -2889,13 +3213,13 @@
       </p:sp>
       <p:sp>
         <p:nvSpPr>
-          <p:cNvPr id="15" name="Text 12"/>
-          <p:cNvSpPr txBox="1"/>
-          <p:nvPr/>
-        </p:nvSpPr>
-        <p:spPr>
-          <a:xfrm>
-            <a:off x="1417320" y="3127248"/>
+          <p:cNvPr id="19" name="Text 15"/>
+          <p:cNvSpPr txBox="1"/>
+          <p:nvPr/>
+        </p:nvSpPr>
+        <p:spPr>
+          <a:xfrm>
+            <a:off x="1417320" y="3995928"/>
             <a:ext cx="5367528" cy="338328"/>
           </a:xfrm>
           <a:prstGeom prst="rect">
@@ -2931,13 +3255,13 @@
       </p:sp>
       <p:sp>
         <p:nvSpPr>
-          <p:cNvPr id="16" name="Text 13"/>
-          <p:cNvSpPr txBox="1"/>
-          <p:nvPr/>
-        </p:nvSpPr>
-        <p:spPr>
-          <a:xfrm>
-            <a:off x="1417320" y="3602736"/>
+          <p:cNvPr id="20" name="Text 16"/>
+          <p:cNvSpPr txBox="1"/>
+          <p:nvPr/>
+        </p:nvSpPr>
+        <p:spPr>
+          <a:xfrm>
+            <a:off x="1417320" y="4471416"/>
             <a:ext cx="1188720" cy="365760"/>
           </a:xfrm>
           <a:prstGeom prst="rect">
@@ -2970,13 +3294,13 @@
       </p:sp>
       <p:sp>
         <p:nvSpPr>
-          <p:cNvPr id="17" name="Shape 14"/>
-          <p:cNvSpPr/>
-          <p:nvPr/>
-        </p:nvSpPr>
-        <p:spPr>
-          <a:xfrm>
-            <a:off x="2606040" y="3922776"/>
+          <p:cNvPr id="21" name="Shape 17"/>
+          <p:cNvSpPr/>
+          <p:nvPr/>
+        </p:nvSpPr>
+        <p:spPr>
+          <a:xfrm>
+            <a:off x="2606040" y="4791456"/>
             <a:ext cx="4178808" cy="0"/>
           </a:xfrm>
           <a:prstGeom prst="line">
@@ -2993,13 +3317,13 @@
       </p:sp>
       <p:sp>
         <p:nvSpPr>
-          <p:cNvPr id="18" name="Text 15"/>
-          <p:cNvSpPr txBox="1"/>
-          <p:nvPr/>
-        </p:nvSpPr>
-        <p:spPr>
-          <a:xfrm>
-            <a:off x="1417320" y="4059936"/>
+          <p:cNvPr id="22" name="Text 18"/>
+          <p:cNvSpPr txBox="1"/>
+          <p:nvPr/>
+        </p:nvSpPr>
+        <p:spPr>
+          <a:xfrm>
+            <a:off x="1417320" y="4928616"/>
             <a:ext cx="1188720" cy="365760"/>
           </a:xfrm>
           <a:prstGeom prst="rect">
@@ -3032,13 +3356,13 @@
       </p:sp>
       <p:sp>
         <p:nvSpPr>
-          <p:cNvPr id="19" name="Shape 16"/>
-          <p:cNvSpPr/>
-          <p:nvPr/>
-        </p:nvSpPr>
-        <p:spPr>
-          <a:xfrm>
-            <a:off x="2606040" y="4379976"/>
+          <p:cNvPr id="23" name="Shape 19"/>
+          <p:cNvSpPr/>
+          <p:nvPr/>
+        </p:nvSpPr>
+        <p:spPr>
+          <a:xfrm>
+            <a:off x="2606040" y="5248656"/>
             <a:ext cx="2743200" cy="0"/>
           </a:xfrm>
           <a:prstGeom prst="line">
@@ -3055,13 +3379,13 @@
       </p:sp>
       <p:sp>
         <p:nvSpPr>
-          <p:cNvPr id="20" name="Shape 17"/>
-          <p:cNvSpPr/>
-          <p:nvPr/>
-        </p:nvSpPr>
-        <p:spPr>
-          <a:xfrm>
-            <a:off x="548640" y="4791456"/>
+          <p:cNvPr id="24" name="Shape 20"/>
+          <p:cNvSpPr/>
+          <p:nvPr/>
+        </p:nvSpPr>
+        <p:spPr>
+          <a:xfrm>
+            <a:off x="548640" y="5660136"/>
             <a:ext cx="6464808" cy="1956816"/>
           </a:xfrm>
           <a:prstGeom prst="roundRect">
@@ -3082,13 +3406,13 @@
       </p:sp>
       <p:sp>
         <p:nvSpPr>
-          <p:cNvPr id="21" name="Shape 18"/>
-          <p:cNvSpPr/>
-          <p:nvPr/>
-        </p:nvSpPr>
-        <p:spPr>
-          <a:xfrm>
-            <a:off x="749808" y="4992624"/>
+          <p:cNvPr id="25" name="Shape 21"/>
+          <p:cNvSpPr/>
+          <p:nvPr/>
+        </p:nvSpPr>
+        <p:spPr>
+          <a:xfrm>
+            <a:off x="749808" y="5861304"/>
             <a:ext cx="457200" cy="457200"/>
           </a:xfrm>
           <a:prstGeom prst="ellipse">
@@ -3107,13 +3431,13 @@
       </p:sp>
       <p:sp>
         <p:nvSpPr>
-          <p:cNvPr id="22" name="Text 19"/>
-          <p:cNvSpPr txBox="1"/>
-          <p:nvPr/>
-        </p:nvSpPr>
-        <p:spPr>
-          <a:xfrm>
-            <a:off x="749808" y="4992624"/>
+          <p:cNvPr id="26" name="Text 22"/>
+          <p:cNvSpPr txBox="1"/>
+          <p:nvPr/>
+        </p:nvSpPr>
+        <p:spPr>
+          <a:xfrm>
+            <a:off x="749808" y="5861304"/>
             <a:ext cx="457200" cy="457200"/>
           </a:xfrm>
           <a:prstGeom prst="rect">
@@ -3146,13 +3470,13 @@
       </p:sp>
       <p:sp>
         <p:nvSpPr>
-          <p:cNvPr id="23" name="Text 20"/>
-          <p:cNvSpPr txBox="1"/>
-          <p:nvPr/>
-        </p:nvSpPr>
-        <p:spPr>
-          <a:xfrm>
-            <a:off x="1417320" y="4974336"/>
+          <p:cNvPr id="27" name="Text 23"/>
+          <p:cNvSpPr txBox="1"/>
+          <p:nvPr/>
+        </p:nvSpPr>
+        <p:spPr>
+          <a:xfrm>
+            <a:off x="1417320" y="5843016"/>
             <a:ext cx="5367528" cy="585216"/>
           </a:xfrm>
           <a:prstGeom prst="rect">
@@ -3188,13 +3512,13 @@
       </p:sp>
       <p:sp>
         <p:nvSpPr>
-          <p:cNvPr id="24" name="Text 21"/>
-          <p:cNvSpPr txBox="1"/>
-          <p:nvPr/>
-        </p:nvSpPr>
-        <p:spPr>
-          <a:xfrm>
-            <a:off x="1417320" y="5696712"/>
+          <p:cNvPr id="28" name="Text 24"/>
+          <p:cNvSpPr txBox="1"/>
+          <p:nvPr/>
+        </p:nvSpPr>
+        <p:spPr>
+          <a:xfrm>
+            <a:off x="1417320" y="6565392"/>
             <a:ext cx="1188720" cy="365760"/>
           </a:xfrm>
           <a:prstGeom prst="rect">
@@ -3227,13 +3551,13 @@
       </p:sp>
       <p:sp>
         <p:nvSpPr>
-          <p:cNvPr id="25" name="Shape 22"/>
-          <p:cNvSpPr/>
-          <p:nvPr/>
-        </p:nvSpPr>
-        <p:spPr>
-          <a:xfrm>
-            <a:off x="2606040" y="6016752"/>
+          <p:cNvPr id="29" name="Shape 25"/>
+          <p:cNvSpPr/>
+          <p:nvPr/>
+        </p:nvSpPr>
+        <p:spPr>
+          <a:xfrm>
+            <a:off x="2606040" y="6885432"/>
             <a:ext cx="4178808" cy="0"/>
           </a:xfrm>
           <a:prstGeom prst="line">
@@ -3250,13 +3574,13 @@
       </p:sp>
       <p:sp>
         <p:nvSpPr>
-          <p:cNvPr id="26" name="Text 23"/>
-          <p:cNvSpPr txBox="1"/>
-          <p:nvPr/>
-        </p:nvSpPr>
-        <p:spPr>
-          <a:xfrm>
-            <a:off x="1417320" y="6153912"/>
+          <p:cNvPr id="30" name="Text 26"/>
+          <p:cNvSpPr txBox="1"/>
+          <p:nvPr/>
+        </p:nvSpPr>
+        <p:spPr>
+          <a:xfrm>
+            <a:off x="1417320" y="7022592"/>
             <a:ext cx="1188720" cy="365760"/>
           </a:xfrm>
           <a:prstGeom prst="rect">
@@ -3289,13 +3613,13 @@
       </p:sp>
       <p:sp>
         <p:nvSpPr>
-          <p:cNvPr id="27" name="Shape 24"/>
-          <p:cNvSpPr/>
-          <p:nvPr/>
-        </p:nvSpPr>
-        <p:spPr>
-          <a:xfrm>
-            <a:off x="2606040" y="6473952"/>
+          <p:cNvPr id="31" name="Shape 27"/>
+          <p:cNvSpPr/>
+          <p:nvPr/>
+        </p:nvSpPr>
+        <p:spPr>
+          <a:xfrm>
+            <a:off x="2606040" y="7342632"/>
             <a:ext cx="2743200" cy="0"/>
           </a:xfrm>
           <a:prstGeom prst="line">
@@ -3312,13 +3636,13 @@
       </p:sp>
       <p:sp>
         <p:nvSpPr>
-          <p:cNvPr id="28" name="Shape 25"/>
-          <p:cNvSpPr/>
-          <p:nvPr/>
-        </p:nvSpPr>
-        <p:spPr>
-          <a:xfrm>
-            <a:off x="548640" y="6885432"/>
+          <p:cNvPr id="32" name="Shape 28"/>
+          <p:cNvSpPr/>
+          <p:nvPr/>
+        </p:nvSpPr>
+        <p:spPr>
+          <a:xfrm>
+            <a:off x="548640" y="7754112"/>
             <a:ext cx="6464808" cy="1956816"/>
           </a:xfrm>
           <a:prstGeom prst="roundRect">
@@ -3339,13 +3663,13 @@
       </p:sp>
       <p:sp>
         <p:nvSpPr>
-          <p:cNvPr id="29" name="Shape 26"/>
-          <p:cNvSpPr/>
-          <p:nvPr/>
-        </p:nvSpPr>
-        <p:spPr>
-          <a:xfrm>
-            <a:off x="749808" y="7086600"/>
+          <p:cNvPr id="33" name="Shape 29"/>
+          <p:cNvSpPr/>
+          <p:nvPr/>
+        </p:nvSpPr>
+        <p:spPr>
+          <a:xfrm>
+            <a:off x="749808" y="7955280"/>
             <a:ext cx="457200" cy="457200"/>
           </a:xfrm>
           <a:prstGeom prst="ellipse">
@@ -3364,13 +3688,13 @@
       </p:sp>
       <p:sp>
         <p:nvSpPr>
-          <p:cNvPr id="30" name="Text 27"/>
-          <p:cNvSpPr txBox="1"/>
-          <p:nvPr/>
-        </p:nvSpPr>
-        <p:spPr>
-          <a:xfrm>
-            <a:off x="749808" y="7086600"/>
+          <p:cNvPr id="34" name="Text 30"/>
+          <p:cNvSpPr txBox="1"/>
+          <p:nvPr/>
+        </p:nvSpPr>
+        <p:spPr>
+          <a:xfrm>
+            <a:off x="749808" y="7955280"/>
             <a:ext cx="457200" cy="457200"/>
           </a:xfrm>
           <a:prstGeom prst="rect">
@@ -3403,13 +3727,13 @@
       </p:sp>
       <p:sp>
         <p:nvSpPr>
-          <p:cNvPr id="31" name="Text 28"/>
-          <p:cNvSpPr txBox="1"/>
-          <p:nvPr/>
-        </p:nvSpPr>
-        <p:spPr>
-          <a:xfrm>
-            <a:off x="1417320" y="7068312"/>
+          <p:cNvPr id="35" name="Text 31"/>
+          <p:cNvSpPr txBox="1"/>
+          <p:nvPr/>
+        </p:nvSpPr>
+        <p:spPr>
+          <a:xfrm>
+            <a:off x="1417320" y="7936992"/>
             <a:ext cx="5367528" cy="585216"/>
           </a:xfrm>
           <a:prstGeom prst="rect">
@@ -3445,13 +3769,13 @@
       </p:sp>
       <p:sp>
         <p:nvSpPr>
-          <p:cNvPr id="32" name="Text 29"/>
-          <p:cNvSpPr txBox="1"/>
-          <p:nvPr/>
-        </p:nvSpPr>
-        <p:spPr>
-          <a:xfrm>
-            <a:off x="1417320" y="7790688"/>
+          <p:cNvPr id="36" name="Text 32"/>
+          <p:cNvSpPr txBox="1"/>
+          <p:nvPr/>
+        </p:nvSpPr>
+        <p:spPr>
+          <a:xfrm>
+            <a:off x="1417320" y="8659368"/>
             <a:ext cx="1188720" cy="365760"/>
           </a:xfrm>
           <a:prstGeom prst="rect">
@@ -3484,13 +3808,13 @@
       </p:sp>
       <p:sp>
         <p:nvSpPr>
-          <p:cNvPr id="33" name="Shape 30"/>
-          <p:cNvSpPr/>
-          <p:nvPr/>
-        </p:nvSpPr>
-        <p:spPr>
-          <a:xfrm>
-            <a:off x="2606040" y="8110728"/>
+          <p:cNvPr id="37" name="Shape 33"/>
+          <p:cNvSpPr/>
+          <p:nvPr/>
+        </p:nvSpPr>
+        <p:spPr>
+          <a:xfrm>
+            <a:off x="2606040" y="8979408"/>
             <a:ext cx="4178808" cy="0"/>
           </a:xfrm>
           <a:prstGeom prst="line">
@@ -3507,13 +3831,13 @@
       </p:sp>
       <p:sp>
         <p:nvSpPr>
-          <p:cNvPr id="34" name="Text 31"/>
-          <p:cNvSpPr txBox="1"/>
-          <p:nvPr/>
-        </p:nvSpPr>
-        <p:spPr>
-          <a:xfrm>
-            <a:off x="1417320" y="8247888"/>
+          <p:cNvPr id="38" name="Text 34"/>
+          <p:cNvSpPr txBox="1"/>
+          <p:nvPr/>
+        </p:nvSpPr>
+        <p:spPr>
+          <a:xfrm>
+            <a:off x="1417320" y="9116568"/>
             <a:ext cx="1188720" cy="365760"/>
           </a:xfrm>
           <a:prstGeom prst="rect">
@@ -3546,13 +3870,13 @@
       </p:sp>
       <p:sp>
         <p:nvSpPr>
-          <p:cNvPr id="35" name="Shape 32"/>
-          <p:cNvSpPr/>
-          <p:nvPr/>
-        </p:nvSpPr>
-        <p:spPr>
-          <a:xfrm>
-            <a:off x="2606040" y="8567928"/>
+          <p:cNvPr id="39" name="Shape 35"/>
+          <p:cNvSpPr/>
+          <p:nvPr/>
+        </p:nvSpPr>
+        <p:spPr>
+          <a:xfrm>
+            <a:off x="2606040" y="9436608"/>
             <a:ext cx="2743200" cy="0"/>
           </a:xfrm>
           <a:prstGeom prst="line">
@@ -3600,7 +3924,169 @@
         </p:nvSpPr>
         <p:spPr>
           <a:xfrm>
-            <a:off x="548640" y="502920"/>
+            <a:off x="548640" y="274320"/>
+            <a:ext cx="2926080" cy="731520"/>
+          </a:xfrm>
+          <a:prstGeom prst="rect">
+            <a:avLst/>
+          </a:prstGeom>
+          <a:noFill/>
+          <a:ln/>
+        </p:spPr>
+        <p:txBody>
+          <a:bodyPr wrap="square" lIns="0" tIns="0" rIns="0" bIns="0" rtlCol="0" anchor="ctr"/>
+          <a:lstStyle/>
+          <a:p>
+            <a:pPr indent="0" marL="0">
+              <a:buNone/>
+            </a:pPr>
+            <a:r>
+              <a:rPr lang="en-US" sz="3000" b="1" dirty="0">
+                <a:solidFill>
+                  <a:srgbClr val="475BA6"/>
+                </a:solidFill>
+                <a:latin typeface="Poppins" pitchFamily="34" charset="0"/>
+                <a:ea typeface="Poppins" pitchFamily="34" charset="-122"/>
+                <a:cs typeface="Poppins" pitchFamily="34" charset="-120"/>
+              </a:rPr>
+              <a:t>clever</a:t>
+            </a:r>
+            <a:pPr indent="0" marL="0">
+              <a:buNone/>
+            </a:pPr>
+            <a:r>
+              <a:rPr lang="en-US" sz="3000" b="1" dirty="0">
+                <a:solidFill>
+                  <a:srgbClr val="36448A"/>
+                </a:solidFill>
+                <a:latin typeface="Poppins" pitchFamily="34" charset="0"/>
+                <a:ea typeface="Poppins" pitchFamily="34" charset="-122"/>
+                <a:cs typeface="Poppins" pitchFamily="34" charset="-120"/>
+              </a:rPr>
+              <a:t>box</a:t>
+            </a:r>
+            <a:endParaRPr lang="en-US" sz="3000" dirty="0"/>
+          </a:p>
+        </p:txBody>
+      </p:sp>
+      <p:pic>
+        <p:nvPicPr>
+          <p:cNvPr id="4" name="Image 0" descr="QR-Code zu www.cleverbox.co.at">    </p:cNvPr>
+          <p:cNvPicPr>
+            <a:picLocks noChangeAspect="1"/>
+          </p:cNvPicPr>
+          <p:nvPr/>
+        </p:nvPicPr>
+        <p:blipFill>
+          <a:blip r:embed="rId1"/>
+          <a:stretch>
+            <a:fillRect/>
+          </a:stretch>
+        </p:blipFill>
+        <p:spPr>
+          <a:xfrm>
+            <a:off x="6144768" y="228600"/>
+            <a:ext cx="868680" cy="868680"/>
+          </a:xfrm>
+          <a:prstGeom prst="rect">
+            <a:avLst/>
+          </a:prstGeom>
+        </p:spPr>
+      </p:pic>
+      <p:sp>
+        <p:nvSpPr>
+          <p:cNvPr id="5" name="Text 1"/>
+          <p:cNvSpPr txBox="1"/>
+          <p:nvPr/>
+        </p:nvSpPr>
+        <p:spPr>
+          <a:xfrm>
+            <a:off x="3767328" y="274320"/>
+            <a:ext cx="2286000" cy="777240"/>
+          </a:xfrm>
+          <a:prstGeom prst="rect">
+            <a:avLst/>
+          </a:prstGeom>
+          <a:noFill/>
+          <a:ln/>
+        </p:spPr>
+        <p:txBody>
+          <a:bodyPr wrap="square" lIns="0" tIns="0" rIns="0" bIns="0" rtlCol="0" anchor="ctr"/>
+          <a:lstStyle/>
+          <a:p>
+            <a:pPr algn="r" indent="0" marL="0">
+              <a:lnSpc>
+                <a:spcPct val="120000"/>
+              </a:lnSpc>
+              <a:buNone/>
+            </a:pPr>
+            <a:r>
+              <a:rPr lang="en-US" sz="1000" dirty="0">
+                <a:solidFill>
+                  <a:srgbClr val="4A5F7A"/>
+                </a:solidFill>
+                <a:latin typeface="Poppins" pitchFamily="34" charset="0"/>
+                <a:ea typeface="Poppins" pitchFamily="34" charset="-122"/>
+                <a:cs typeface="Poppins" pitchFamily="34" charset="-120"/>
+              </a:rPr>
+              <a:t>Mehr Material:</a:t>
+            </a:r>
+            <a:endParaRPr lang="en-US" sz="1000" dirty="0"/>
+          </a:p>
+          <a:p>
+            <a:pPr algn="r" indent="0" marL="0">
+              <a:lnSpc>
+                <a:spcPct val="120000"/>
+              </a:lnSpc>
+              <a:buNone/>
+            </a:pPr>
+            <a:r>
+              <a:rPr lang="en-US" sz="1000" dirty="0">
+                <a:solidFill>
+                  <a:srgbClr val="4A5F7A"/>
+                </a:solidFill>
+                <a:latin typeface="Poppins" pitchFamily="34" charset="0"/>
+                <a:ea typeface="Poppins" pitchFamily="34" charset="-122"/>
+                <a:cs typeface="Poppins" pitchFamily="34" charset="-120"/>
+              </a:rPr>
+              <a:t>www.cleverbox.co.at</a:t>
+            </a:r>
+            <a:endParaRPr lang="en-US" sz="1000" dirty="0"/>
+          </a:p>
+        </p:txBody>
+      </p:sp>
+      <p:sp>
+        <p:nvSpPr>
+          <p:cNvPr id="6" name="Shape 2"/>
+          <p:cNvSpPr/>
+          <p:nvPr/>
+        </p:nvSpPr>
+        <p:spPr>
+          <a:xfrm>
+            <a:off x="548640" y="1188720"/>
+            <a:ext cx="6464808" cy="0"/>
+          </a:xfrm>
+          <a:prstGeom prst="line">
+            <a:avLst/>
+          </a:prstGeom>
+          <a:noFill/>
+          <a:ln w="15875">
+            <a:solidFill>
+              <a:srgbClr val="8DBBF2"/>
+            </a:solidFill>
+            <a:prstDash val="solid"/>
+          </a:ln>
+        </p:spPr>
+      </p:sp>
+      <p:sp>
+        <p:nvSpPr>
+          <p:cNvPr id="7" name="Text 3"/>
+          <p:cNvSpPr txBox="1"/>
+          <p:nvPr/>
+        </p:nvSpPr>
+        <p:spPr>
+          <a:xfrm>
+            <a:off x="548640" y="1371600"/>
             <a:ext cx="6400800" cy="365760"/>
           </a:xfrm>
           <a:prstGeom prst="rect">
@@ -3633,13 +4119,13 @@
       </p:sp>
       <p:sp>
         <p:nvSpPr>
-          <p:cNvPr id="4" name="Shape 1"/>
-          <p:cNvSpPr/>
-          <p:nvPr/>
-        </p:nvSpPr>
-        <p:spPr>
-          <a:xfrm>
-            <a:off x="548640" y="1097280"/>
+          <p:cNvPr id="8" name="Shape 4"/>
+          <p:cNvSpPr/>
+          <p:nvPr/>
+        </p:nvSpPr>
+        <p:spPr>
+          <a:xfrm>
+            <a:off x="548640" y="1965960"/>
             <a:ext cx="6464808" cy="1956816"/>
           </a:xfrm>
           <a:prstGeom prst="roundRect">
@@ -3660,13 +4146,13 @@
       </p:sp>
       <p:sp>
         <p:nvSpPr>
-          <p:cNvPr id="5" name="Shape 2"/>
-          <p:cNvSpPr/>
-          <p:nvPr/>
-        </p:nvSpPr>
-        <p:spPr>
-          <a:xfrm>
-            <a:off x="749808" y="1298448"/>
+          <p:cNvPr id="9" name="Shape 5"/>
+          <p:cNvSpPr/>
+          <p:nvPr/>
+        </p:nvSpPr>
+        <p:spPr>
+          <a:xfrm>
+            <a:off x="749808" y="2167128"/>
             <a:ext cx="457200" cy="457200"/>
           </a:xfrm>
           <a:prstGeom prst="ellipse">
@@ -3685,13 +4171,13 @@
       </p:sp>
       <p:sp>
         <p:nvSpPr>
-          <p:cNvPr id="6" name="Text 3"/>
-          <p:cNvSpPr txBox="1"/>
-          <p:nvPr/>
-        </p:nvSpPr>
-        <p:spPr>
-          <a:xfrm>
-            <a:off x="749808" y="1298448"/>
+          <p:cNvPr id="10" name="Text 6"/>
+          <p:cNvSpPr txBox="1"/>
+          <p:nvPr/>
+        </p:nvSpPr>
+        <p:spPr>
+          <a:xfrm>
+            <a:off x="749808" y="2167128"/>
             <a:ext cx="457200" cy="457200"/>
           </a:xfrm>
           <a:prstGeom prst="rect">
@@ -3724,13 +4210,13 @@
       </p:sp>
       <p:sp>
         <p:nvSpPr>
-          <p:cNvPr id="7" name="Text 4"/>
-          <p:cNvSpPr txBox="1"/>
-          <p:nvPr/>
-        </p:nvSpPr>
-        <p:spPr>
-          <a:xfrm>
-            <a:off x="1417320" y="1280160"/>
+          <p:cNvPr id="11" name="Text 7"/>
+          <p:cNvSpPr txBox="1"/>
+          <p:nvPr/>
+        </p:nvSpPr>
+        <p:spPr>
+          <a:xfrm>
+            <a:off x="1417320" y="2148840"/>
             <a:ext cx="5367528" cy="585216"/>
           </a:xfrm>
           <a:prstGeom prst="rect">
@@ -3766,13 +4252,13 @@
       </p:sp>
       <p:sp>
         <p:nvSpPr>
-          <p:cNvPr id="8" name="Text 5"/>
-          <p:cNvSpPr txBox="1"/>
-          <p:nvPr/>
-        </p:nvSpPr>
-        <p:spPr>
-          <a:xfrm>
-            <a:off x="1417320" y="2002536"/>
+          <p:cNvPr id="12" name="Text 8"/>
+          <p:cNvSpPr txBox="1"/>
+          <p:nvPr/>
+        </p:nvSpPr>
+        <p:spPr>
+          <a:xfrm>
+            <a:off x="1417320" y="2871216"/>
             <a:ext cx="1188720" cy="365760"/>
           </a:xfrm>
           <a:prstGeom prst="rect">
@@ -3805,13 +4291,13 @@
       </p:sp>
       <p:sp>
         <p:nvSpPr>
-          <p:cNvPr id="9" name="Shape 6"/>
-          <p:cNvSpPr/>
-          <p:nvPr/>
-        </p:nvSpPr>
-        <p:spPr>
-          <a:xfrm>
-            <a:off x="2606040" y="2322576"/>
+          <p:cNvPr id="13" name="Shape 9"/>
+          <p:cNvSpPr/>
+          <p:nvPr/>
+        </p:nvSpPr>
+        <p:spPr>
+          <a:xfrm>
+            <a:off x="2606040" y="3191256"/>
             <a:ext cx="4178808" cy="0"/>
           </a:xfrm>
           <a:prstGeom prst="line">
@@ -3828,13 +4314,13 @@
       </p:sp>
       <p:sp>
         <p:nvSpPr>
-          <p:cNvPr id="10" name="Text 7"/>
-          <p:cNvSpPr txBox="1"/>
-          <p:nvPr/>
-        </p:nvSpPr>
-        <p:spPr>
-          <a:xfrm>
-            <a:off x="1417320" y="2459736"/>
+          <p:cNvPr id="14" name="Text 10"/>
+          <p:cNvSpPr txBox="1"/>
+          <p:nvPr/>
+        </p:nvSpPr>
+        <p:spPr>
+          <a:xfrm>
+            <a:off x="1417320" y="3328416"/>
             <a:ext cx="1188720" cy="365760"/>
           </a:xfrm>
           <a:prstGeom prst="rect">
@@ -3867,13 +4353,13 @@
       </p:sp>
       <p:sp>
         <p:nvSpPr>
-          <p:cNvPr id="11" name="Shape 8"/>
-          <p:cNvSpPr/>
-          <p:nvPr/>
-        </p:nvSpPr>
-        <p:spPr>
-          <a:xfrm>
-            <a:off x="2606040" y="2779776"/>
+          <p:cNvPr id="15" name="Shape 11"/>
+          <p:cNvSpPr/>
+          <p:nvPr/>
+        </p:nvSpPr>
+        <p:spPr>
+          <a:xfrm>
+            <a:off x="2606040" y="3648456"/>
             <a:ext cx="2743200" cy="0"/>
           </a:xfrm>
           <a:prstGeom prst="line">
@@ -3890,13 +4376,13 @@
       </p:sp>
       <p:sp>
         <p:nvSpPr>
-          <p:cNvPr id="12" name="Shape 9"/>
-          <p:cNvSpPr/>
-          <p:nvPr/>
-        </p:nvSpPr>
-        <p:spPr>
-          <a:xfrm>
-            <a:off x="548640" y="3191256"/>
+          <p:cNvPr id="16" name="Shape 12"/>
+          <p:cNvSpPr/>
+          <p:nvPr/>
+        </p:nvSpPr>
+        <p:spPr>
+          <a:xfrm>
+            <a:off x="548640" y="4059936"/>
             <a:ext cx="6464808" cy="1956816"/>
           </a:xfrm>
           <a:prstGeom prst="roundRect">
@@ -3917,13 +4403,13 @@
       </p:sp>
       <p:sp>
         <p:nvSpPr>
-          <p:cNvPr id="13" name="Shape 10"/>
-          <p:cNvSpPr/>
-          <p:nvPr/>
-        </p:nvSpPr>
-        <p:spPr>
-          <a:xfrm>
-            <a:off x="749808" y="3392424"/>
+          <p:cNvPr id="17" name="Shape 13"/>
+          <p:cNvSpPr/>
+          <p:nvPr/>
+        </p:nvSpPr>
+        <p:spPr>
+          <a:xfrm>
+            <a:off x="749808" y="4261104"/>
             <a:ext cx="457200" cy="457200"/>
           </a:xfrm>
           <a:prstGeom prst="ellipse">
@@ -3942,13 +4428,13 @@
       </p:sp>
       <p:sp>
         <p:nvSpPr>
-          <p:cNvPr id="14" name="Text 11"/>
-          <p:cNvSpPr txBox="1"/>
-          <p:nvPr/>
-        </p:nvSpPr>
-        <p:spPr>
-          <a:xfrm>
-            <a:off x="749808" y="3392424"/>
+          <p:cNvPr id="18" name="Text 14"/>
+          <p:cNvSpPr txBox="1"/>
+          <p:nvPr/>
+        </p:nvSpPr>
+        <p:spPr>
+          <a:xfrm>
+            <a:off x="749808" y="4261104"/>
             <a:ext cx="457200" cy="457200"/>
           </a:xfrm>
           <a:prstGeom prst="rect">
@@ -3981,13 +4467,13 @@
       </p:sp>
       <p:sp>
         <p:nvSpPr>
-          <p:cNvPr id="15" name="Text 12"/>
-          <p:cNvSpPr txBox="1"/>
-          <p:nvPr/>
-        </p:nvSpPr>
-        <p:spPr>
-          <a:xfrm>
-            <a:off x="1417320" y="3374136"/>
+          <p:cNvPr id="19" name="Text 15"/>
+          <p:cNvSpPr txBox="1"/>
+          <p:nvPr/>
+        </p:nvSpPr>
+        <p:spPr>
+          <a:xfrm>
+            <a:off x="1417320" y="4242816"/>
             <a:ext cx="5367528" cy="585216"/>
           </a:xfrm>
           <a:prstGeom prst="rect">
@@ -4023,13 +4509,13 @@
       </p:sp>
       <p:sp>
         <p:nvSpPr>
-          <p:cNvPr id="16" name="Text 13"/>
-          <p:cNvSpPr txBox="1"/>
-          <p:nvPr/>
-        </p:nvSpPr>
-        <p:spPr>
-          <a:xfrm>
-            <a:off x="1417320" y="4096512"/>
+          <p:cNvPr id="20" name="Text 16"/>
+          <p:cNvSpPr txBox="1"/>
+          <p:nvPr/>
+        </p:nvSpPr>
+        <p:spPr>
+          <a:xfrm>
+            <a:off x="1417320" y="4965192"/>
             <a:ext cx="1188720" cy="365760"/>
           </a:xfrm>
           <a:prstGeom prst="rect">
@@ -4062,13 +4548,13 @@
       </p:sp>
       <p:sp>
         <p:nvSpPr>
-          <p:cNvPr id="17" name="Shape 14"/>
-          <p:cNvSpPr/>
-          <p:nvPr/>
-        </p:nvSpPr>
-        <p:spPr>
-          <a:xfrm>
-            <a:off x="2606040" y="4416552"/>
+          <p:cNvPr id="21" name="Shape 17"/>
+          <p:cNvSpPr/>
+          <p:nvPr/>
+        </p:nvSpPr>
+        <p:spPr>
+          <a:xfrm>
+            <a:off x="2606040" y="5285232"/>
             <a:ext cx="4178808" cy="0"/>
           </a:xfrm>
           <a:prstGeom prst="line">
@@ -4085,13 +4571,13 @@
       </p:sp>
       <p:sp>
         <p:nvSpPr>
-          <p:cNvPr id="18" name="Text 15"/>
-          <p:cNvSpPr txBox="1"/>
-          <p:nvPr/>
-        </p:nvSpPr>
-        <p:spPr>
-          <a:xfrm>
-            <a:off x="1417320" y="4553712"/>
+          <p:cNvPr id="22" name="Text 18"/>
+          <p:cNvSpPr txBox="1"/>
+          <p:nvPr/>
+        </p:nvSpPr>
+        <p:spPr>
+          <a:xfrm>
+            <a:off x="1417320" y="5422392"/>
             <a:ext cx="1188720" cy="365760"/>
           </a:xfrm>
           <a:prstGeom prst="rect">
@@ -4124,13 +4610,13 @@
       </p:sp>
       <p:sp>
         <p:nvSpPr>
-          <p:cNvPr id="19" name="Shape 16"/>
-          <p:cNvSpPr/>
-          <p:nvPr/>
-        </p:nvSpPr>
-        <p:spPr>
-          <a:xfrm>
-            <a:off x="2606040" y="4873752"/>
+          <p:cNvPr id="23" name="Shape 19"/>
+          <p:cNvSpPr/>
+          <p:nvPr/>
+        </p:nvSpPr>
+        <p:spPr>
+          <a:xfrm>
+            <a:off x="2606040" y="5742432"/>
             <a:ext cx="2743200" cy="0"/>
           </a:xfrm>
           <a:prstGeom prst="line">
@@ -4147,13 +4633,13 @@
       </p:sp>
       <p:sp>
         <p:nvSpPr>
-          <p:cNvPr id="20" name="Shape 17"/>
-          <p:cNvSpPr/>
-          <p:nvPr/>
-        </p:nvSpPr>
-        <p:spPr>
-          <a:xfrm>
-            <a:off x="548640" y="5285232"/>
+          <p:cNvPr id="24" name="Shape 20"/>
+          <p:cNvSpPr/>
+          <p:nvPr/>
+        </p:nvSpPr>
+        <p:spPr>
+          <a:xfrm>
+            <a:off x="548640" y="6153912"/>
             <a:ext cx="6464808" cy="1956816"/>
           </a:xfrm>
           <a:prstGeom prst="roundRect">
@@ -4174,13 +4660,13 @@
       </p:sp>
       <p:sp>
         <p:nvSpPr>
-          <p:cNvPr id="21" name="Shape 18"/>
-          <p:cNvSpPr/>
-          <p:nvPr/>
-        </p:nvSpPr>
-        <p:spPr>
-          <a:xfrm>
-            <a:off x="749808" y="5486400"/>
+          <p:cNvPr id="25" name="Shape 21"/>
+          <p:cNvSpPr/>
+          <p:nvPr/>
+        </p:nvSpPr>
+        <p:spPr>
+          <a:xfrm>
+            <a:off x="749808" y="6355080"/>
             <a:ext cx="457200" cy="457200"/>
           </a:xfrm>
           <a:prstGeom prst="ellipse">
@@ -4199,13 +4685,13 @@
       </p:sp>
       <p:sp>
         <p:nvSpPr>
-          <p:cNvPr id="22" name="Text 19"/>
-          <p:cNvSpPr txBox="1"/>
-          <p:nvPr/>
-        </p:nvSpPr>
-        <p:spPr>
-          <a:xfrm>
-            <a:off x="749808" y="5486400"/>
+          <p:cNvPr id="26" name="Text 22"/>
+          <p:cNvSpPr txBox="1"/>
+          <p:nvPr/>
+        </p:nvSpPr>
+        <p:spPr>
+          <a:xfrm>
+            <a:off x="749808" y="6355080"/>
             <a:ext cx="457200" cy="457200"/>
           </a:xfrm>
           <a:prstGeom prst="rect">
@@ -4238,13 +4724,13 @@
       </p:sp>
       <p:sp>
         <p:nvSpPr>
-          <p:cNvPr id="23" name="Text 20"/>
-          <p:cNvSpPr txBox="1"/>
-          <p:nvPr/>
-        </p:nvSpPr>
-        <p:spPr>
-          <a:xfrm>
-            <a:off x="1417320" y="5468112"/>
+          <p:cNvPr id="27" name="Text 23"/>
+          <p:cNvSpPr txBox="1"/>
+          <p:nvPr/>
+        </p:nvSpPr>
+        <p:spPr>
+          <a:xfrm>
+            <a:off x="1417320" y="6336792"/>
             <a:ext cx="5367528" cy="585216"/>
           </a:xfrm>
           <a:prstGeom prst="rect">
@@ -4280,13 +4766,13 @@
       </p:sp>
       <p:sp>
         <p:nvSpPr>
-          <p:cNvPr id="24" name="Text 21"/>
-          <p:cNvSpPr txBox="1"/>
-          <p:nvPr/>
-        </p:nvSpPr>
-        <p:spPr>
-          <a:xfrm>
-            <a:off x="1417320" y="6190488"/>
+          <p:cNvPr id="28" name="Text 24"/>
+          <p:cNvSpPr txBox="1"/>
+          <p:nvPr/>
+        </p:nvSpPr>
+        <p:spPr>
+          <a:xfrm>
+            <a:off x="1417320" y="7059168"/>
             <a:ext cx="1188720" cy="365760"/>
           </a:xfrm>
           <a:prstGeom prst="rect">
@@ -4319,13 +4805,13 @@
       </p:sp>
       <p:sp>
         <p:nvSpPr>
-          <p:cNvPr id="25" name="Shape 22"/>
-          <p:cNvSpPr/>
-          <p:nvPr/>
-        </p:nvSpPr>
-        <p:spPr>
-          <a:xfrm>
-            <a:off x="2606040" y="6510528"/>
+          <p:cNvPr id="29" name="Shape 25"/>
+          <p:cNvSpPr/>
+          <p:nvPr/>
+        </p:nvSpPr>
+        <p:spPr>
+          <a:xfrm>
+            <a:off x="2606040" y="7379208"/>
             <a:ext cx="4178808" cy="0"/>
           </a:xfrm>
           <a:prstGeom prst="line">
@@ -4342,13 +4828,13 @@
       </p:sp>
       <p:sp>
         <p:nvSpPr>
-          <p:cNvPr id="26" name="Text 23"/>
-          <p:cNvSpPr txBox="1"/>
-          <p:nvPr/>
-        </p:nvSpPr>
-        <p:spPr>
-          <a:xfrm>
-            <a:off x="1417320" y="6647688"/>
+          <p:cNvPr id="30" name="Text 26"/>
+          <p:cNvSpPr txBox="1"/>
+          <p:nvPr/>
+        </p:nvSpPr>
+        <p:spPr>
+          <a:xfrm>
+            <a:off x="1417320" y="7516368"/>
             <a:ext cx="1188720" cy="365760"/>
           </a:xfrm>
           <a:prstGeom prst="rect">
@@ -4381,270 +4867,13 @@
       </p:sp>
       <p:sp>
         <p:nvSpPr>
-          <p:cNvPr id="27" name="Shape 24"/>
-          <p:cNvSpPr/>
-          <p:nvPr/>
-        </p:nvSpPr>
-        <p:spPr>
-          <a:xfrm>
-            <a:off x="2606040" y="6967728"/>
-            <a:ext cx="2743200" cy="0"/>
-          </a:xfrm>
-          <a:prstGeom prst="line">
-            <a:avLst/>
-          </a:prstGeom>
-          <a:noFill/>
-          <a:ln w="15875">
-            <a:solidFill>
-              <a:srgbClr val="8DBBF2"/>
-            </a:solidFill>
-            <a:prstDash val="sysDot"/>
-          </a:ln>
-        </p:spPr>
-      </p:sp>
-      <p:sp>
-        <p:nvSpPr>
-          <p:cNvPr id="28" name="Shape 25"/>
-          <p:cNvSpPr/>
-          <p:nvPr/>
-        </p:nvSpPr>
-        <p:spPr>
-          <a:xfrm>
-            <a:off x="548640" y="7379208"/>
-            <a:ext cx="6464808" cy="1956816"/>
-          </a:xfrm>
-          <a:prstGeom prst="roundRect">
-            <a:avLst>
-              <a:gd name="adj" fmla="val 7009"/>
-            </a:avLst>
-          </a:prstGeom>
-          <a:solidFill>
-            <a:srgbClr val="FFFFFF"/>
-          </a:solidFill>
-          <a:ln w="15875">
-            <a:solidFill>
-              <a:srgbClr val="8DBBF2"/>
-            </a:solidFill>
-            <a:prstDash val="solid"/>
-          </a:ln>
-        </p:spPr>
-      </p:sp>
-      <p:sp>
-        <p:nvSpPr>
-          <p:cNvPr id="29" name="Shape 26"/>
-          <p:cNvSpPr/>
-          <p:nvPr/>
-        </p:nvSpPr>
-        <p:spPr>
-          <a:xfrm>
-            <a:off x="749808" y="7580376"/>
-            <a:ext cx="457200" cy="457200"/>
-          </a:xfrm>
-          <a:prstGeom prst="ellipse">
-            <a:avLst/>
-          </a:prstGeom>
-          <a:solidFill>
-            <a:srgbClr val="BCD6F5"/>
-          </a:solidFill>
-          <a:ln w="12700">
-            <a:solidFill>
-              <a:srgbClr val="BCD6F5"/>
-            </a:solidFill>
-            <a:prstDash val="solid"/>
-          </a:ln>
-        </p:spPr>
-      </p:sp>
-      <p:sp>
-        <p:nvSpPr>
-          <p:cNvPr id="30" name="Text 27"/>
-          <p:cNvSpPr txBox="1"/>
-          <p:nvPr/>
-        </p:nvSpPr>
-        <p:spPr>
-          <a:xfrm>
-            <a:off x="749808" y="7580376"/>
-            <a:ext cx="457200" cy="457200"/>
-          </a:xfrm>
-          <a:prstGeom prst="rect">
-            <a:avLst/>
-          </a:prstGeom>
-          <a:noFill/>
-          <a:ln/>
-        </p:spPr>
-        <p:txBody>
-          <a:bodyPr wrap="square" lIns="0" tIns="0" rIns="0" bIns="0" rtlCol="0" anchor="ctr"/>
-          <a:lstStyle/>
-          <a:p>
-            <a:pPr algn="ctr" indent="0" marL="0">
-              <a:buNone/>
-            </a:pPr>
-            <a:r>
-              <a:rPr lang="en-US" sz="1600" b="1" dirty="0">
-                <a:solidFill>
-                  <a:srgbClr val="0B1E3A"/>
-                </a:solidFill>
-                <a:latin typeface="Poppins" pitchFamily="34" charset="0"/>
-                <a:ea typeface="Poppins" pitchFamily="34" charset="-122"/>
-                <a:cs typeface="Poppins" pitchFamily="34" charset="-120"/>
-              </a:rPr>
-              <a:t>11</a:t>
-            </a:r>
-            <a:endParaRPr lang="en-US" sz="1600" dirty="0"/>
-          </a:p>
-        </p:txBody>
-      </p:sp>
-      <p:sp>
-        <p:nvSpPr>
-          <p:cNvPr id="31" name="Text 28"/>
-          <p:cNvSpPr txBox="1"/>
-          <p:nvPr/>
-        </p:nvSpPr>
-        <p:spPr>
-          <a:xfrm>
-            <a:off x="1417320" y="7562088"/>
-            <a:ext cx="5367528" cy="585216"/>
-          </a:xfrm>
-          <a:prstGeom prst="rect">
-            <a:avLst/>
-          </a:prstGeom>
-          <a:noFill/>
-          <a:ln/>
-        </p:spPr>
-        <p:txBody>
-          <a:bodyPr wrap="square" lIns="0" tIns="0" rIns="0" bIns="0" rtlCol="0" anchor="t"/>
-          <a:lstStyle/>
-          <a:p>
-            <a:pPr indent="0" marL="0">
-              <a:lnSpc>
-                <a:spcPct val="120000"/>
-              </a:lnSpc>
-              <a:buNone/>
-            </a:pPr>
-            <a:r>
-              <a:rPr lang="en-US" sz="1250" dirty="0">
-                <a:solidFill>
-                  <a:srgbClr val="0B1E3A"/>
-                </a:solidFill>
-                <a:latin typeface="Poppins" pitchFamily="34" charset="0"/>
-                <a:ea typeface="Poppins" pitchFamily="34" charset="-122"/>
-                <a:cs typeface="Poppins" pitchFamily="34" charset="-120"/>
-              </a:rPr>
-              <a:t>Verena ist um 8 Jahre älter als ihr Bruder Roman. Beide zusammen sind 32 Jahre alt. Wie alt ist Roman?</a:t>
-            </a:r>
-            <a:endParaRPr lang="en-US" sz="1250" dirty="0"/>
-          </a:p>
-        </p:txBody>
-      </p:sp>
-      <p:sp>
-        <p:nvSpPr>
-          <p:cNvPr id="32" name="Text 29"/>
-          <p:cNvSpPr txBox="1"/>
-          <p:nvPr/>
-        </p:nvSpPr>
-        <p:spPr>
-          <a:xfrm>
-            <a:off x="1417320" y="8284464"/>
-            <a:ext cx="1188720" cy="365760"/>
-          </a:xfrm>
-          <a:prstGeom prst="rect">
-            <a:avLst/>
-          </a:prstGeom>
-          <a:noFill/>
-          <a:ln/>
-        </p:spPr>
-        <p:txBody>
-          <a:bodyPr wrap="square" lIns="0" tIns="0" rIns="0" bIns="0" rtlCol="0" anchor="ctr"/>
-          <a:lstStyle/>
-          <a:p>
-            <a:pPr indent="0" marL="0">
-              <a:buNone/>
-            </a:pPr>
-            <a:r>
-              <a:rPr lang="en-US" sz="1000" dirty="0">
-                <a:solidFill>
-                  <a:srgbClr val="4A5F7A"/>
-                </a:solidFill>
-                <a:latin typeface="Poppins" pitchFamily="34" charset="0"/>
-                <a:ea typeface="Poppins" pitchFamily="34" charset="-122"/>
-                <a:cs typeface="Poppins" pitchFamily="34" charset="-120"/>
-              </a:rPr>
-              <a:t>Gleichung:</a:t>
-            </a:r>
-            <a:endParaRPr lang="en-US" sz="1000" dirty="0"/>
-          </a:p>
-        </p:txBody>
-      </p:sp>
-      <p:sp>
-        <p:nvSpPr>
-          <p:cNvPr id="33" name="Shape 30"/>
-          <p:cNvSpPr/>
-          <p:nvPr/>
-        </p:nvSpPr>
-        <p:spPr>
-          <a:xfrm>
-            <a:off x="2606040" y="8604504"/>
-            <a:ext cx="4178808" cy="0"/>
-          </a:xfrm>
-          <a:prstGeom prst="line">
-            <a:avLst/>
-          </a:prstGeom>
-          <a:noFill/>
-          <a:ln w="15875">
-            <a:solidFill>
-              <a:srgbClr val="8DBBF2"/>
-            </a:solidFill>
-            <a:prstDash val="sysDot"/>
-          </a:ln>
-        </p:spPr>
-      </p:sp>
-      <p:sp>
-        <p:nvSpPr>
-          <p:cNvPr id="34" name="Text 31"/>
-          <p:cNvSpPr txBox="1"/>
-          <p:nvPr/>
-        </p:nvSpPr>
-        <p:spPr>
-          <a:xfrm>
-            <a:off x="1417320" y="8741664"/>
-            <a:ext cx="1188720" cy="365760"/>
-          </a:xfrm>
-          <a:prstGeom prst="rect">
-            <a:avLst/>
-          </a:prstGeom>
-          <a:noFill/>
-          <a:ln/>
-        </p:spPr>
-        <p:txBody>
-          <a:bodyPr wrap="square" lIns="0" tIns="0" rIns="0" bIns="0" rtlCol="0" anchor="ctr"/>
-          <a:lstStyle/>
-          <a:p>
-            <a:pPr indent="0" marL="0">
-              <a:buNone/>
-            </a:pPr>
-            <a:r>
-              <a:rPr lang="en-US" sz="1000" dirty="0">
-                <a:solidFill>
-                  <a:srgbClr val="4A5F7A"/>
-                </a:solidFill>
-                <a:latin typeface="Poppins" pitchFamily="34" charset="0"/>
-                <a:ea typeface="Poppins" pitchFamily="34" charset="-122"/>
-                <a:cs typeface="Poppins" pitchFamily="34" charset="-120"/>
-              </a:rPr>
-              <a:t>Lösung:</a:t>
-            </a:r>
-            <a:endParaRPr lang="en-US" sz="1000" dirty="0"/>
-          </a:p>
-        </p:txBody>
-      </p:sp>
-      <p:sp>
-        <p:nvSpPr>
-          <p:cNvPr id="35" name="Shape 32"/>
-          <p:cNvSpPr/>
-          <p:nvPr/>
-        </p:nvSpPr>
-        <p:spPr>
-          <a:xfrm>
-            <a:off x="2606040" y="9061704"/>
+          <p:cNvPr id="31" name="Shape 27"/>
+          <p:cNvSpPr/>
+          <p:nvPr/>
+        </p:nvSpPr>
+        <p:spPr>
+          <a:xfrm>
+            <a:off x="2606040" y="7836408"/>
             <a:ext cx="2743200" cy="0"/>
           </a:xfrm>
           <a:prstGeom prst="line">
@@ -4692,7 +4921,169 @@
         </p:nvSpPr>
         <p:spPr>
           <a:xfrm>
-            <a:off x="548640" y="502920"/>
+            <a:off x="548640" y="274320"/>
+            <a:ext cx="2926080" cy="731520"/>
+          </a:xfrm>
+          <a:prstGeom prst="rect">
+            <a:avLst/>
+          </a:prstGeom>
+          <a:noFill/>
+          <a:ln/>
+        </p:spPr>
+        <p:txBody>
+          <a:bodyPr wrap="square" lIns="0" tIns="0" rIns="0" bIns="0" rtlCol="0" anchor="ctr"/>
+          <a:lstStyle/>
+          <a:p>
+            <a:pPr indent="0" marL="0">
+              <a:buNone/>
+            </a:pPr>
+            <a:r>
+              <a:rPr lang="en-US" sz="3000" b="1" dirty="0">
+                <a:solidFill>
+                  <a:srgbClr val="475BA6"/>
+                </a:solidFill>
+                <a:latin typeface="Poppins" pitchFamily="34" charset="0"/>
+                <a:ea typeface="Poppins" pitchFamily="34" charset="-122"/>
+                <a:cs typeface="Poppins" pitchFamily="34" charset="-120"/>
+              </a:rPr>
+              <a:t>clever</a:t>
+            </a:r>
+            <a:pPr indent="0" marL="0">
+              <a:buNone/>
+            </a:pPr>
+            <a:r>
+              <a:rPr lang="en-US" sz="3000" b="1" dirty="0">
+                <a:solidFill>
+                  <a:srgbClr val="36448A"/>
+                </a:solidFill>
+                <a:latin typeface="Poppins" pitchFamily="34" charset="0"/>
+                <a:ea typeface="Poppins" pitchFamily="34" charset="-122"/>
+                <a:cs typeface="Poppins" pitchFamily="34" charset="-120"/>
+              </a:rPr>
+              <a:t>box</a:t>
+            </a:r>
+            <a:endParaRPr lang="en-US" sz="3000" dirty="0"/>
+          </a:p>
+        </p:txBody>
+      </p:sp>
+      <p:pic>
+        <p:nvPicPr>
+          <p:cNvPr id="4" name="Image 0" descr="QR-Code zu www.cleverbox.co.at">    </p:cNvPr>
+          <p:cNvPicPr>
+            <a:picLocks noChangeAspect="1"/>
+          </p:cNvPicPr>
+          <p:nvPr/>
+        </p:nvPicPr>
+        <p:blipFill>
+          <a:blip r:embed="rId1"/>
+          <a:stretch>
+            <a:fillRect/>
+          </a:stretch>
+        </p:blipFill>
+        <p:spPr>
+          <a:xfrm>
+            <a:off x="6144768" y="228600"/>
+            <a:ext cx="868680" cy="868680"/>
+          </a:xfrm>
+          <a:prstGeom prst="rect">
+            <a:avLst/>
+          </a:prstGeom>
+        </p:spPr>
+      </p:pic>
+      <p:sp>
+        <p:nvSpPr>
+          <p:cNvPr id="5" name="Text 1"/>
+          <p:cNvSpPr txBox="1"/>
+          <p:nvPr/>
+        </p:nvSpPr>
+        <p:spPr>
+          <a:xfrm>
+            <a:off x="3767328" y="274320"/>
+            <a:ext cx="2286000" cy="777240"/>
+          </a:xfrm>
+          <a:prstGeom prst="rect">
+            <a:avLst/>
+          </a:prstGeom>
+          <a:noFill/>
+          <a:ln/>
+        </p:spPr>
+        <p:txBody>
+          <a:bodyPr wrap="square" lIns="0" tIns="0" rIns="0" bIns="0" rtlCol="0" anchor="ctr"/>
+          <a:lstStyle/>
+          <a:p>
+            <a:pPr algn="r" indent="0" marL="0">
+              <a:lnSpc>
+                <a:spcPct val="120000"/>
+              </a:lnSpc>
+              <a:buNone/>
+            </a:pPr>
+            <a:r>
+              <a:rPr lang="en-US" sz="1000" dirty="0">
+                <a:solidFill>
+                  <a:srgbClr val="4A5F7A"/>
+                </a:solidFill>
+                <a:latin typeface="Poppins" pitchFamily="34" charset="0"/>
+                <a:ea typeface="Poppins" pitchFamily="34" charset="-122"/>
+                <a:cs typeface="Poppins" pitchFamily="34" charset="-120"/>
+              </a:rPr>
+              <a:t>Mehr Material:</a:t>
+            </a:r>
+            <a:endParaRPr lang="en-US" sz="1000" dirty="0"/>
+          </a:p>
+          <a:p>
+            <a:pPr algn="r" indent="0" marL="0">
+              <a:lnSpc>
+                <a:spcPct val="120000"/>
+              </a:lnSpc>
+              <a:buNone/>
+            </a:pPr>
+            <a:r>
+              <a:rPr lang="en-US" sz="1000" dirty="0">
+                <a:solidFill>
+                  <a:srgbClr val="4A5F7A"/>
+                </a:solidFill>
+                <a:latin typeface="Poppins" pitchFamily="34" charset="0"/>
+                <a:ea typeface="Poppins" pitchFamily="34" charset="-122"/>
+                <a:cs typeface="Poppins" pitchFamily="34" charset="-120"/>
+              </a:rPr>
+              <a:t>www.cleverbox.co.at</a:t>
+            </a:r>
+            <a:endParaRPr lang="en-US" sz="1000" dirty="0"/>
+          </a:p>
+        </p:txBody>
+      </p:sp>
+      <p:sp>
+        <p:nvSpPr>
+          <p:cNvPr id="6" name="Shape 2"/>
+          <p:cNvSpPr/>
+          <p:nvPr/>
+        </p:nvSpPr>
+        <p:spPr>
+          <a:xfrm>
+            <a:off x="548640" y="1188720"/>
+            <a:ext cx="6464808" cy="0"/>
+          </a:xfrm>
+          <a:prstGeom prst="line">
+            <a:avLst/>
+          </a:prstGeom>
+          <a:noFill/>
+          <a:ln w="15875">
+            <a:solidFill>
+              <a:srgbClr val="8DBBF2"/>
+            </a:solidFill>
+            <a:prstDash val="solid"/>
+          </a:ln>
+        </p:spPr>
+      </p:sp>
+      <p:sp>
+        <p:nvSpPr>
+          <p:cNvPr id="7" name="Text 3"/>
+          <p:cNvSpPr txBox="1"/>
+          <p:nvPr/>
+        </p:nvSpPr>
+        <p:spPr>
+          <a:xfrm>
+            <a:off x="548640" y="1371600"/>
             <a:ext cx="6400800" cy="365760"/>
           </a:xfrm>
           <a:prstGeom prst="rect">
@@ -4725,18 +5116,18 @@
       </p:sp>
       <p:sp>
         <p:nvSpPr>
-          <p:cNvPr id="4" name="Shape 1"/>
-          <p:cNvSpPr/>
-          <p:nvPr/>
-        </p:nvSpPr>
-        <p:spPr>
-          <a:xfrm>
-            <a:off x="548640" y="1097280"/>
-            <a:ext cx="6464808" cy="2203704"/>
+          <p:cNvPr id="8" name="Shape 4"/>
+          <p:cNvSpPr/>
+          <p:nvPr/>
+        </p:nvSpPr>
+        <p:spPr>
+          <a:xfrm>
+            <a:off x="548640" y="1965960"/>
+            <a:ext cx="6464808" cy="1956816"/>
           </a:xfrm>
           <a:prstGeom prst="roundRect">
             <a:avLst>
-              <a:gd name="adj" fmla="val 6224"/>
+              <a:gd name="adj" fmla="val 7009"/>
             </a:avLst>
           </a:prstGeom>
           <a:solidFill>
@@ -4752,13 +5143,13 @@
       </p:sp>
       <p:sp>
         <p:nvSpPr>
-          <p:cNvPr id="5" name="Shape 2"/>
-          <p:cNvSpPr/>
-          <p:nvPr/>
-        </p:nvSpPr>
-        <p:spPr>
-          <a:xfrm>
-            <a:off x="749808" y="1298448"/>
+          <p:cNvPr id="9" name="Shape 5"/>
+          <p:cNvSpPr/>
+          <p:nvPr/>
+        </p:nvSpPr>
+        <p:spPr>
+          <a:xfrm>
+            <a:off x="749808" y="2167128"/>
             <a:ext cx="457200" cy="457200"/>
           </a:xfrm>
           <a:prstGeom prst="ellipse">
@@ -4777,13 +5168,13 @@
       </p:sp>
       <p:sp>
         <p:nvSpPr>
-          <p:cNvPr id="6" name="Text 3"/>
-          <p:cNvSpPr txBox="1"/>
-          <p:nvPr/>
-        </p:nvSpPr>
-        <p:spPr>
-          <a:xfrm>
-            <a:off x="749808" y="1298448"/>
+          <p:cNvPr id="10" name="Text 6"/>
+          <p:cNvSpPr txBox="1"/>
+          <p:nvPr/>
+        </p:nvSpPr>
+        <p:spPr>
+          <a:xfrm>
+            <a:off x="749808" y="2167128"/>
             <a:ext cx="457200" cy="457200"/>
           </a:xfrm>
           <a:prstGeom prst="rect">
@@ -4808,7 +5199,7 @@
                 <a:ea typeface="Poppins" pitchFamily="34" charset="-122"/>
                 <a:cs typeface="Poppins" pitchFamily="34" charset="-120"/>
               </a:rPr>
-              <a:t>12</a:t>
+              <a:t>11</a:t>
             </a:r>
             <a:endParaRPr lang="en-US" sz="1600" dirty="0"/>
           </a:p>
@@ -4816,14 +5207,14 @@
       </p:sp>
       <p:sp>
         <p:nvSpPr>
-          <p:cNvPr id="7" name="Text 4"/>
-          <p:cNvSpPr txBox="1"/>
-          <p:nvPr/>
-        </p:nvSpPr>
-        <p:spPr>
-          <a:xfrm>
-            <a:off x="1417320" y="1280160"/>
-            <a:ext cx="5367528" cy="832104"/>
+          <p:cNvPr id="11" name="Text 7"/>
+          <p:cNvSpPr txBox="1"/>
+          <p:nvPr/>
+        </p:nvSpPr>
+        <p:spPr>
+          <a:xfrm>
+            <a:off x="1417320" y="2148840"/>
+            <a:ext cx="5367528" cy="585216"/>
           </a:xfrm>
           <a:prstGeom prst="rect">
             <a:avLst/>
@@ -4850,7 +5241,7 @@
                 <a:ea typeface="Poppins" pitchFamily="34" charset="-122"/>
                 <a:cs typeface="Poppins" pitchFamily="34" charset="-120"/>
               </a:rPr>
-              <a:t>Petra, Konrad und Leon sind zusammen 42 Jahre alt. Leon ist um 5 Jahre älter als Petra und Konrad ist um 7 Jahre älter als Petra. Wie alt ist Leon?</a:t>
+              <a:t>Verena ist um 8 Jahre älter als ihr Bruder Roman. Beide zusammen sind 32 Jahre alt. Wie alt ist Roman?</a:t>
             </a:r>
             <a:endParaRPr lang="en-US" sz="1250" dirty="0"/>
           </a:p>
@@ -4858,13 +5249,13 @@
       </p:sp>
       <p:sp>
         <p:nvSpPr>
-          <p:cNvPr id="8" name="Text 5"/>
-          <p:cNvSpPr txBox="1"/>
-          <p:nvPr/>
-        </p:nvSpPr>
-        <p:spPr>
-          <a:xfrm>
-            <a:off x="1417320" y="2249424"/>
+          <p:cNvPr id="12" name="Text 8"/>
+          <p:cNvSpPr txBox="1"/>
+          <p:nvPr/>
+        </p:nvSpPr>
+        <p:spPr>
+          <a:xfrm>
+            <a:off x="1417320" y="2871216"/>
             <a:ext cx="1188720" cy="365760"/>
           </a:xfrm>
           <a:prstGeom prst="rect">
@@ -4897,13 +5288,13 @@
       </p:sp>
       <p:sp>
         <p:nvSpPr>
-          <p:cNvPr id="9" name="Shape 6"/>
-          <p:cNvSpPr/>
-          <p:nvPr/>
-        </p:nvSpPr>
-        <p:spPr>
-          <a:xfrm>
-            <a:off x="2606040" y="2569464"/>
+          <p:cNvPr id="13" name="Shape 9"/>
+          <p:cNvSpPr/>
+          <p:nvPr/>
+        </p:nvSpPr>
+        <p:spPr>
+          <a:xfrm>
+            <a:off x="2606040" y="3191256"/>
             <a:ext cx="4178808" cy="0"/>
           </a:xfrm>
           <a:prstGeom prst="line">
@@ -4920,13 +5311,13 @@
       </p:sp>
       <p:sp>
         <p:nvSpPr>
-          <p:cNvPr id="10" name="Text 7"/>
-          <p:cNvSpPr txBox="1"/>
-          <p:nvPr/>
-        </p:nvSpPr>
-        <p:spPr>
-          <a:xfrm>
-            <a:off x="1417320" y="2706624"/>
+          <p:cNvPr id="14" name="Text 10"/>
+          <p:cNvSpPr txBox="1"/>
+          <p:nvPr/>
+        </p:nvSpPr>
+        <p:spPr>
+          <a:xfrm>
+            <a:off x="1417320" y="3328416"/>
             <a:ext cx="1188720" cy="365760"/>
           </a:xfrm>
           <a:prstGeom prst="rect">
@@ -4959,13 +5350,13 @@
       </p:sp>
       <p:sp>
         <p:nvSpPr>
-          <p:cNvPr id="11" name="Shape 8"/>
-          <p:cNvSpPr/>
-          <p:nvPr/>
-        </p:nvSpPr>
-        <p:spPr>
-          <a:xfrm>
-            <a:off x="2606040" y="3026664"/>
+          <p:cNvPr id="15" name="Shape 11"/>
+          <p:cNvSpPr/>
+          <p:nvPr/>
+        </p:nvSpPr>
+        <p:spPr>
+          <a:xfrm>
+            <a:off x="2606040" y="3648456"/>
             <a:ext cx="2743200" cy="0"/>
           </a:xfrm>
           <a:prstGeom prst="line">
@@ -4982,13 +5373,13 @@
       </p:sp>
       <p:sp>
         <p:nvSpPr>
-          <p:cNvPr id="12" name="Shape 9"/>
-          <p:cNvSpPr/>
-          <p:nvPr/>
-        </p:nvSpPr>
-        <p:spPr>
-          <a:xfrm>
-            <a:off x="548640" y="3438144"/>
+          <p:cNvPr id="16" name="Shape 12"/>
+          <p:cNvSpPr/>
+          <p:nvPr/>
+        </p:nvSpPr>
+        <p:spPr>
+          <a:xfrm>
+            <a:off x="548640" y="4059936"/>
             <a:ext cx="6464808" cy="2203704"/>
           </a:xfrm>
           <a:prstGeom prst="roundRect">
@@ -5009,13 +5400,13 @@
       </p:sp>
       <p:sp>
         <p:nvSpPr>
-          <p:cNvPr id="13" name="Shape 10"/>
-          <p:cNvSpPr/>
-          <p:nvPr/>
-        </p:nvSpPr>
-        <p:spPr>
-          <a:xfrm>
-            <a:off x="749808" y="3639312"/>
+          <p:cNvPr id="17" name="Shape 13"/>
+          <p:cNvSpPr/>
+          <p:nvPr/>
+        </p:nvSpPr>
+        <p:spPr>
+          <a:xfrm>
+            <a:off x="749808" y="4261104"/>
             <a:ext cx="457200" cy="457200"/>
           </a:xfrm>
           <a:prstGeom prst="ellipse">
@@ -5034,13 +5425,13 @@
       </p:sp>
       <p:sp>
         <p:nvSpPr>
-          <p:cNvPr id="14" name="Text 11"/>
-          <p:cNvSpPr txBox="1"/>
-          <p:nvPr/>
-        </p:nvSpPr>
-        <p:spPr>
-          <a:xfrm>
-            <a:off x="749808" y="3639312"/>
+          <p:cNvPr id="18" name="Text 14"/>
+          <p:cNvSpPr txBox="1"/>
+          <p:nvPr/>
+        </p:nvSpPr>
+        <p:spPr>
+          <a:xfrm>
+            <a:off x="749808" y="4261104"/>
             <a:ext cx="457200" cy="457200"/>
           </a:xfrm>
           <a:prstGeom prst="rect">
@@ -5065,7 +5456,7 @@
                 <a:ea typeface="Poppins" pitchFamily="34" charset="-122"/>
                 <a:cs typeface="Poppins" pitchFamily="34" charset="-120"/>
               </a:rPr>
-              <a:t>13</a:t>
+              <a:t>12</a:t>
             </a:r>
             <a:endParaRPr lang="en-US" sz="1600" dirty="0"/>
           </a:p>
@@ -5073,13 +5464,13 @@
       </p:sp>
       <p:sp>
         <p:nvSpPr>
-          <p:cNvPr id="15" name="Text 12"/>
-          <p:cNvSpPr txBox="1"/>
-          <p:nvPr/>
-        </p:nvSpPr>
-        <p:spPr>
-          <a:xfrm>
-            <a:off x="1417320" y="3621024"/>
+          <p:cNvPr id="19" name="Text 15"/>
+          <p:cNvSpPr txBox="1"/>
+          <p:nvPr/>
+        </p:nvSpPr>
+        <p:spPr>
+          <a:xfrm>
+            <a:off x="1417320" y="4242816"/>
             <a:ext cx="5367528" cy="832104"/>
           </a:xfrm>
           <a:prstGeom prst="rect">
@@ -5107,7 +5498,7 @@
                 <a:ea typeface="Poppins" pitchFamily="34" charset="-122"/>
                 <a:cs typeface="Poppins" pitchFamily="34" charset="-120"/>
               </a:rPr>
-              <a:t>Anja, Armin und Alina sind zusammen 32 Jahre alt. Anja ist um 10 Jahre älter als Alina und Armin ist um 6 Jahre jünger als Anja. Wie alt ist Armin?</a:t>
+              <a:t>Petra, Konrad und Leon sind zusammen 42 Jahre alt. Leon ist um 5 Jahre älter als Petra und Konrad ist um 7 Jahre älter als Petra. Wie alt ist Leon?</a:t>
             </a:r>
             <a:endParaRPr lang="en-US" sz="1250" dirty="0"/>
           </a:p>
@@ -5115,13 +5506,13 @@
       </p:sp>
       <p:sp>
         <p:nvSpPr>
-          <p:cNvPr id="16" name="Text 13"/>
-          <p:cNvSpPr txBox="1"/>
-          <p:nvPr/>
-        </p:nvSpPr>
-        <p:spPr>
-          <a:xfrm>
-            <a:off x="1417320" y="4590288"/>
+          <p:cNvPr id="20" name="Text 16"/>
+          <p:cNvSpPr txBox="1"/>
+          <p:nvPr/>
+        </p:nvSpPr>
+        <p:spPr>
+          <a:xfrm>
+            <a:off x="1417320" y="5212080"/>
             <a:ext cx="1188720" cy="365760"/>
           </a:xfrm>
           <a:prstGeom prst="rect">
@@ -5154,13 +5545,13 @@
       </p:sp>
       <p:sp>
         <p:nvSpPr>
-          <p:cNvPr id="17" name="Shape 14"/>
-          <p:cNvSpPr/>
-          <p:nvPr/>
-        </p:nvSpPr>
-        <p:spPr>
-          <a:xfrm>
-            <a:off x="2606040" y="4910328"/>
+          <p:cNvPr id="21" name="Shape 17"/>
+          <p:cNvSpPr/>
+          <p:nvPr/>
+        </p:nvSpPr>
+        <p:spPr>
+          <a:xfrm>
+            <a:off x="2606040" y="5532120"/>
             <a:ext cx="4178808" cy="0"/>
           </a:xfrm>
           <a:prstGeom prst="line">
@@ -5177,13 +5568,13 @@
       </p:sp>
       <p:sp>
         <p:nvSpPr>
-          <p:cNvPr id="18" name="Text 15"/>
-          <p:cNvSpPr txBox="1"/>
-          <p:nvPr/>
-        </p:nvSpPr>
-        <p:spPr>
-          <a:xfrm>
-            <a:off x="1417320" y="5047488"/>
+          <p:cNvPr id="22" name="Text 18"/>
+          <p:cNvSpPr txBox="1"/>
+          <p:nvPr/>
+        </p:nvSpPr>
+        <p:spPr>
+          <a:xfrm>
+            <a:off x="1417320" y="5669280"/>
             <a:ext cx="1188720" cy="365760"/>
           </a:xfrm>
           <a:prstGeom prst="rect">
@@ -5216,13 +5607,13 @@
       </p:sp>
       <p:sp>
         <p:nvSpPr>
-          <p:cNvPr id="19" name="Shape 16"/>
-          <p:cNvSpPr/>
-          <p:nvPr/>
-        </p:nvSpPr>
-        <p:spPr>
-          <a:xfrm>
-            <a:off x="2606040" y="5367528"/>
+          <p:cNvPr id="23" name="Shape 19"/>
+          <p:cNvSpPr/>
+          <p:nvPr/>
+        </p:nvSpPr>
+        <p:spPr>
+          <a:xfrm>
+            <a:off x="2606040" y="5989320"/>
             <a:ext cx="2743200" cy="0"/>
           </a:xfrm>
           <a:prstGeom prst="line">
@@ -5239,18 +5630,18 @@
       </p:sp>
       <p:sp>
         <p:nvSpPr>
-          <p:cNvPr id="20" name="Shape 17"/>
-          <p:cNvSpPr/>
-          <p:nvPr/>
-        </p:nvSpPr>
-        <p:spPr>
-          <a:xfrm>
-            <a:off x="548640" y="5779008"/>
-            <a:ext cx="6464808" cy="3136392"/>
+          <p:cNvPr id="24" name="Shape 20"/>
+          <p:cNvSpPr/>
+          <p:nvPr/>
+        </p:nvSpPr>
+        <p:spPr>
+          <a:xfrm>
+            <a:off x="548640" y="6400800"/>
+            <a:ext cx="6464808" cy="2203704"/>
           </a:xfrm>
           <a:prstGeom prst="roundRect">
             <a:avLst>
-              <a:gd name="adj" fmla="val 4373"/>
+              <a:gd name="adj" fmla="val 6224"/>
             </a:avLst>
           </a:prstGeom>
           <a:solidFill>
@@ -5266,13 +5657,13 @@
       </p:sp>
       <p:sp>
         <p:nvSpPr>
-          <p:cNvPr id="21" name="Shape 18"/>
-          <p:cNvSpPr/>
-          <p:nvPr/>
-        </p:nvSpPr>
-        <p:spPr>
-          <a:xfrm>
-            <a:off x="749808" y="5980176"/>
+          <p:cNvPr id="25" name="Shape 21"/>
+          <p:cNvSpPr/>
+          <p:nvPr/>
+        </p:nvSpPr>
+        <p:spPr>
+          <a:xfrm>
+            <a:off x="749808" y="6601968"/>
             <a:ext cx="457200" cy="457200"/>
           </a:xfrm>
           <a:prstGeom prst="ellipse">
@@ -5291,13 +5682,13 @@
       </p:sp>
       <p:sp>
         <p:nvSpPr>
-          <p:cNvPr id="22" name="Text 19"/>
-          <p:cNvSpPr txBox="1"/>
-          <p:nvPr/>
-        </p:nvSpPr>
-        <p:spPr>
-          <a:xfrm>
-            <a:off x="749808" y="5980176"/>
+          <p:cNvPr id="26" name="Text 22"/>
+          <p:cNvSpPr txBox="1"/>
+          <p:nvPr/>
+        </p:nvSpPr>
+        <p:spPr>
+          <a:xfrm>
+            <a:off x="749808" y="6601968"/>
             <a:ext cx="457200" cy="457200"/>
           </a:xfrm>
           <a:prstGeom prst="rect">
@@ -5322,7 +5713,7 @@
                 <a:ea typeface="Poppins" pitchFamily="34" charset="-122"/>
                 <a:cs typeface="Poppins" pitchFamily="34" charset="-120"/>
               </a:rPr>
-              <a:t>14</a:t>
+              <a:t>13</a:t>
             </a:r>
             <a:endParaRPr lang="en-US" sz="1600" dirty="0"/>
           </a:p>
@@ -5330,14 +5721,14 @@
       </p:sp>
       <p:sp>
         <p:nvSpPr>
-          <p:cNvPr id="23" name="Text 20"/>
-          <p:cNvSpPr txBox="1"/>
-          <p:nvPr/>
-        </p:nvSpPr>
-        <p:spPr>
-          <a:xfrm>
-            <a:off x="1417320" y="5961888"/>
-            <a:ext cx="5367528" cy="1078992"/>
+          <p:cNvPr id="27" name="Text 23"/>
+          <p:cNvSpPr txBox="1"/>
+          <p:nvPr/>
+        </p:nvSpPr>
+        <p:spPr>
+          <a:xfrm>
+            <a:off x="1417320" y="6583680"/>
+            <a:ext cx="5367528" cy="832104"/>
           </a:xfrm>
           <a:prstGeom prst="rect">
             <a:avLst/>
@@ -5364,61 +5755,21 @@
                 <a:ea typeface="Poppins" pitchFamily="34" charset="-122"/>
                 <a:cs typeface="Poppins" pitchFamily="34" charset="-120"/>
               </a:rPr>
-              <a:t>In einem rechtwinkeligen Dreieck ist α viermal so groß wie β.</a:t>
+              <a:t>Anja, Armin und Alina sind zusammen 32 Jahre alt. Anja ist um 10 Jahre älter als Alina und Armin ist um 6 Jahre jünger als Anja. Wie alt ist Armin?</a:t>
             </a:r>
             <a:endParaRPr lang="en-US" sz="1250" dirty="0"/>
           </a:p>
-          <a:p>
-            <a:pPr indent="0" marL="0">
-              <a:lnSpc>
-                <a:spcPct val="120000"/>
-              </a:lnSpc>
-              <a:buNone/>
-            </a:pPr>
-            <a:r>
-              <a:rPr lang="en-US" sz="1250" dirty="0">
-                <a:solidFill>
-                  <a:srgbClr val="0B1E3A"/>
-                </a:solidFill>
-                <a:latin typeface="Poppins" pitchFamily="34" charset="0"/>
-                <a:ea typeface="Poppins" pitchFamily="34" charset="-122"/>
-                <a:cs typeface="Poppins" pitchFamily="34" charset="-120"/>
-              </a:rPr>
-              <a:t>a) Wie groß ist der rechte Winkel?</a:t>
-            </a:r>
-            <a:endParaRPr lang="en-US" sz="1250" dirty="0"/>
-          </a:p>
-          <a:p>
-            <a:pPr indent="0" marL="0">
-              <a:lnSpc>
-                <a:spcPct val="120000"/>
-              </a:lnSpc>
-              <a:buNone/>
-            </a:pPr>
-            <a:r>
-              <a:rPr lang="en-US" sz="1250" dirty="0">
-                <a:solidFill>
-                  <a:srgbClr val="0B1E3A"/>
-                </a:solidFill>
-                <a:latin typeface="Poppins" pitchFamily="34" charset="0"/>
-                <a:ea typeface="Poppins" pitchFamily="34" charset="-122"/>
-                <a:cs typeface="Poppins" pitchFamily="34" charset="-120"/>
-              </a:rPr>
-              <a:t>b) Wie groß ist α?</a:t>
-            </a:r>
-            <a:endParaRPr lang="en-US" sz="1250" dirty="0"/>
-          </a:p>
-        </p:txBody>
-      </p:sp>
-      <p:sp>
-        <p:nvSpPr>
-          <p:cNvPr id="24" name="Text 21"/>
-          <p:cNvSpPr txBox="1"/>
-          <p:nvPr/>
-        </p:nvSpPr>
-        <p:spPr>
-          <a:xfrm>
-            <a:off x="1417320" y="7178040"/>
+        </p:txBody>
+      </p:sp>
+      <p:sp>
+        <p:nvSpPr>
+          <p:cNvPr id="28" name="Text 24"/>
+          <p:cNvSpPr txBox="1"/>
+          <p:nvPr/>
+        </p:nvSpPr>
+        <p:spPr>
+          <a:xfrm>
+            <a:off x="1417320" y="7552944"/>
             <a:ext cx="1188720" cy="365760"/>
           </a:xfrm>
           <a:prstGeom prst="rect">
@@ -5451,13 +5802,13 @@
       </p:sp>
       <p:sp>
         <p:nvSpPr>
-          <p:cNvPr id="25" name="Shape 22"/>
-          <p:cNvSpPr/>
-          <p:nvPr/>
-        </p:nvSpPr>
-        <p:spPr>
-          <a:xfrm>
-            <a:off x="2606040" y="7498080"/>
+          <p:cNvPr id="29" name="Shape 25"/>
+          <p:cNvSpPr/>
+          <p:nvPr/>
+        </p:nvSpPr>
+        <p:spPr>
+          <a:xfrm>
+            <a:off x="2606040" y="7872984"/>
             <a:ext cx="4178808" cy="0"/>
           </a:xfrm>
           <a:prstGeom prst="line">
@@ -5474,14 +5825,14 @@
       </p:sp>
       <p:sp>
         <p:nvSpPr>
-          <p:cNvPr id="26" name="Text 23"/>
-          <p:cNvSpPr txBox="1"/>
-          <p:nvPr/>
-        </p:nvSpPr>
-        <p:spPr>
-          <a:xfrm>
-            <a:off x="1417320" y="7635240"/>
-            <a:ext cx="457200" cy="365760"/>
+          <p:cNvPr id="30" name="Text 26"/>
+          <p:cNvSpPr txBox="1"/>
+          <p:nvPr/>
+        </p:nvSpPr>
+        <p:spPr>
+          <a:xfrm>
+            <a:off x="1417320" y="8010144"/>
+            <a:ext cx="1188720" cy="365760"/>
           </a:xfrm>
           <a:prstGeom prst="rect">
             <a:avLst/>
@@ -5497,7 +5848,7 @@
               <a:buNone/>
             </a:pPr>
             <a:r>
-              <a:rPr lang="en-US" sz="1050" b="1" dirty="0">
+              <a:rPr lang="en-US" sz="1000" dirty="0">
                 <a:solidFill>
                   <a:srgbClr val="4A5F7A"/>
                 </a:solidFill>
@@ -5505,84 +5856,22 @@
                 <a:ea typeface="Poppins" pitchFamily="34" charset="-122"/>
                 <a:cs typeface="Poppins" pitchFamily="34" charset="-120"/>
               </a:rPr>
-              <a:t>a)</a:t>
-            </a:r>
-            <a:endParaRPr lang="en-US" sz="1050" dirty="0"/>
-          </a:p>
-        </p:txBody>
-      </p:sp>
-      <p:sp>
-        <p:nvSpPr>
-          <p:cNvPr id="27" name="Shape 24"/>
-          <p:cNvSpPr/>
-          <p:nvPr/>
-        </p:nvSpPr>
-        <p:spPr>
-          <a:xfrm>
-            <a:off x="1828800" y="7955280"/>
-            <a:ext cx="4956048" cy="0"/>
-          </a:xfrm>
-          <a:prstGeom prst="line">
-            <a:avLst/>
-          </a:prstGeom>
-          <a:noFill/>
-          <a:ln w="15875">
-            <a:solidFill>
-              <a:srgbClr val="8DBBF2"/>
-            </a:solidFill>
-            <a:prstDash val="sysDot"/>
-          </a:ln>
-        </p:spPr>
-      </p:sp>
-      <p:sp>
-        <p:nvSpPr>
-          <p:cNvPr id="28" name="Text 25"/>
-          <p:cNvSpPr txBox="1"/>
-          <p:nvPr/>
-        </p:nvSpPr>
-        <p:spPr>
-          <a:xfrm>
-            <a:off x="1417320" y="8138160"/>
-            <a:ext cx="457200" cy="365760"/>
-          </a:xfrm>
-          <a:prstGeom prst="rect">
-            <a:avLst/>
-          </a:prstGeom>
-          <a:noFill/>
-          <a:ln/>
-        </p:spPr>
-        <p:txBody>
-          <a:bodyPr wrap="square" lIns="0" tIns="0" rIns="0" bIns="0" rtlCol="0" anchor="ctr"/>
-          <a:lstStyle/>
-          <a:p>
-            <a:pPr indent="0" marL="0">
-              <a:buNone/>
-            </a:pPr>
-            <a:r>
-              <a:rPr lang="en-US" sz="1050" b="1" dirty="0">
-                <a:solidFill>
-                  <a:srgbClr val="4A5F7A"/>
-                </a:solidFill>
-                <a:latin typeface="Poppins" pitchFamily="34" charset="0"/>
-                <a:ea typeface="Poppins" pitchFamily="34" charset="-122"/>
-                <a:cs typeface="Poppins" pitchFamily="34" charset="-120"/>
-              </a:rPr>
-              <a:t>b)</a:t>
-            </a:r>
-            <a:endParaRPr lang="en-US" sz="1050" dirty="0"/>
-          </a:p>
-        </p:txBody>
-      </p:sp>
-      <p:sp>
-        <p:nvSpPr>
-          <p:cNvPr id="29" name="Shape 26"/>
-          <p:cNvSpPr/>
-          <p:nvPr/>
-        </p:nvSpPr>
-        <p:spPr>
-          <a:xfrm>
-            <a:off x="1828800" y="8458200"/>
-            <a:ext cx="4956048" cy="0"/>
+              <a:t>Lösung:</a:t>
+            </a:r>
+            <a:endParaRPr lang="en-US" sz="1000" dirty="0"/>
+          </a:p>
+        </p:txBody>
+      </p:sp>
+      <p:sp>
+        <p:nvSpPr>
+          <p:cNvPr id="31" name="Shape 27"/>
+          <p:cNvSpPr/>
+          <p:nvPr/>
+        </p:nvSpPr>
+        <p:spPr>
+          <a:xfrm>
+            <a:off x="2606040" y="8330184"/>
+            <a:ext cx="2743200" cy="0"/>
           </a:xfrm>
           <a:prstGeom prst="line">
             <a:avLst/>
@@ -5629,7 +5918,169 @@
         </p:nvSpPr>
         <p:spPr>
           <a:xfrm>
-            <a:off x="548640" y="502920"/>
+            <a:off x="548640" y="274320"/>
+            <a:ext cx="2926080" cy="731520"/>
+          </a:xfrm>
+          <a:prstGeom prst="rect">
+            <a:avLst/>
+          </a:prstGeom>
+          <a:noFill/>
+          <a:ln/>
+        </p:spPr>
+        <p:txBody>
+          <a:bodyPr wrap="square" lIns="0" tIns="0" rIns="0" bIns="0" rtlCol="0" anchor="ctr"/>
+          <a:lstStyle/>
+          <a:p>
+            <a:pPr indent="0" marL="0">
+              <a:buNone/>
+            </a:pPr>
+            <a:r>
+              <a:rPr lang="en-US" sz="3000" b="1" dirty="0">
+                <a:solidFill>
+                  <a:srgbClr val="475BA6"/>
+                </a:solidFill>
+                <a:latin typeface="Poppins" pitchFamily="34" charset="0"/>
+                <a:ea typeface="Poppins" pitchFamily="34" charset="-122"/>
+                <a:cs typeface="Poppins" pitchFamily="34" charset="-120"/>
+              </a:rPr>
+              <a:t>clever</a:t>
+            </a:r>
+            <a:pPr indent="0" marL="0">
+              <a:buNone/>
+            </a:pPr>
+            <a:r>
+              <a:rPr lang="en-US" sz="3000" b="1" dirty="0">
+                <a:solidFill>
+                  <a:srgbClr val="36448A"/>
+                </a:solidFill>
+                <a:latin typeface="Poppins" pitchFamily="34" charset="0"/>
+                <a:ea typeface="Poppins" pitchFamily="34" charset="-122"/>
+                <a:cs typeface="Poppins" pitchFamily="34" charset="-120"/>
+              </a:rPr>
+              <a:t>box</a:t>
+            </a:r>
+            <a:endParaRPr lang="en-US" sz="3000" dirty="0"/>
+          </a:p>
+        </p:txBody>
+      </p:sp>
+      <p:pic>
+        <p:nvPicPr>
+          <p:cNvPr id="4" name="Image 0" descr="QR-Code zu www.cleverbox.co.at">    </p:cNvPr>
+          <p:cNvPicPr>
+            <a:picLocks noChangeAspect="1"/>
+          </p:cNvPicPr>
+          <p:nvPr/>
+        </p:nvPicPr>
+        <p:blipFill>
+          <a:blip r:embed="rId1"/>
+          <a:stretch>
+            <a:fillRect/>
+          </a:stretch>
+        </p:blipFill>
+        <p:spPr>
+          <a:xfrm>
+            <a:off x="6144768" y="228600"/>
+            <a:ext cx="868680" cy="868680"/>
+          </a:xfrm>
+          <a:prstGeom prst="rect">
+            <a:avLst/>
+          </a:prstGeom>
+        </p:spPr>
+      </p:pic>
+      <p:sp>
+        <p:nvSpPr>
+          <p:cNvPr id="5" name="Text 1"/>
+          <p:cNvSpPr txBox="1"/>
+          <p:nvPr/>
+        </p:nvSpPr>
+        <p:spPr>
+          <a:xfrm>
+            <a:off x="3767328" y="274320"/>
+            <a:ext cx="2286000" cy="777240"/>
+          </a:xfrm>
+          <a:prstGeom prst="rect">
+            <a:avLst/>
+          </a:prstGeom>
+          <a:noFill/>
+          <a:ln/>
+        </p:spPr>
+        <p:txBody>
+          <a:bodyPr wrap="square" lIns="0" tIns="0" rIns="0" bIns="0" rtlCol="0" anchor="ctr"/>
+          <a:lstStyle/>
+          <a:p>
+            <a:pPr algn="r" indent="0" marL="0">
+              <a:lnSpc>
+                <a:spcPct val="120000"/>
+              </a:lnSpc>
+              <a:buNone/>
+            </a:pPr>
+            <a:r>
+              <a:rPr lang="en-US" sz="1000" dirty="0">
+                <a:solidFill>
+                  <a:srgbClr val="4A5F7A"/>
+                </a:solidFill>
+                <a:latin typeface="Poppins" pitchFamily="34" charset="0"/>
+                <a:ea typeface="Poppins" pitchFamily="34" charset="-122"/>
+                <a:cs typeface="Poppins" pitchFamily="34" charset="-120"/>
+              </a:rPr>
+              <a:t>Mehr Material:</a:t>
+            </a:r>
+            <a:endParaRPr lang="en-US" sz="1000" dirty="0"/>
+          </a:p>
+          <a:p>
+            <a:pPr algn="r" indent="0" marL="0">
+              <a:lnSpc>
+                <a:spcPct val="120000"/>
+              </a:lnSpc>
+              <a:buNone/>
+            </a:pPr>
+            <a:r>
+              <a:rPr lang="en-US" sz="1000" dirty="0">
+                <a:solidFill>
+                  <a:srgbClr val="4A5F7A"/>
+                </a:solidFill>
+                <a:latin typeface="Poppins" pitchFamily="34" charset="0"/>
+                <a:ea typeface="Poppins" pitchFamily="34" charset="-122"/>
+                <a:cs typeface="Poppins" pitchFamily="34" charset="-120"/>
+              </a:rPr>
+              <a:t>www.cleverbox.co.at</a:t>
+            </a:r>
+            <a:endParaRPr lang="en-US" sz="1000" dirty="0"/>
+          </a:p>
+        </p:txBody>
+      </p:sp>
+      <p:sp>
+        <p:nvSpPr>
+          <p:cNvPr id="6" name="Shape 2"/>
+          <p:cNvSpPr/>
+          <p:nvPr/>
+        </p:nvSpPr>
+        <p:spPr>
+          <a:xfrm>
+            <a:off x="548640" y="1188720"/>
+            <a:ext cx="6464808" cy="0"/>
+          </a:xfrm>
+          <a:prstGeom prst="line">
+            <a:avLst/>
+          </a:prstGeom>
+          <a:noFill/>
+          <a:ln w="15875">
+            <a:solidFill>
+              <a:srgbClr val="8DBBF2"/>
+            </a:solidFill>
+            <a:prstDash val="solid"/>
+          </a:ln>
+        </p:spPr>
+      </p:sp>
+      <p:sp>
+        <p:nvSpPr>
+          <p:cNvPr id="7" name="Text 3"/>
+          <p:cNvSpPr txBox="1"/>
+          <p:nvPr/>
+        </p:nvSpPr>
+        <p:spPr>
+          <a:xfrm>
+            <a:off x="548640" y="1371600"/>
             <a:ext cx="6400800" cy="365760"/>
           </a:xfrm>
           <a:prstGeom prst="rect">
@@ -5662,18 +6113,18 @@
       </p:sp>
       <p:sp>
         <p:nvSpPr>
-          <p:cNvPr id="4" name="Shape 1"/>
-          <p:cNvSpPr/>
-          <p:nvPr/>
-        </p:nvSpPr>
-        <p:spPr>
-          <a:xfrm>
-            <a:off x="548640" y="1097280"/>
-            <a:ext cx="6464808" cy="2203704"/>
+          <p:cNvPr id="8" name="Shape 4"/>
+          <p:cNvSpPr/>
+          <p:nvPr/>
+        </p:nvSpPr>
+        <p:spPr>
+          <a:xfrm>
+            <a:off x="548640" y="1965960"/>
+            <a:ext cx="6464808" cy="3136392"/>
           </a:xfrm>
           <a:prstGeom prst="roundRect">
             <a:avLst>
-              <a:gd name="adj" fmla="val 6224"/>
+              <a:gd name="adj" fmla="val 4373"/>
             </a:avLst>
           </a:prstGeom>
           <a:solidFill>
@@ -5689,13 +6140,13 @@
       </p:sp>
       <p:sp>
         <p:nvSpPr>
-          <p:cNvPr id="5" name="Shape 2"/>
-          <p:cNvSpPr/>
-          <p:nvPr/>
-        </p:nvSpPr>
-        <p:spPr>
-          <a:xfrm>
-            <a:off x="749808" y="1298448"/>
+          <p:cNvPr id="9" name="Shape 5"/>
+          <p:cNvSpPr/>
+          <p:nvPr/>
+        </p:nvSpPr>
+        <p:spPr>
+          <a:xfrm>
+            <a:off x="749808" y="2167128"/>
             <a:ext cx="457200" cy="457200"/>
           </a:xfrm>
           <a:prstGeom prst="ellipse">
@@ -5714,13 +6165,13 @@
       </p:sp>
       <p:sp>
         <p:nvSpPr>
-          <p:cNvPr id="6" name="Text 3"/>
-          <p:cNvSpPr txBox="1"/>
-          <p:nvPr/>
-        </p:nvSpPr>
-        <p:spPr>
-          <a:xfrm>
-            <a:off x="749808" y="1298448"/>
+          <p:cNvPr id="10" name="Text 6"/>
+          <p:cNvSpPr txBox="1"/>
+          <p:nvPr/>
+        </p:nvSpPr>
+        <p:spPr>
+          <a:xfrm>
+            <a:off x="749808" y="2167128"/>
             <a:ext cx="457200" cy="457200"/>
           </a:xfrm>
           <a:prstGeom prst="rect">
@@ -5745,7 +6196,7 @@
                 <a:ea typeface="Poppins" pitchFamily="34" charset="-122"/>
                 <a:cs typeface="Poppins" pitchFamily="34" charset="-120"/>
               </a:rPr>
-              <a:t>15</a:t>
+              <a:t>14</a:t>
             </a:r>
             <a:endParaRPr lang="en-US" sz="1600" dirty="0"/>
           </a:p>
@@ -5753,14 +6204,14 @@
       </p:sp>
       <p:sp>
         <p:nvSpPr>
-          <p:cNvPr id="7" name="Text 4"/>
-          <p:cNvSpPr txBox="1"/>
-          <p:nvPr/>
-        </p:nvSpPr>
-        <p:spPr>
-          <a:xfrm>
-            <a:off x="1417320" y="1280160"/>
-            <a:ext cx="5367528" cy="832104"/>
+          <p:cNvPr id="11" name="Text 7"/>
+          <p:cNvSpPr txBox="1"/>
+          <p:nvPr/>
+        </p:nvSpPr>
+        <p:spPr>
+          <a:xfrm>
+            <a:off x="1417320" y="2148840"/>
+            <a:ext cx="5367528" cy="1078992"/>
           </a:xfrm>
           <a:prstGeom prst="rect">
             <a:avLst/>
@@ -5787,21 +6238,61 @@
                 <a:ea typeface="Poppins" pitchFamily="34" charset="-122"/>
                 <a:cs typeface="Poppins" pitchFamily="34" charset="-120"/>
               </a:rPr>
-              <a:t>Georg, Nicole und Carina sind zusammen 43 Jahre alt. Georg ist um 7 Jahre älter als Nicole und Carina ist um 9 Jahre älter als Nicole. Wie alt ist Nicole?</a:t>
+              <a:t>In einem rechtwinkeligen Dreieck ist α viermal so groß wie β.</a:t>
             </a:r>
             <a:endParaRPr lang="en-US" sz="1250" dirty="0"/>
           </a:p>
-        </p:txBody>
-      </p:sp>
-      <p:sp>
-        <p:nvSpPr>
-          <p:cNvPr id="8" name="Text 5"/>
-          <p:cNvSpPr txBox="1"/>
-          <p:nvPr/>
-        </p:nvSpPr>
-        <p:spPr>
-          <a:xfrm>
-            <a:off x="1417320" y="2249424"/>
+          <a:p>
+            <a:pPr indent="0" marL="0">
+              <a:lnSpc>
+                <a:spcPct val="120000"/>
+              </a:lnSpc>
+              <a:buNone/>
+            </a:pPr>
+            <a:r>
+              <a:rPr lang="en-US" sz="1250" dirty="0">
+                <a:solidFill>
+                  <a:srgbClr val="0B1E3A"/>
+                </a:solidFill>
+                <a:latin typeface="Poppins" pitchFamily="34" charset="0"/>
+                <a:ea typeface="Poppins" pitchFamily="34" charset="-122"/>
+                <a:cs typeface="Poppins" pitchFamily="34" charset="-120"/>
+              </a:rPr>
+              <a:t>a) Wie groß ist der rechte Winkel?</a:t>
+            </a:r>
+            <a:endParaRPr lang="en-US" sz="1250" dirty="0"/>
+          </a:p>
+          <a:p>
+            <a:pPr indent="0" marL="0">
+              <a:lnSpc>
+                <a:spcPct val="120000"/>
+              </a:lnSpc>
+              <a:buNone/>
+            </a:pPr>
+            <a:r>
+              <a:rPr lang="en-US" sz="1250" dirty="0">
+                <a:solidFill>
+                  <a:srgbClr val="0B1E3A"/>
+                </a:solidFill>
+                <a:latin typeface="Poppins" pitchFamily="34" charset="0"/>
+                <a:ea typeface="Poppins" pitchFamily="34" charset="-122"/>
+                <a:cs typeface="Poppins" pitchFamily="34" charset="-120"/>
+              </a:rPr>
+              <a:t>b) Wie groß ist α?</a:t>
+            </a:r>
+            <a:endParaRPr lang="en-US" sz="1250" dirty="0"/>
+          </a:p>
+        </p:txBody>
+      </p:sp>
+      <p:sp>
+        <p:nvSpPr>
+          <p:cNvPr id="12" name="Text 8"/>
+          <p:cNvSpPr txBox="1"/>
+          <p:nvPr/>
+        </p:nvSpPr>
+        <p:spPr>
+          <a:xfrm>
+            <a:off x="1417320" y="3364992"/>
             <a:ext cx="1188720" cy="365760"/>
           </a:xfrm>
           <a:prstGeom prst="rect">
@@ -5834,13 +6325,13 @@
       </p:sp>
       <p:sp>
         <p:nvSpPr>
-          <p:cNvPr id="9" name="Shape 6"/>
-          <p:cNvSpPr/>
-          <p:nvPr/>
-        </p:nvSpPr>
-        <p:spPr>
-          <a:xfrm>
-            <a:off x="2606040" y="2569464"/>
+          <p:cNvPr id="13" name="Shape 9"/>
+          <p:cNvSpPr/>
+          <p:nvPr/>
+        </p:nvSpPr>
+        <p:spPr>
+          <a:xfrm>
+            <a:off x="2606040" y="3685032"/>
             <a:ext cx="4178808" cy="0"/>
           </a:xfrm>
           <a:prstGeom prst="line">
@@ -5857,14 +6348,14 @@
       </p:sp>
       <p:sp>
         <p:nvSpPr>
-          <p:cNvPr id="10" name="Text 7"/>
-          <p:cNvSpPr txBox="1"/>
-          <p:nvPr/>
-        </p:nvSpPr>
-        <p:spPr>
-          <a:xfrm>
-            <a:off x="1417320" y="2706624"/>
-            <a:ext cx="1188720" cy="365760"/>
+          <p:cNvPr id="14" name="Text 10"/>
+          <p:cNvSpPr txBox="1"/>
+          <p:nvPr/>
+        </p:nvSpPr>
+        <p:spPr>
+          <a:xfrm>
+            <a:off x="1417320" y="3822192"/>
+            <a:ext cx="457200" cy="365760"/>
           </a:xfrm>
           <a:prstGeom prst="rect">
             <a:avLst/>
@@ -5880,7 +6371,7 @@
               <a:buNone/>
             </a:pPr>
             <a:r>
-              <a:rPr lang="en-US" sz="1000" dirty="0">
+              <a:rPr lang="en-US" sz="1050" b="1" dirty="0">
                 <a:solidFill>
                   <a:srgbClr val="4A5F7A"/>
                 </a:solidFill>
@@ -5888,22 +6379,22 @@
                 <a:ea typeface="Poppins" pitchFamily="34" charset="-122"/>
                 <a:cs typeface="Poppins" pitchFamily="34" charset="-120"/>
               </a:rPr>
-              <a:t>Lösung:</a:t>
-            </a:r>
-            <a:endParaRPr lang="en-US" sz="1000" dirty="0"/>
-          </a:p>
-        </p:txBody>
-      </p:sp>
-      <p:sp>
-        <p:nvSpPr>
-          <p:cNvPr id="11" name="Shape 8"/>
-          <p:cNvSpPr/>
-          <p:nvPr/>
-        </p:nvSpPr>
-        <p:spPr>
-          <a:xfrm>
-            <a:off x="2606040" y="3026664"/>
-            <a:ext cx="2743200" cy="0"/>
+              <a:t>a)</a:t>
+            </a:r>
+            <a:endParaRPr lang="en-US" sz="1050" dirty="0"/>
+          </a:p>
+        </p:txBody>
+      </p:sp>
+      <p:sp>
+        <p:nvSpPr>
+          <p:cNvPr id="15" name="Shape 11"/>
+          <p:cNvSpPr/>
+          <p:nvPr/>
+        </p:nvSpPr>
+        <p:spPr>
+          <a:xfrm>
+            <a:off x="1828800" y="4142232"/>
+            <a:ext cx="4956048" cy="0"/>
           </a:xfrm>
           <a:prstGeom prst="line">
             <a:avLst/>
@@ -5919,13 +6410,75 @@
       </p:sp>
       <p:sp>
         <p:nvSpPr>
-          <p:cNvPr id="12" name="Shape 9"/>
-          <p:cNvSpPr/>
-          <p:nvPr/>
-        </p:nvSpPr>
-        <p:spPr>
-          <a:xfrm>
-            <a:off x="548640" y="3438144"/>
+          <p:cNvPr id="16" name="Text 12"/>
+          <p:cNvSpPr txBox="1"/>
+          <p:nvPr/>
+        </p:nvSpPr>
+        <p:spPr>
+          <a:xfrm>
+            <a:off x="1417320" y="4325112"/>
+            <a:ext cx="457200" cy="365760"/>
+          </a:xfrm>
+          <a:prstGeom prst="rect">
+            <a:avLst/>
+          </a:prstGeom>
+          <a:noFill/>
+          <a:ln/>
+        </p:spPr>
+        <p:txBody>
+          <a:bodyPr wrap="square" lIns="0" tIns="0" rIns="0" bIns="0" rtlCol="0" anchor="ctr"/>
+          <a:lstStyle/>
+          <a:p>
+            <a:pPr indent="0" marL="0">
+              <a:buNone/>
+            </a:pPr>
+            <a:r>
+              <a:rPr lang="en-US" sz="1050" b="1" dirty="0">
+                <a:solidFill>
+                  <a:srgbClr val="4A5F7A"/>
+                </a:solidFill>
+                <a:latin typeface="Poppins" pitchFamily="34" charset="0"/>
+                <a:ea typeface="Poppins" pitchFamily="34" charset="-122"/>
+                <a:cs typeface="Poppins" pitchFamily="34" charset="-120"/>
+              </a:rPr>
+              <a:t>b)</a:t>
+            </a:r>
+            <a:endParaRPr lang="en-US" sz="1050" dirty="0"/>
+          </a:p>
+        </p:txBody>
+      </p:sp>
+      <p:sp>
+        <p:nvSpPr>
+          <p:cNvPr id="17" name="Shape 13"/>
+          <p:cNvSpPr/>
+          <p:nvPr/>
+        </p:nvSpPr>
+        <p:spPr>
+          <a:xfrm>
+            <a:off x="1828800" y="4645152"/>
+            <a:ext cx="4956048" cy="0"/>
+          </a:xfrm>
+          <a:prstGeom prst="line">
+            <a:avLst/>
+          </a:prstGeom>
+          <a:noFill/>
+          <a:ln w="15875">
+            <a:solidFill>
+              <a:srgbClr val="8DBBF2"/>
+            </a:solidFill>
+            <a:prstDash val="sysDot"/>
+          </a:ln>
+        </p:spPr>
+      </p:sp>
+      <p:sp>
+        <p:nvSpPr>
+          <p:cNvPr id="18" name="Shape 14"/>
+          <p:cNvSpPr/>
+          <p:nvPr/>
+        </p:nvSpPr>
+        <p:spPr>
+          <a:xfrm>
+            <a:off x="548640" y="5239512"/>
             <a:ext cx="6464808" cy="2203704"/>
           </a:xfrm>
           <a:prstGeom prst="roundRect">
@@ -5946,13 +6499,13 @@
       </p:sp>
       <p:sp>
         <p:nvSpPr>
-          <p:cNvPr id="13" name="Shape 10"/>
-          <p:cNvSpPr/>
-          <p:nvPr/>
-        </p:nvSpPr>
-        <p:spPr>
-          <a:xfrm>
-            <a:off x="749808" y="3639312"/>
+          <p:cNvPr id="19" name="Shape 15"/>
+          <p:cNvSpPr/>
+          <p:nvPr/>
+        </p:nvSpPr>
+        <p:spPr>
+          <a:xfrm>
+            <a:off x="749808" y="5440680"/>
             <a:ext cx="457200" cy="457200"/>
           </a:xfrm>
           <a:prstGeom prst="ellipse">
@@ -5971,13 +6524,13 @@
       </p:sp>
       <p:sp>
         <p:nvSpPr>
-          <p:cNvPr id="14" name="Text 11"/>
-          <p:cNvSpPr txBox="1"/>
-          <p:nvPr/>
-        </p:nvSpPr>
-        <p:spPr>
-          <a:xfrm>
-            <a:off x="749808" y="3639312"/>
+          <p:cNvPr id="20" name="Text 16"/>
+          <p:cNvSpPr txBox="1"/>
+          <p:nvPr/>
+        </p:nvSpPr>
+        <p:spPr>
+          <a:xfrm>
+            <a:off x="749808" y="5440680"/>
             <a:ext cx="457200" cy="457200"/>
           </a:xfrm>
           <a:prstGeom prst="rect">
@@ -6002,7 +6555,7 @@
                 <a:ea typeface="Poppins" pitchFamily="34" charset="-122"/>
                 <a:cs typeface="Poppins" pitchFamily="34" charset="-120"/>
               </a:rPr>
-              <a:t>16</a:t>
+              <a:t>15</a:t>
             </a:r>
             <a:endParaRPr lang="en-US" sz="1600" dirty="0"/>
           </a:p>
@@ -6010,13 +6563,13 @@
       </p:sp>
       <p:sp>
         <p:nvSpPr>
-          <p:cNvPr id="15" name="Text 12"/>
-          <p:cNvSpPr txBox="1"/>
-          <p:nvPr/>
-        </p:nvSpPr>
-        <p:spPr>
-          <a:xfrm>
-            <a:off x="1417320" y="3621024"/>
+          <p:cNvPr id="21" name="Text 17"/>
+          <p:cNvSpPr txBox="1"/>
+          <p:nvPr/>
+        </p:nvSpPr>
+        <p:spPr>
+          <a:xfrm>
+            <a:off x="1417320" y="5422392"/>
             <a:ext cx="5367528" cy="832104"/>
           </a:xfrm>
           <a:prstGeom prst="rect">
@@ -6044,7 +6597,7 @@
                 <a:ea typeface="Poppins" pitchFamily="34" charset="-122"/>
                 <a:cs typeface="Poppins" pitchFamily="34" charset="-120"/>
               </a:rPr>
-              <a:t>Pia, Johannes und Elisabeth sind zusammen 39 Jahre alt. Pia ist um 4 Jahre älter als Elisabeth und Johannes ist um 2 Jahre jünger als Pia. Wie alt ist Pia?</a:t>
+              <a:t>Georg, Nicole und Carina sind zusammen 43 Jahre alt. Georg ist um 7 Jahre älter als Nicole und Carina ist um 9 Jahre älter als Nicole. Wie alt ist Nicole?</a:t>
             </a:r>
             <a:endParaRPr lang="en-US" sz="1250" dirty="0"/>
           </a:p>
@@ -6052,13 +6605,13 @@
       </p:sp>
       <p:sp>
         <p:nvSpPr>
-          <p:cNvPr id="16" name="Text 13"/>
-          <p:cNvSpPr txBox="1"/>
-          <p:nvPr/>
-        </p:nvSpPr>
-        <p:spPr>
-          <a:xfrm>
-            <a:off x="1417320" y="4590288"/>
+          <p:cNvPr id="22" name="Text 18"/>
+          <p:cNvSpPr txBox="1"/>
+          <p:nvPr/>
+        </p:nvSpPr>
+        <p:spPr>
+          <a:xfrm>
+            <a:off x="1417320" y="6391656"/>
             <a:ext cx="1188720" cy="365760"/>
           </a:xfrm>
           <a:prstGeom prst="rect">
@@ -6091,13 +6644,13 @@
       </p:sp>
       <p:sp>
         <p:nvSpPr>
-          <p:cNvPr id="17" name="Shape 14"/>
-          <p:cNvSpPr/>
-          <p:nvPr/>
-        </p:nvSpPr>
-        <p:spPr>
-          <a:xfrm>
-            <a:off x="2606040" y="4910328"/>
+          <p:cNvPr id="23" name="Shape 19"/>
+          <p:cNvSpPr/>
+          <p:nvPr/>
+        </p:nvSpPr>
+        <p:spPr>
+          <a:xfrm>
+            <a:off x="2606040" y="6711696"/>
             <a:ext cx="4178808" cy="0"/>
           </a:xfrm>
           <a:prstGeom prst="line">
@@ -6114,13 +6667,13 @@
       </p:sp>
       <p:sp>
         <p:nvSpPr>
-          <p:cNvPr id="18" name="Text 15"/>
-          <p:cNvSpPr txBox="1"/>
-          <p:nvPr/>
-        </p:nvSpPr>
-        <p:spPr>
-          <a:xfrm>
-            <a:off x="1417320" y="5047488"/>
+          <p:cNvPr id="24" name="Text 20"/>
+          <p:cNvSpPr txBox="1"/>
+          <p:nvPr/>
+        </p:nvSpPr>
+        <p:spPr>
+          <a:xfrm>
+            <a:off x="1417320" y="6848856"/>
             <a:ext cx="1188720" cy="365760"/>
           </a:xfrm>
           <a:prstGeom prst="rect">
@@ -6153,13 +6706,270 @@
       </p:sp>
       <p:sp>
         <p:nvSpPr>
-          <p:cNvPr id="19" name="Shape 16"/>
-          <p:cNvSpPr/>
-          <p:nvPr/>
-        </p:nvSpPr>
-        <p:spPr>
-          <a:xfrm>
-            <a:off x="2606040" y="5367528"/>
+          <p:cNvPr id="25" name="Shape 21"/>
+          <p:cNvSpPr/>
+          <p:nvPr/>
+        </p:nvSpPr>
+        <p:spPr>
+          <a:xfrm>
+            <a:off x="2606040" y="7168896"/>
+            <a:ext cx="2743200" cy="0"/>
+          </a:xfrm>
+          <a:prstGeom prst="line">
+            <a:avLst/>
+          </a:prstGeom>
+          <a:noFill/>
+          <a:ln w="15875">
+            <a:solidFill>
+              <a:srgbClr val="8DBBF2"/>
+            </a:solidFill>
+            <a:prstDash val="sysDot"/>
+          </a:ln>
+        </p:spPr>
+      </p:sp>
+      <p:sp>
+        <p:nvSpPr>
+          <p:cNvPr id="26" name="Shape 22"/>
+          <p:cNvSpPr/>
+          <p:nvPr/>
+        </p:nvSpPr>
+        <p:spPr>
+          <a:xfrm>
+            <a:off x="548640" y="7580376"/>
+            <a:ext cx="6464808" cy="2203704"/>
+          </a:xfrm>
+          <a:prstGeom prst="roundRect">
+            <a:avLst>
+              <a:gd name="adj" fmla="val 6224"/>
+            </a:avLst>
+          </a:prstGeom>
+          <a:solidFill>
+            <a:srgbClr val="FFFFFF"/>
+          </a:solidFill>
+          <a:ln w="15875">
+            <a:solidFill>
+              <a:srgbClr val="8DBBF2"/>
+            </a:solidFill>
+            <a:prstDash val="solid"/>
+          </a:ln>
+        </p:spPr>
+      </p:sp>
+      <p:sp>
+        <p:nvSpPr>
+          <p:cNvPr id="27" name="Shape 23"/>
+          <p:cNvSpPr/>
+          <p:nvPr/>
+        </p:nvSpPr>
+        <p:spPr>
+          <a:xfrm>
+            <a:off x="749808" y="7781544"/>
+            <a:ext cx="457200" cy="457200"/>
+          </a:xfrm>
+          <a:prstGeom prst="ellipse">
+            <a:avLst/>
+          </a:prstGeom>
+          <a:solidFill>
+            <a:srgbClr val="BCD6F5"/>
+          </a:solidFill>
+          <a:ln w="12700">
+            <a:solidFill>
+              <a:srgbClr val="BCD6F5"/>
+            </a:solidFill>
+            <a:prstDash val="solid"/>
+          </a:ln>
+        </p:spPr>
+      </p:sp>
+      <p:sp>
+        <p:nvSpPr>
+          <p:cNvPr id="28" name="Text 24"/>
+          <p:cNvSpPr txBox="1"/>
+          <p:nvPr/>
+        </p:nvSpPr>
+        <p:spPr>
+          <a:xfrm>
+            <a:off x="749808" y="7781544"/>
+            <a:ext cx="457200" cy="457200"/>
+          </a:xfrm>
+          <a:prstGeom prst="rect">
+            <a:avLst/>
+          </a:prstGeom>
+          <a:noFill/>
+          <a:ln/>
+        </p:spPr>
+        <p:txBody>
+          <a:bodyPr wrap="square" lIns="0" tIns="0" rIns="0" bIns="0" rtlCol="0" anchor="ctr"/>
+          <a:lstStyle/>
+          <a:p>
+            <a:pPr algn="ctr" indent="0" marL="0">
+              <a:buNone/>
+            </a:pPr>
+            <a:r>
+              <a:rPr lang="en-US" sz="1600" b="1" dirty="0">
+                <a:solidFill>
+                  <a:srgbClr val="0B1E3A"/>
+                </a:solidFill>
+                <a:latin typeface="Poppins" pitchFamily="34" charset="0"/>
+                <a:ea typeface="Poppins" pitchFamily="34" charset="-122"/>
+                <a:cs typeface="Poppins" pitchFamily="34" charset="-120"/>
+              </a:rPr>
+              <a:t>16</a:t>
+            </a:r>
+            <a:endParaRPr lang="en-US" sz="1600" dirty="0"/>
+          </a:p>
+        </p:txBody>
+      </p:sp>
+      <p:sp>
+        <p:nvSpPr>
+          <p:cNvPr id="29" name="Text 25"/>
+          <p:cNvSpPr txBox="1"/>
+          <p:nvPr/>
+        </p:nvSpPr>
+        <p:spPr>
+          <a:xfrm>
+            <a:off x="1417320" y="7763256"/>
+            <a:ext cx="5367528" cy="832104"/>
+          </a:xfrm>
+          <a:prstGeom prst="rect">
+            <a:avLst/>
+          </a:prstGeom>
+          <a:noFill/>
+          <a:ln/>
+        </p:spPr>
+        <p:txBody>
+          <a:bodyPr wrap="square" lIns="0" tIns="0" rIns="0" bIns="0" rtlCol="0" anchor="t"/>
+          <a:lstStyle/>
+          <a:p>
+            <a:pPr indent="0" marL="0">
+              <a:lnSpc>
+                <a:spcPct val="120000"/>
+              </a:lnSpc>
+              <a:buNone/>
+            </a:pPr>
+            <a:r>
+              <a:rPr lang="en-US" sz="1250" dirty="0">
+                <a:solidFill>
+                  <a:srgbClr val="0B1E3A"/>
+                </a:solidFill>
+                <a:latin typeface="Poppins" pitchFamily="34" charset="0"/>
+                <a:ea typeface="Poppins" pitchFamily="34" charset="-122"/>
+                <a:cs typeface="Poppins" pitchFamily="34" charset="-120"/>
+              </a:rPr>
+              <a:t>Pia, Johannes und Elisabeth sind zusammen 39 Jahre alt. Pia ist um 4 Jahre älter als Elisabeth und Johannes ist um 2 Jahre jünger als Pia. Wie alt ist Pia?</a:t>
+            </a:r>
+            <a:endParaRPr lang="en-US" sz="1250" dirty="0"/>
+          </a:p>
+        </p:txBody>
+      </p:sp>
+      <p:sp>
+        <p:nvSpPr>
+          <p:cNvPr id="30" name="Text 26"/>
+          <p:cNvSpPr txBox="1"/>
+          <p:nvPr/>
+        </p:nvSpPr>
+        <p:spPr>
+          <a:xfrm>
+            <a:off x="1417320" y="8732520"/>
+            <a:ext cx="1188720" cy="365760"/>
+          </a:xfrm>
+          <a:prstGeom prst="rect">
+            <a:avLst/>
+          </a:prstGeom>
+          <a:noFill/>
+          <a:ln/>
+        </p:spPr>
+        <p:txBody>
+          <a:bodyPr wrap="square" lIns="0" tIns="0" rIns="0" bIns="0" rtlCol="0" anchor="ctr"/>
+          <a:lstStyle/>
+          <a:p>
+            <a:pPr indent="0" marL="0">
+              <a:buNone/>
+            </a:pPr>
+            <a:r>
+              <a:rPr lang="en-US" sz="1000" dirty="0">
+                <a:solidFill>
+                  <a:srgbClr val="4A5F7A"/>
+                </a:solidFill>
+                <a:latin typeface="Poppins" pitchFamily="34" charset="0"/>
+                <a:ea typeface="Poppins" pitchFamily="34" charset="-122"/>
+                <a:cs typeface="Poppins" pitchFamily="34" charset="-120"/>
+              </a:rPr>
+              <a:t>Gleichung:</a:t>
+            </a:r>
+            <a:endParaRPr lang="en-US" sz="1000" dirty="0"/>
+          </a:p>
+        </p:txBody>
+      </p:sp>
+      <p:sp>
+        <p:nvSpPr>
+          <p:cNvPr id="31" name="Shape 27"/>
+          <p:cNvSpPr/>
+          <p:nvPr/>
+        </p:nvSpPr>
+        <p:spPr>
+          <a:xfrm>
+            <a:off x="2606040" y="9052560"/>
+            <a:ext cx="4178808" cy="0"/>
+          </a:xfrm>
+          <a:prstGeom prst="line">
+            <a:avLst/>
+          </a:prstGeom>
+          <a:noFill/>
+          <a:ln w="15875">
+            <a:solidFill>
+              <a:srgbClr val="8DBBF2"/>
+            </a:solidFill>
+            <a:prstDash val="sysDot"/>
+          </a:ln>
+        </p:spPr>
+      </p:sp>
+      <p:sp>
+        <p:nvSpPr>
+          <p:cNvPr id="32" name="Text 28"/>
+          <p:cNvSpPr txBox="1"/>
+          <p:nvPr/>
+        </p:nvSpPr>
+        <p:spPr>
+          <a:xfrm>
+            <a:off x="1417320" y="9189720"/>
+            <a:ext cx="1188720" cy="365760"/>
+          </a:xfrm>
+          <a:prstGeom prst="rect">
+            <a:avLst/>
+          </a:prstGeom>
+          <a:noFill/>
+          <a:ln/>
+        </p:spPr>
+        <p:txBody>
+          <a:bodyPr wrap="square" lIns="0" tIns="0" rIns="0" bIns="0" rtlCol="0" anchor="ctr"/>
+          <a:lstStyle/>
+          <a:p>
+            <a:pPr indent="0" marL="0">
+              <a:buNone/>
+            </a:pPr>
+            <a:r>
+              <a:rPr lang="en-US" sz="1000" dirty="0">
+                <a:solidFill>
+                  <a:srgbClr val="4A5F7A"/>
+                </a:solidFill>
+                <a:latin typeface="Poppins" pitchFamily="34" charset="0"/>
+                <a:ea typeface="Poppins" pitchFamily="34" charset="-122"/>
+                <a:cs typeface="Poppins" pitchFamily="34" charset="-120"/>
+              </a:rPr>
+              <a:t>Lösung:</a:t>
+            </a:r>
+            <a:endParaRPr lang="en-US" sz="1000" dirty="0"/>
+          </a:p>
+        </p:txBody>
+      </p:sp>
+      <p:sp>
+        <p:nvSpPr>
+          <p:cNvPr id="33" name="Shape 29"/>
+          <p:cNvSpPr/>
+          <p:nvPr/>
+        </p:nvSpPr>
+        <p:spPr>
+          <a:xfrm>
+            <a:off x="2606040" y="9509760"/>
             <a:ext cx="2743200" cy="0"/>
           </a:xfrm>
           <a:prstGeom prst="line">

</xml_diff>

<commit_message>
Arbeitsblatt: echtes Cleverbox-Logo in der Kopfzeile
Co-Authored-By: Claude Sonnet 5.5 <noreply@anthropic.com>
Claude-Session: https://claude.ai/code/session_0139kriXJ67p3UvpR2gsSR9G
</commit_message>
<xml_diff>
--- a/videoslides/arbeitsblatt-textgleichungen-a4.pptx
+++ b/videoslides/arbeitsblatt-textgleichungen-a4.pptx
@@ -1440,62 +1440,9 @@
           <a:chExt cx="0" cy="0"/>
         </a:xfrm>
       </p:grpSpPr>
-      <p:sp>
-        <p:nvSpPr>
-          <p:cNvPr id="3" name="Text 0"/>
-          <p:cNvSpPr txBox="1"/>
-          <p:nvPr/>
-        </p:nvSpPr>
-        <p:spPr>
-          <a:xfrm>
-            <a:off x="548640" y="274320"/>
-            <a:ext cx="2926080" cy="731520"/>
-          </a:xfrm>
-          <a:prstGeom prst="rect">
-            <a:avLst/>
-          </a:prstGeom>
-          <a:noFill/>
-          <a:ln/>
-        </p:spPr>
-        <p:txBody>
-          <a:bodyPr wrap="square" lIns="0" tIns="0" rIns="0" bIns="0" rtlCol="0" anchor="ctr"/>
-          <a:lstStyle/>
-          <a:p>
-            <a:pPr indent="0" marL="0">
-              <a:buNone/>
-            </a:pPr>
-            <a:r>
-              <a:rPr lang="en-US" sz="3000" b="1" dirty="0">
-                <a:solidFill>
-                  <a:srgbClr val="475BA6"/>
-                </a:solidFill>
-                <a:latin typeface="Poppins" pitchFamily="34" charset="0"/>
-                <a:ea typeface="Poppins" pitchFamily="34" charset="-122"/>
-                <a:cs typeface="Poppins" pitchFamily="34" charset="-120"/>
-              </a:rPr>
-              <a:t>clever</a:t>
-            </a:r>
-            <a:pPr indent="0" marL="0">
-              <a:buNone/>
-            </a:pPr>
-            <a:r>
-              <a:rPr lang="en-US" sz="3000" b="1" dirty="0">
-                <a:solidFill>
-                  <a:srgbClr val="36448A"/>
-                </a:solidFill>
-                <a:latin typeface="Poppins" pitchFamily="34" charset="0"/>
-                <a:ea typeface="Poppins" pitchFamily="34" charset="-122"/>
-                <a:cs typeface="Poppins" pitchFamily="34" charset="-120"/>
-              </a:rPr>
-              <a:t>box</a:t>
-            </a:r>
-            <a:endParaRPr lang="en-US" sz="3000" dirty="0"/>
-          </a:p>
-        </p:txBody>
-      </p:sp>
       <p:pic>
         <p:nvPicPr>
-          <p:cNvPr id="4" name="Image 0" descr="QR-Code zu www.cleverbox.co.at">    </p:cNvPr>
+          <p:cNvPr id="3" name="Image 0" descr="cleverbox – modern. kostenlos. lehrreich.">    </p:cNvPr>
           <p:cNvPicPr>
             <a:picLocks noChangeAspect="1"/>
           </p:cNvPicPr>
@@ -1509,6 +1456,30 @@
         </p:blipFill>
         <p:spPr>
           <a:xfrm>
+            <a:off x="548640" y="201168"/>
+            <a:ext cx="2331720" cy="864835"/>
+          </a:xfrm>
+          <a:prstGeom prst="rect">
+            <a:avLst/>
+          </a:prstGeom>
+        </p:spPr>
+      </p:pic>
+      <p:pic>
+        <p:nvPicPr>
+          <p:cNvPr id="4" name="Image 1" descr="QR-Code zu www.cleverbox.co.at">    </p:cNvPr>
+          <p:cNvPicPr>
+            <a:picLocks noChangeAspect="1"/>
+          </p:cNvPicPr>
+          <p:nvPr/>
+        </p:nvPicPr>
+        <p:blipFill>
+          <a:blip r:embed="rId2"/>
+          <a:stretch>
+            <a:fillRect/>
+          </a:stretch>
+        </p:blipFill>
+        <p:spPr>
+          <a:xfrm>
             <a:off x="6144768" y="228600"/>
             <a:ext cx="868680" cy="868680"/>
           </a:xfrm>
@@ -1519,7 +1490,7 @@
       </p:pic>
       <p:sp>
         <p:nvSpPr>
-          <p:cNvPr id="5" name="Text 1"/>
+          <p:cNvPr id="5" name="Text 0"/>
           <p:cNvSpPr txBox="1"/>
           <p:nvPr/>
         </p:nvSpPr>
@@ -1581,7 +1552,7 @@
       </p:sp>
       <p:sp>
         <p:nvSpPr>
-          <p:cNvPr id="6" name="Shape 2"/>
+          <p:cNvPr id="6" name="Shape 1"/>
           <p:cNvSpPr/>
           <p:nvPr/>
         </p:nvSpPr>
@@ -1604,7 +1575,7 @@
       </p:sp>
       <p:sp>
         <p:nvSpPr>
-          <p:cNvPr id="7" name="Text 3"/>
+          <p:cNvPr id="7" name="Text 2"/>
           <p:cNvSpPr txBox="1"/>
           <p:nvPr/>
         </p:nvSpPr>
@@ -1643,7 +1614,7 @@
       </p:sp>
       <p:sp>
         <p:nvSpPr>
-          <p:cNvPr id="8" name="Text 4"/>
+          <p:cNvPr id="8" name="Text 3"/>
           <p:cNvSpPr txBox="1"/>
           <p:nvPr/>
         </p:nvSpPr>
@@ -1705,7 +1676,7 @@
       </p:sp>
       <p:sp>
         <p:nvSpPr>
-          <p:cNvPr id="9" name="Text 5"/>
+          <p:cNvPr id="9" name="Text 4"/>
           <p:cNvSpPr txBox="1"/>
           <p:nvPr/>
         </p:nvSpPr>
@@ -1744,7 +1715,7 @@
       </p:sp>
       <p:sp>
         <p:nvSpPr>
-          <p:cNvPr id="10" name="Shape 6"/>
+          <p:cNvPr id="10" name="Shape 5"/>
           <p:cNvSpPr/>
           <p:nvPr/>
         </p:nvSpPr>
@@ -1767,7 +1738,7 @@
       </p:sp>
       <p:sp>
         <p:nvSpPr>
-          <p:cNvPr id="11" name="Text 7"/>
+          <p:cNvPr id="11" name="Text 6"/>
           <p:cNvSpPr txBox="1"/>
           <p:nvPr/>
         </p:nvSpPr>
@@ -1806,7 +1777,7 @@
       </p:sp>
       <p:sp>
         <p:nvSpPr>
-          <p:cNvPr id="12" name="Shape 8"/>
+          <p:cNvPr id="12" name="Shape 7"/>
           <p:cNvSpPr/>
           <p:nvPr/>
         </p:nvSpPr>
@@ -1829,7 +1800,7 @@
       </p:sp>
       <p:sp>
         <p:nvSpPr>
-          <p:cNvPr id="13" name="Text 9"/>
+          <p:cNvPr id="13" name="Text 8"/>
           <p:cNvSpPr txBox="1"/>
           <p:nvPr/>
         </p:nvSpPr>
@@ -1868,7 +1839,7 @@
       </p:sp>
       <p:sp>
         <p:nvSpPr>
-          <p:cNvPr id="14" name="Shape 10"/>
+          <p:cNvPr id="14" name="Shape 9"/>
           <p:cNvSpPr/>
           <p:nvPr/>
         </p:nvSpPr>
@@ -1895,7 +1866,7 @@
       </p:sp>
       <p:sp>
         <p:nvSpPr>
-          <p:cNvPr id="15" name="Shape 11"/>
+          <p:cNvPr id="15" name="Shape 10"/>
           <p:cNvSpPr/>
           <p:nvPr/>
         </p:nvSpPr>
@@ -1920,7 +1891,7 @@
       </p:sp>
       <p:sp>
         <p:nvSpPr>
-          <p:cNvPr id="16" name="Text 12"/>
+          <p:cNvPr id="16" name="Text 11"/>
           <p:cNvSpPr txBox="1"/>
           <p:nvPr/>
         </p:nvSpPr>
@@ -1959,7 +1930,7 @@
       </p:sp>
       <p:sp>
         <p:nvSpPr>
-          <p:cNvPr id="17" name="Text 13"/>
+          <p:cNvPr id="17" name="Text 12"/>
           <p:cNvSpPr txBox="1"/>
           <p:nvPr/>
         </p:nvSpPr>
@@ -2001,7 +1972,7 @@
       </p:sp>
       <p:sp>
         <p:nvSpPr>
-          <p:cNvPr id="18" name="Text 14"/>
+          <p:cNvPr id="18" name="Text 13"/>
           <p:cNvSpPr txBox="1"/>
           <p:nvPr/>
         </p:nvSpPr>
@@ -2040,7 +2011,7 @@
       </p:sp>
       <p:sp>
         <p:nvSpPr>
-          <p:cNvPr id="19" name="Shape 15"/>
+          <p:cNvPr id="19" name="Shape 14"/>
           <p:cNvSpPr/>
           <p:nvPr/>
         </p:nvSpPr>
@@ -2063,7 +2034,7 @@
       </p:sp>
       <p:sp>
         <p:nvSpPr>
-          <p:cNvPr id="20" name="Text 16"/>
+          <p:cNvPr id="20" name="Text 15"/>
           <p:cNvSpPr txBox="1"/>
           <p:nvPr/>
         </p:nvSpPr>
@@ -2102,7 +2073,7 @@
       </p:sp>
       <p:sp>
         <p:nvSpPr>
-          <p:cNvPr id="21" name="Shape 17"/>
+          <p:cNvPr id="21" name="Shape 16"/>
           <p:cNvSpPr/>
           <p:nvPr/>
         </p:nvSpPr>
@@ -2125,7 +2096,7 @@
       </p:sp>
       <p:sp>
         <p:nvSpPr>
-          <p:cNvPr id="22" name="Shape 18"/>
+          <p:cNvPr id="22" name="Shape 17"/>
           <p:cNvSpPr/>
           <p:nvPr/>
         </p:nvSpPr>
@@ -2152,7 +2123,7 @@
       </p:sp>
       <p:sp>
         <p:nvSpPr>
-          <p:cNvPr id="23" name="Shape 19"/>
+          <p:cNvPr id="23" name="Shape 18"/>
           <p:cNvSpPr/>
           <p:nvPr/>
         </p:nvSpPr>
@@ -2177,7 +2148,7 @@
       </p:sp>
       <p:sp>
         <p:nvSpPr>
-          <p:cNvPr id="24" name="Text 20"/>
+          <p:cNvPr id="24" name="Text 19"/>
           <p:cNvSpPr txBox="1"/>
           <p:nvPr/>
         </p:nvSpPr>
@@ -2216,7 +2187,7 @@
       </p:sp>
       <p:sp>
         <p:nvSpPr>
-          <p:cNvPr id="25" name="Text 21"/>
+          <p:cNvPr id="25" name="Text 20"/>
           <p:cNvSpPr txBox="1"/>
           <p:nvPr/>
         </p:nvSpPr>
@@ -2258,7 +2229,7 @@
       </p:sp>
       <p:sp>
         <p:nvSpPr>
-          <p:cNvPr id="26" name="Text 22"/>
+          <p:cNvPr id="26" name="Text 21"/>
           <p:cNvSpPr txBox="1"/>
           <p:nvPr/>
         </p:nvSpPr>
@@ -2297,7 +2268,7 @@
       </p:sp>
       <p:sp>
         <p:nvSpPr>
-          <p:cNvPr id="27" name="Shape 23"/>
+          <p:cNvPr id="27" name="Shape 22"/>
           <p:cNvSpPr/>
           <p:nvPr/>
         </p:nvSpPr>
@@ -2320,7 +2291,7 @@
       </p:sp>
       <p:sp>
         <p:nvSpPr>
-          <p:cNvPr id="28" name="Text 24"/>
+          <p:cNvPr id="28" name="Text 23"/>
           <p:cNvSpPr txBox="1"/>
           <p:nvPr/>
         </p:nvSpPr>
@@ -2359,7 +2330,7 @@
       </p:sp>
       <p:sp>
         <p:nvSpPr>
-          <p:cNvPr id="29" name="Shape 25"/>
+          <p:cNvPr id="29" name="Shape 24"/>
           <p:cNvSpPr/>
           <p:nvPr/>
         </p:nvSpPr>
@@ -2382,7 +2353,7 @@
       </p:sp>
       <p:sp>
         <p:nvSpPr>
-          <p:cNvPr id="30" name="Shape 26"/>
+          <p:cNvPr id="30" name="Shape 25"/>
           <p:cNvSpPr/>
           <p:nvPr/>
         </p:nvSpPr>
@@ -2409,7 +2380,7 @@
       </p:sp>
       <p:sp>
         <p:nvSpPr>
-          <p:cNvPr id="31" name="Shape 27"/>
+          <p:cNvPr id="31" name="Shape 26"/>
           <p:cNvSpPr/>
           <p:nvPr/>
         </p:nvSpPr>
@@ -2434,7 +2405,7 @@
       </p:sp>
       <p:sp>
         <p:nvSpPr>
-          <p:cNvPr id="32" name="Text 28"/>
+          <p:cNvPr id="32" name="Text 27"/>
           <p:cNvSpPr txBox="1"/>
           <p:nvPr/>
         </p:nvSpPr>
@@ -2473,7 +2444,7 @@
       </p:sp>
       <p:sp>
         <p:nvSpPr>
-          <p:cNvPr id="33" name="Text 29"/>
+          <p:cNvPr id="33" name="Text 28"/>
           <p:cNvSpPr txBox="1"/>
           <p:nvPr/>
         </p:nvSpPr>
@@ -2515,7 +2486,7 @@
       </p:sp>
       <p:sp>
         <p:nvSpPr>
-          <p:cNvPr id="34" name="Text 30"/>
+          <p:cNvPr id="34" name="Text 29"/>
           <p:cNvSpPr txBox="1"/>
           <p:nvPr/>
         </p:nvSpPr>
@@ -2554,7 +2525,7 @@
       </p:sp>
       <p:sp>
         <p:nvSpPr>
-          <p:cNvPr id="35" name="Shape 31"/>
+          <p:cNvPr id="35" name="Shape 30"/>
           <p:cNvSpPr/>
           <p:nvPr/>
         </p:nvSpPr>
@@ -2577,7 +2548,7 @@
       </p:sp>
       <p:sp>
         <p:nvSpPr>
-          <p:cNvPr id="36" name="Text 32"/>
+          <p:cNvPr id="36" name="Text 31"/>
           <p:cNvSpPr txBox="1"/>
           <p:nvPr/>
         </p:nvSpPr>
@@ -2616,7 +2587,7 @@
       </p:sp>
       <p:sp>
         <p:nvSpPr>
-          <p:cNvPr id="37" name="Shape 33"/>
+          <p:cNvPr id="37" name="Shape 32"/>
           <p:cNvSpPr/>
           <p:nvPr/>
         </p:nvSpPr>
@@ -2662,62 +2633,9 @@
           <a:chExt cx="0" cy="0"/>
         </a:xfrm>
       </p:grpSpPr>
-      <p:sp>
-        <p:nvSpPr>
-          <p:cNvPr id="3" name="Text 0"/>
-          <p:cNvSpPr txBox="1"/>
-          <p:nvPr/>
-        </p:nvSpPr>
-        <p:spPr>
-          <a:xfrm>
-            <a:off x="548640" y="274320"/>
-            <a:ext cx="2926080" cy="731520"/>
-          </a:xfrm>
-          <a:prstGeom prst="rect">
-            <a:avLst/>
-          </a:prstGeom>
-          <a:noFill/>
-          <a:ln/>
-        </p:spPr>
-        <p:txBody>
-          <a:bodyPr wrap="square" lIns="0" tIns="0" rIns="0" bIns="0" rtlCol="0" anchor="ctr"/>
-          <a:lstStyle/>
-          <a:p>
-            <a:pPr indent="0" marL="0">
-              <a:buNone/>
-            </a:pPr>
-            <a:r>
-              <a:rPr lang="en-US" sz="3000" b="1" dirty="0">
-                <a:solidFill>
-                  <a:srgbClr val="475BA6"/>
-                </a:solidFill>
-                <a:latin typeface="Poppins" pitchFamily="34" charset="0"/>
-                <a:ea typeface="Poppins" pitchFamily="34" charset="-122"/>
-                <a:cs typeface="Poppins" pitchFamily="34" charset="-120"/>
-              </a:rPr>
-              <a:t>clever</a:t>
-            </a:r>
-            <a:pPr indent="0" marL="0">
-              <a:buNone/>
-            </a:pPr>
-            <a:r>
-              <a:rPr lang="en-US" sz="3000" b="1" dirty="0">
-                <a:solidFill>
-                  <a:srgbClr val="36448A"/>
-                </a:solidFill>
-                <a:latin typeface="Poppins" pitchFamily="34" charset="0"/>
-                <a:ea typeface="Poppins" pitchFamily="34" charset="-122"/>
-                <a:cs typeface="Poppins" pitchFamily="34" charset="-120"/>
-              </a:rPr>
-              <a:t>box</a:t>
-            </a:r>
-            <a:endParaRPr lang="en-US" sz="3000" dirty="0"/>
-          </a:p>
-        </p:txBody>
-      </p:sp>
       <p:pic>
         <p:nvPicPr>
-          <p:cNvPr id="4" name="Image 0" descr="QR-Code zu www.cleverbox.co.at">    </p:cNvPr>
+          <p:cNvPr id="3" name="Image 0" descr="cleverbox – modern. kostenlos. lehrreich.">    </p:cNvPr>
           <p:cNvPicPr>
             <a:picLocks noChangeAspect="1"/>
           </p:cNvPicPr>
@@ -2731,6 +2649,30 @@
         </p:blipFill>
         <p:spPr>
           <a:xfrm>
+            <a:off x="548640" y="201168"/>
+            <a:ext cx="2331720" cy="864835"/>
+          </a:xfrm>
+          <a:prstGeom prst="rect">
+            <a:avLst/>
+          </a:prstGeom>
+        </p:spPr>
+      </p:pic>
+      <p:pic>
+        <p:nvPicPr>
+          <p:cNvPr id="4" name="Image 1" descr="QR-Code zu www.cleverbox.co.at">    </p:cNvPr>
+          <p:cNvPicPr>
+            <a:picLocks noChangeAspect="1"/>
+          </p:cNvPicPr>
+          <p:nvPr/>
+        </p:nvPicPr>
+        <p:blipFill>
+          <a:blip r:embed="rId2"/>
+          <a:stretch>
+            <a:fillRect/>
+          </a:stretch>
+        </p:blipFill>
+        <p:spPr>
+          <a:xfrm>
             <a:off x="6144768" y="228600"/>
             <a:ext cx="868680" cy="868680"/>
           </a:xfrm>
@@ -2741,7 +2683,7 @@
       </p:pic>
       <p:sp>
         <p:nvSpPr>
-          <p:cNvPr id="5" name="Text 1"/>
+          <p:cNvPr id="5" name="Text 0"/>
           <p:cNvSpPr txBox="1"/>
           <p:nvPr/>
         </p:nvSpPr>
@@ -2803,7 +2745,7 @@
       </p:sp>
       <p:sp>
         <p:nvSpPr>
-          <p:cNvPr id="6" name="Shape 2"/>
+          <p:cNvPr id="6" name="Shape 1"/>
           <p:cNvSpPr/>
           <p:nvPr/>
         </p:nvSpPr>
@@ -2826,7 +2768,7 @@
       </p:sp>
       <p:sp>
         <p:nvSpPr>
-          <p:cNvPr id="7" name="Text 3"/>
+          <p:cNvPr id="7" name="Text 2"/>
           <p:cNvSpPr txBox="1"/>
           <p:nvPr/>
         </p:nvSpPr>
@@ -2865,7 +2807,7 @@
       </p:sp>
       <p:sp>
         <p:nvSpPr>
-          <p:cNvPr id="8" name="Shape 4"/>
+          <p:cNvPr id="8" name="Shape 3"/>
           <p:cNvSpPr/>
           <p:nvPr/>
         </p:nvSpPr>
@@ -2892,7 +2834,7 @@
       </p:sp>
       <p:sp>
         <p:nvSpPr>
-          <p:cNvPr id="9" name="Shape 5"/>
+          <p:cNvPr id="9" name="Shape 4"/>
           <p:cNvSpPr/>
           <p:nvPr/>
         </p:nvSpPr>
@@ -2917,7 +2859,7 @@
       </p:sp>
       <p:sp>
         <p:nvSpPr>
-          <p:cNvPr id="10" name="Text 6"/>
+          <p:cNvPr id="10" name="Text 5"/>
           <p:cNvSpPr txBox="1"/>
           <p:nvPr/>
         </p:nvSpPr>
@@ -2956,7 +2898,7 @@
       </p:sp>
       <p:sp>
         <p:nvSpPr>
-          <p:cNvPr id="11" name="Text 7"/>
+          <p:cNvPr id="11" name="Text 6"/>
           <p:cNvSpPr txBox="1"/>
           <p:nvPr/>
         </p:nvSpPr>
@@ -2998,7 +2940,7 @@
       </p:sp>
       <p:sp>
         <p:nvSpPr>
-          <p:cNvPr id="12" name="Text 8"/>
+          <p:cNvPr id="12" name="Text 7"/>
           <p:cNvSpPr txBox="1"/>
           <p:nvPr/>
         </p:nvSpPr>
@@ -3037,7 +2979,7 @@
       </p:sp>
       <p:sp>
         <p:nvSpPr>
-          <p:cNvPr id="13" name="Shape 9"/>
+          <p:cNvPr id="13" name="Shape 8"/>
           <p:cNvSpPr/>
           <p:nvPr/>
         </p:nvSpPr>
@@ -3060,7 +3002,7 @@
       </p:sp>
       <p:sp>
         <p:nvSpPr>
-          <p:cNvPr id="14" name="Text 10"/>
+          <p:cNvPr id="14" name="Text 9"/>
           <p:cNvSpPr txBox="1"/>
           <p:nvPr/>
         </p:nvSpPr>
@@ -3099,7 +3041,7 @@
       </p:sp>
       <p:sp>
         <p:nvSpPr>
-          <p:cNvPr id="15" name="Shape 11"/>
+          <p:cNvPr id="15" name="Shape 10"/>
           <p:cNvSpPr/>
           <p:nvPr/>
         </p:nvSpPr>
@@ -3122,7 +3064,7 @@
       </p:sp>
       <p:sp>
         <p:nvSpPr>
-          <p:cNvPr id="16" name="Shape 12"/>
+          <p:cNvPr id="16" name="Shape 11"/>
           <p:cNvSpPr/>
           <p:nvPr/>
         </p:nvSpPr>
@@ -3149,7 +3091,7 @@
       </p:sp>
       <p:sp>
         <p:nvSpPr>
-          <p:cNvPr id="17" name="Shape 13"/>
+          <p:cNvPr id="17" name="Shape 12"/>
           <p:cNvSpPr/>
           <p:nvPr/>
         </p:nvSpPr>
@@ -3174,7 +3116,7 @@
       </p:sp>
       <p:sp>
         <p:nvSpPr>
-          <p:cNvPr id="18" name="Text 14"/>
+          <p:cNvPr id="18" name="Text 13"/>
           <p:cNvSpPr txBox="1"/>
           <p:nvPr/>
         </p:nvSpPr>
@@ -3213,7 +3155,7 @@
       </p:sp>
       <p:sp>
         <p:nvSpPr>
-          <p:cNvPr id="19" name="Text 15"/>
+          <p:cNvPr id="19" name="Text 14"/>
           <p:cNvSpPr txBox="1"/>
           <p:nvPr/>
         </p:nvSpPr>
@@ -3255,7 +3197,7 @@
       </p:sp>
       <p:sp>
         <p:nvSpPr>
-          <p:cNvPr id="20" name="Text 16"/>
+          <p:cNvPr id="20" name="Text 15"/>
           <p:cNvSpPr txBox="1"/>
           <p:nvPr/>
         </p:nvSpPr>
@@ -3294,7 +3236,7 @@
       </p:sp>
       <p:sp>
         <p:nvSpPr>
-          <p:cNvPr id="21" name="Shape 17"/>
+          <p:cNvPr id="21" name="Shape 16"/>
           <p:cNvSpPr/>
           <p:nvPr/>
         </p:nvSpPr>
@@ -3317,7 +3259,7 @@
       </p:sp>
       <p:sp>
         <p:nvSpPr>
-          <p:cNvPr id="22" name="Text 18"/>
+          <p:cNvPr id="22" name="Text 17"/>
           <p:cNvSpPr txBox="1"/>
           <p:nvPr/>
         </p:nvSpPr>
@@ -3356,7 +3298,7 @@
       </p:sp>
       <p:sp>
         <p:nvSpPr>
-          <p:cNvPr id="23" name="Shape 19"/>
+          <p:cNvPr id="23" name="Shape 18"/>
           <p:cNvSpPr/>
           <p:nvPr/>
         </p:nvSpPr>
@@ -3379,7 +3321,7 @@
       </p:sp>
       <p:sp>
         <p:nvSpPr>
-          <p:cNvPr id="24" name="Shape 20"/>
+          <p:cNvPr id="24" name="Shape 19"/>
           <p:cNvSpPr/>
           <p:nvPr/>
         </p:nvSpPr>
@@ -3406,7 +3348,7 @@
       </p:sp>
       <p:sp>
         <p:nvSpPr>
-          <p:cNvPr id="25" name="Shape 21"/>
+          <p:cNvPr id="25" name="Shape 20"/>
           <p:cNvSpPr/>
           <p:nvPr/>
         </p:nvSpPr>
@@ -3431,7 +3373,7 @@
       </p:sp>
       <p:sp>
         <p:nvSpPr>
-          <p:cNvPr id="26" name="Text 22"/>
+          <p:cNvPr id="26" name="Text 21"/>
           <p:cNvSpPr txBox="1"/>
           <p:nvPr/>
         </p:nvSpPr>
@@ -3470,7 +3412,7 @@
       </p:sp>
       <p:sp>
         <p:nvSpPr>
-          <p:cNvPr id="27" name="Text 23"/>
+          <p:cNvPr id="27" name="Text 22"/>
           <p:cNvSpPr txBox="1"/>
           <p:nvPr/>
         </p:nvSpPr>
@@ -3512,7 +3454,7 @@
       </p:sp>
       <p:sp>
         <p:nvSpPr>
-          <p:cNvPr id="28" name="Text 24"/>
+          <p:cNvPr id="28" name="Text 23"/>
           <p:cNvSpPr txBox="1"/>
           <p:nvPr/>
         </p:nvSpPr>
@@ -3551,7 +3493,7 @@
       </p:sp>
       <p:sp>
         <p:nvSpPr>
-          <p:cNvPr id="29" name="Shape 25"/>
+          <p:cNvPr id="29" name="Shape 24"/>
           <p:cNvSpPr/>
           <p:nvPr/>
         </p:nvSpPr>
@@ -3574,7 +3516,7 @@
       </p:sp>
       <p:sp>
         <p:nvSpPr>
-          <p:cNvPr id="30" name="Text 26"/>
+          <p:cNvPr id="30" name="Text 25"/>
           <p:cNvSpPr txBox="1"/>
           <p:nvPr/>
         </p:nvSpPr>
@@ -3613,7 +3555,7 @@
       </p:sp>
       <p:sp>
         <p:nvSpPr>
-          <p:cNvPr id="31" name="Shape 27"/>
+          <p:cNvPr id="31" name="Shape 26"/>
           <p:cNvSpPr/>
           <p:nvPr/>
         </p:nvSpPr>
@@ -3636,7 +3578,7 @@
       </p:sp>
       <p:sp>
         <p:nvSpPr>
-          <p:cNvPr id="32" name="Shape 28"/>
+          <p:cNvPr id="32" name="Shape 27"/>
           <p:cNvSpPr/>
           <p:nvPr/>
         </p:nvSpPr>
@@ -3663,7 +3605,7 @@
       </p:sp>
       <p:sp>
         <p:nvSpPr>
-          <p:cNvPr id="33" name="Shape 29"/>
+          <p:cNvPr id="33" name="Shape 28"/>
           <p:cNvSpPr/>
           <p:nvPr/>
         </p:nvSpPr>
@@ -3688,7 +3630,7 @@
       </p:sp>
       <p:sp>
         <p:nvSpPr>
-          <p:cNvPr id="34" name="Text 30"/>
+          <p:cNvPr id="34" name="Text 29"/>
           <p:cNvSpPr txBox="1"/>
           <p:nvPr/>
         </p:nvSpPr>
@@ -3727,7 +3669,7 @@
       </p:sp>
       <p:sp>
         <p:nvSpPr>
-          <p:cNvPr id="35" name="Text 31"/>
+          <p:cNvPr id="35" name="Text 30"/>
           <p:cNvSpPr txBox="1"/>
           <p:nvPr/>
         </p:nvSpPr>
@@ -3769,7 +3711,7 @@
       </p:sp>
       <p:sp>
         <p:nvSpPr>
-          <p:cNvPr id="36" name="Text 32"/>
+          <p:cNvPr id="36" name="Text 31"/>
           <p:cNvSpPr txBox="1"/>
           <p:nvPr/>
         </p:nvSpPr>
@@ -3808,7 +3750,7 @@
       </p:sp>
       <p:sp>
         <p:nvSpPr>
-          <p:cNvPr id="37" name="Shape 33"/>
+          <p:cNvPr id="37" name="Shape 32"/>
           <p:cNvSpPr/>
           <p:nvPr/>
         </p:nvSpPr>
@@ -3831,7 +3773,7 @@
       </p:sp>
       <p:sp>
         <p:nvSpPr>
-          <p:cNvPr id="38" name="Text 34"/>
+          <p:cNvPr id="38" name="Text 33"/>
           <p:cNvSpPr txBox="1"/>
           <p:nvPr/>
         </p:nvSpPr>
@@ -3870,7 +3812,7 @@
       </p:sp>
       <p:sp>
         <p:nvSpPr>
-          <p:cNvPr id="39" name="Shape 35"/>
+          <p:cNvPr id="39" name="Shape 34"/>
           <p:cNvSpPr/>
           <p:nvPr/>
         </p:nvSpPr>
@@ -3916,62 +3858,9 @@
           <a:chExt cx="0" cy="0"/>
         </a:xfrm>
       </p:grpSpPr>
-      <p:sp>
-        <p:nvSpPr>
-          <p:cNvPr id="3" name="Text 0"/>
-          <p:cNvSpPr txBox="1"/>
-          <p:nvPr/>
-        </p:nvSpPr>
-        <p:spPr>
-          <a:xfrm>
-            <a:off x="548640" y="274320"/>
-            <a:ext cx="2926080" cy="731520"/>
-          </a:xfrm>
-          <a:prstGeom prst="rect">
-            <a:avLst/>
-          </a:prstGeom>
-          <a:noFill/>
-          <a:ln/>
-        </p:spPr>
-        <p:txBody>
-          <a:bodyPr wrap="square" lIns="0" tIns="0" rIns="0" bIns="0" rtlCol="0" anchor="ctr"/>
-          <a:lstStyle/>
-          <a:p>
-            <a:pPr indent="0" marL="0">
-              <a:buNone/>
-            </a:pPr>
-            <a:r>
-              <a:rPr lang="en-US" sz="3000" b="1" dirty="0">
-                <a:solidFill>
-                  <a:srgbClr val="475BA6"/>
-                </a:solidFill>
-                <a:latin typeface="Poppins" pitchFamily="34" charset="0"/>
-                <a:ea typeface="Poppins" pitchFamily="34" charset="-122"/>
-                <a:cs typeface="Poppins" pitchFamily="34" charset="-120"/>
-              </a:rPr>
-              <a:t>clever</a:t>
-            </a:r>
-            <a:pPr indent="0" marL="0">
-              <a:buNone/>
-            </a:pPr>
-            <a:r>
-              <a:rPr lang="en-US" sz="3000" b="1" dirty="0">
-                <a:solidFill>
-                  <a:srgbClr val="36448A"/>
-                </a:solidFill>
-                <a:latin typeface="Poppins" pitchFamily="34" charset="0"/>
-                <a:ea typeface="Poppins" pitchFamily="34" charset="-122"/>
-                <a:cs typeface="Poppins" pitchFamily="34" charset="-120"/>
-              </a:rPr>
-              <a:t>box</a:t>
-            </a:r>
-            <a:endParaRPr lang="en-US" sz="3000" dirty="0"/>
-          </a:p>
-        </p:txBody>
-      </p:sp>
       <p:pic>
         <p:nvPicPr>
-          <p:cNvPr id="4" name="Image 0" descr="QR-Code zu www.cleverbox.co.at">    </p:cNvPr>
+          <p:cNvPr id="3" name="Image 0" descr="cleverbox – modern. kostenlos. lehrreich.">    </p:cNvPr>
           <p:cNvPicPr>
             <a:picLocks noChangeAspect="1"/>
           </p:cNvPicPr>
@@ -3985,6 +3874,30 @@
         </p:blipFill>
         <p:spPr>
           <a:xfrm>
+            <a:off x="548640" y="201168"/>
+            <a:ext cx="2331720" cy="864835"/>
+          </a:xfrm>
+          <a:prstGeom prst="rect">
+            <a:avLst/>
+          </a:prstGeom>
+        </p:spPr>
+      </p:pic>
+      <p:pic>
+        <p:nvPicPr>
+          <p:cNvPr id="4" name="Image 1" descr="QR-Code zu www.cleverbox.co.at">    </p:cNvPr>
+          <p:cNvPicPr>
+            <a:picLocks noChangeAspect="1"/>
+          </p:cNvPicPr>
+          <p:nvPr/>
+        </p:nvPicPr>
+        <p:blipFill>
+          <a:blip r:embed="rId2"/>
+          <a:stretch>
+            <a:fillRect/>
+          </a:stretch>
+        </p:blipFill>
+        <p:spPr>
+          <a:xfrm>
             <a:off x="6144768" y="228600"/>
             <a:ext cx="868680" cy="868680"/>
           </a:xfrm>
@@ -3995,7 +3908,7 @@
       </p:pic>
       <p:sp>
         <p:nvSpPr>
-          <p:cNvPr id="5" name="Text 1"/>
+          <p:cNvPr id="5" name="Text 0"/>
           <p:cNvSpPr txBox="1"/>
           <p:nvPr/>
         </p:nvSpPr>
@@ -4057,7 +3970,7 @@
       </p:sp>
       <p:sp>
         <p:nvSpPr>
-          <p:cNvPr id="6" name="Shape 2"/>
+          <p:cNvPr id="6" name="Shape 1"/>
           <p:cNvSpPr/>
           <p:nvPr/>
         </p:nvSpPr>
@@ -4080,7 +3993,7 @@
       </p:sp>
       <p:sp>
         <p:nvSpPr>
-          <p:cNvPr id="7" name="Text 3"/>
+          <p:cNvPr id="7" name="Text 2"/>
           <p:cNvSpPr txBox="1"/>
           <p:nvPr/>
         </p:nvSpPr>
@@ -4119,7 +4032,7 @@
       </p:sp>
       <p:sp>
         <p:nvSpPr>
-          <p:cNvPr id="8" name="Shape 4"/>
+          <p:cNvPr id="8" name="Shape 3"/>
           <p:cNvSpPr/>
           <p:nvPr/>
         </p:nvSpPr>
@@ -4146,7 +4059,7 @@
       </p:sp>
       <p:sp>
         <p:nvSpPr>
-          <p:cNvPr id="9" name="Shape 5"/>
+          <p:cNvPr id="9" name="Shape 4"/>
           <p:cNvSpPr/>
           <p:nvPr/>
         </p:nvSpPr>
@@ -4171,7 +4084,7 @@
       </p:sp>
       <p:sp>
         <p:nvSpPr>
-          <p:cNvPr id="10" name="Text 6"/>
+          <p:cNvPr id="10" name="Text 5"/>
           <p:cNvSpPr txBox="1"/>
           <p:nvPr/>
         </p:nvSpPr>
@@ -4210,7 +4123,7 @@
       </p:sp>
       <p:sp>
         <p:nvSpPr>
-          <p:cNvPr id="11" name="Text 7"/>
+          <p:cNvPr id="11" name="Text 6"/>
           <p:cNvSpPr txBox="1"/>
           <p:nvPr/>
         </p:nvSpPr>
@@ -4252,7 +4165,7 @@
       </p:sp>
       <p:sp>
         <p:nvSpPr>
-          <p:cNvPr id="12" name="Text 8"/>
+          <p:cNvPr id="12" name="Text 7"/>
           <p:cNvSpPr txBox="1"/>
           <p:nvPr/>
         </p:nvSpPr>
@@ -4291,7 +4204,7 @@
       </p:sp>
       <p:sp>
         <p:nvSpPr>
-          <p:cNvPr id="13" name="Shape 9"/>
+          <p:cNvPr id="13" name="Shape 8"/>
           <p:cNvSpPr/>
           <p:nvPr/>
         </p:nvSpPr>
@@ -4314,7 +4227,7 @@
       </p:sp>
       <p:sp>
         <p:nvSpPr>
-          <p:cNvPr id="14" name="Text 10"/>
+          <p:cNvPr id="14" name="Text 9"/>
           <p:cNvSpPr txBox="1"/>
           <p:nvPr/>
         </p:nvSpPr>
@@ -4353,7 +4266,7 @@
       </p:sp>
       <p:sp>
         <p:nvSpPr>
-          <p:cNvPr id="15" name="Shape 11"/>
+          <p:cNvPr id="15" name="Shape 10"/>
           <p:cNvSpPr/>
           <p:nvPr/>
         </p:nvSpPr>
@@ -4376,7 +4289,7 @@
       </p:sp>
       <p:sp>
         <p:nvSpPr>
-          <p:cNvPr id="16" name="Shape 12"/>
+          <p:cNvPr id="16" name="Shape 11"/>
           <p:cNvSpPr/>
           <p:nvPr/>
         </p:nvSpPr>
@@ -4403,7 +4316,7 @@
       </p:sp>
       <p:sp>
         <p:nvSpPr>
-          <p:cNvPr id="17" name="Shape 13"/>
+          <p:cNvPr id="17" name="Shape 12"/>
           <p:cNvSpPr/>
           <p:nvPr/>
         </p:nvSpPr>
@@ -4428,7 +4341,7 @@
       </p:sp>
       <p:sp>
         <p:nvSpPr>
-          <p:cNvPr id="18" name="Text 14"/>
+          <p:cNvPr id="18" name="Text 13"/>
           <p:cNvSpPr txBox="1"/>
           <p:nvPr/>
         </p:nvSpPr>
@@ -4467,7 +4380,7 @@
       </p:sp>
       <p:sp>
         <p:nvSpPr>
-          <p:cNvPr id="19" name="Text 15"/>
+          <p:cNvPr id="19" name="Text 14"/>
           <p:cNvSpPr txBox="1"/>
           <p:nvPr/>
         </p:nvSpPr>
@@ -4509,7 +4422,7 @@
       </p:sp>
       <p:sp>
         <p:nvSpPr>
-          <p:cNvPr id="20" name="Text 16"/>
+          <p:cNvPr id="20" name="Text 15"/>
           <p:cNvSpPr txBox="1"/>
           <p:nvPr/>
         </p:nvSpPr>
@@ -4548,7 +4461,7 @@
       </p:sp>
       <p:sp>
         <p:nvSpPr>
-          <p:cNvPr id="21" name="Shape 17"/>
+          <p:cNvPr id="21" name="Shape 16"/>
           <p:cNvSpPr/>
           <p:nvPr/>
         </p:nvSpPr>
@@ -4571,7 +4484,7 @@
       </p:sp>
       <p:sp>
         <p:nvSpPr>
-          <p:cNvPr id="22" name="Text 18"/>
+          <p:cNvPr id="22" name="Text 17"/>
           <p:cNvSpPr txBox="1"/>
           <p:nvPr/>
         </p:nvSpPr>
@@ -4610,7 +4523,7 @@
       </p:sp>
       <p:sp>
         <p:nvSpPr>
-          <p:cNvPr id="23" name="Shape 19"/>
+          <p:cNvPr id="23" name="Shape 18"/>
           <p:cNvSpPr/>
           <p:nvPr/>
         </p:nvSpPr>
@@ -4633,7 +4546,7 @@
       </p:sp>
       <p:sp>
         <p:nvSpPr>
-          <p:cNvPr id="24" name="Shape 20"/>
+          <p:cNvPr id="24" name="Shape 19"/>
           <p:cNvSpPr/>
           <p:nvPr/>
         </p:nvSpPr>
@@ -4660,7 +4573,7 @@
       </p:sp>
       <p:sp>
         <p:nvSpPr>
-          <p:cNvPr id="25" name="Shape 21"/>
+          <p:cNvPr id="25" name="Shape 20"/>
           <p:cNvSpPr/>
           <p:nvPr/>
         </p:nvSpPr>
@@ -4685,7 +4598,7 @@
       </p:sp>
       <p:sp>
         <p:nvSpPr>
-          <p:cNvPr id="26" name="Text 22"/>
+          <p:cNvPr id="26" name="Text 21"/>
           <p:cNvSpPr txBox="1"/>
           <p:nvPr/>
         </p:nvSpPr>
@@ -4724,7 +4637,7 @@
       </p:sp>
       <p:sp>
         <p:nvSpPr>
-          <p:cNvPr id="27" name="Text 23"/>
+          <p:cNvPr id="27" name="Text 22"/>
           <p:cNvSpPr txBox="1"/>
           <p:nvPr/>
         </p:nvSpPr>
@@ -4766,7 +4679,7 @@
       </p:sp>
       <p:sp>
         <p:nvSpPr>
-          <p:cNvPr id="28" name="Text 24"/>
+          <p:cNvPr id="28" name="Text 23"/>
           <p:cNvSpPr txBox="1"/>
           <p:nvPr/>
         </p:nvSpPr>
@@ -4805,7 +4718,7 @@
       </p:sp>
       <p:sp>
         <p:nvSpPr>
-          <p:cNvPr id="29" name="Shape 25"/>
+          <p:cNvPr id="29" name="Shape 24"/>
           <p:cNvSpPr/>
           <p:nvPr/>
         </p:nvSpPr>
@@ -4828,7 +4741,7 @@
       </p:sp>
       <p:sp>
         <p:nvSpPr>
-          <p:cNvPr id="30" name="Text 26"/>
+          <p:cNvPr id="30" name="Text 25"/>
           <p:cNvSpPr txBox="1"/>
           <p:nvPr/>
         </p:nvSpPr>
@@ -4867,7 +4780,7 @@
       </p:sp>
       <p:sp>
         <p:nvSpPr>
-          <p:cNvPr id="31" name="Shape 27"/>
+          <p:cNvPr id="31" name="Shape 26"/>
           <p:cNvSpPr/>
           <p:nvPr/>
         </p:nvSpPr>
@@ -4913,62 +4826,9 @@
           <a:chExt cx="0" cy="0"/>
         </a:xfrm>
       </p:grpSpPr>
-      <p:sp>
-        <p:nvSpPr>
-          <p:cNvPr id="3" name="Text 0"/>
-          <p:cNvSpPr txBox="1"/>
-          <p:nvPr/>
-        </p:nvSpPr>
-        <p:spPr>
-          <a:xfrm>
-            <a:off x="548640" y="274320"/>
-            <a:ext cx="2926080" cy="731520"/>
-          </a:xfrm>
-          <a:prstGeom prst="rect">
-            <a:avLst/>
-          </a:prstGeom>
-          <a:noFill/>
-          <a:ln/>
-        </p:spPr>
-        <p:txBody>
-          <a:bodyPr wrap="square" lIns="0" tIns="0" rIns="0" bIns="0" rtlCol="0" anchor="ctr"/>
-          <a:lstStyle/>
-          <a:p>
-            <a:pPr indent="0" marL="0">
-              <a:buNone/>
-            </a:pPr>
-            <a:r>
-              <a:rPr lang="en-US" sz="3000" b="1" dirty="0">
-                <a:solidFill>
-                  <a:srgbClr val="475BA6"/>
-                </a:solidFill>
-                <a:latin typeface="Poppins" pitchFamily="34" charset="0"/>
-                <a:ea typeface="Poppins" pitchFamily="34" charset="-122"/>
-                <a:cs typeface="Poppins" pitchFamily="34" charset="-120"/>
-              </a:rPr>
-              <a:t>clever</a:t>
-            </a:r>
-            <a:pPr indent="0" marL="0">
-              <a:buNone/>
-            </a:pPr>
-            <a:r>
-              <a:rPr lang="en-US" sz="3000" b="1" dirty="0">
-                <a:solidFill>
-                  <a:srgbClr val="36448A"/>
-                </a:solidFill>
-                <a:latin typeface="Poppins" pitchFamily="34" charset="0"/>
-                <a:ea typeface="Poppins" pitchFamily="34" charset="-122"/>
-                <a:cs typeface="Poppins" pitchFamily="34" charset="-120"/>
-              </a:rPr>
-              <a:t>box</a:t>
-            </a:r>
-            <a:endParaRPr lang="en-US" sz="3000" dirty="0"/>
-          </a:p>
-        </p:txBody>
-      </p:sp>
       <p:pic>
         <p:nvPicPr>
-          <p:cNvPr id="4" name="Image 0" descr="QR-Code zu www.cleverbox.co.at">    </p:cNvPr>
+          <p:cNvPr id="3" name="Image 0" descr="cleverbox – modern. kostenlos. lehrreich.">    </p:cNvPr>
           <p:cNvPicPr>
             <a:picLocks noChangeAspect="1"/>
           </p:cNvPicPr>
@@ -4982,6 +4842,30 @@
         </p:blipFill>
         <p:spPr>
           <a:xfrm>
+            <a:off x="548640" y="201168"/>
+            <a:ext cx="2331720" cy="864835"/>
+          </a:xfrm>
+          <a:prstGeom prst="rect">
+            <a:avLst/>
+          </a:prstGeom>
+        </p:spPr>
+      </p:pic>
+      <p:pic>
+        <p:nvPicPr>
+          <p:cNvPr id="4" name="Image 1" descr="QR-Code zu www.cleverbox.co.at">    </p:cNvPr>
+          <p:cNvPicPr>
+            <a:picLocks noChangeAspect="1"/>
+          </p:cNvPicPr>
+          <p:nvPr/>
+        </p:nvPicPr>
+        <p:blipFill>
+          <a:blip r:embed="rId2"/>
+          <a:stretch>
+            <a:fillRect/>
+          </a:stretch>
+        </p:blipFill>
+        <p:spPr>
+          <a:xfrm>
             <a:off x="6144768" y="228600"/>
             <a:ext cx="868680" cy="868680"/>
           </a:xfrm>
@@ -4992,7 +4876,7 @@
       </p:pic>
       <p:sp>
         <p:nvSpPr>
-          <p:cNvPr id="5" name="Text 1"/>
+          <p:cNvPr id="5" name="Text 0"/>
           <p:cNvSpPr txBox="1"/>
           <p:nvPr/>
         </p:nvSpPr>
@@ -5054,7 +4938,7 @@
       </p:sp>
       <p:sp>
         <p:nvSpPr>
-          <p:cNvPr id="6" name="Shape 2"/>
+          <p:cNvPr id="6" name="Shape 1"/>
           <p:cNvSpPr/>
           <p:nvPr/>
         </p:nvSpPr>
@@ -5077,7 +4961,7 @@
       </p:sp>
       <p:sp>
         <p:nvSpPr>
-          <p:cNvPr id="7" name="Text 3"/>
+          <p:cNvPr id="7" name="Text 2"/>
           <p:cNvSpPr txBox="1"/>
           <p:nvPr/>
         </p:nvSpPr>
@@ -5116,7 +5000,7 @@
       </p:sp>
       <p:sp>
         <p:nvSpPr>
-          <p:cNvPr id="8" name="Shape 4"/>
+          <p:cNvPr id="8" name="Shape 3"/>
           <p:cNvSpPr/>
           <p:nvPr/>
         </p:nvSpPr>
@@ -5143,7 +5027,7 @@
       </p:sp>
       <p:sp>
         <p:nvSpPr>
-          <p:cNvPr id="9" name="Shape 5"/>
+          <p:cNvPr id="9" name="Shape 4"/>
           <p:cNvSpPr/>
           <p:nvPr/>
         </p:nvSpPr>
@@ -5168,7 +5052,7 @@
       </p:sp>
       <p:sp>
         <p:nvSpPr>
-          <p:cNvPr id="10" name="Text 6"/>
+          <p:cNvPr id="10" name="Text 5"/>
           <p:cNvSpPr txBox="1"/>
           <p:nvPr/>
         </p:nvSpPr>
@@ -5207,7 +5091,7 @@
       </p:sp>
       <p:sp>
         <p:nvSpPr>
-          <p:cNvPr id="11" name="Text 7"/>
+          <p:cNvPr id="11" name="Text 6"/>
           <p:cNvSpPr txBox="1"/>
           <p:nvPr/>
         </p:nvSpPr>
@@ -5249,7 +5133,7 @@
       </p:sp>
       <p:sp>
         <p:nvSpPr>
-          <p:cNvPr id="12" name="Text 8"/>
+          <p:cNvPr id="12" name="Text 7"/>
           <p:cNvSpPr txBox="1"/>
           <p:nvPr/>
         </p:nvSpPr>
@@ -5288,7 +5172,7 @@
       </p:sp>
       <p:sp>
         <p:nvSpPr>
-          <p:cNvPr id="13" name="Shape 9"/>
+          <p:cNvPr id="13" name="Shape 8"/>
           <p:cNvSpPr/>
           <p:nvPr/>
         </p:nvSpPr>
@@ -5311,7 +5195,7 @@
       </p:sp>
       <p:sp>
         <p:nvSpPr>
-          <p:cNvPr id="14" name="Text 10"/>
+          <p:cNvPr id="14" name="Text 9"/>
           <p:cNvSpPr txBox="1"/>
           <p:nvPr/>
         </p:nvSpPr>
@@ -5350,7 +5234,7 @@
       </p:sp>
       <p:sp>
         <p:nvSpPr>
-          <p:cNvPr id="15" name="Shape 11"/>
+          <p:cNvPr id="15" name="Shape 10"/>
           <p:cNvSpPr/>
           <p:nvPr/>
         </p:nvSpPr>
@@ -5373,7 +5257,7 @@
       </p:sp>
       <p:sp>
         <p:nvSpPr>
-          <p:cNvPr id="16" name="Shape 12"/>
+          <p:cNvPr id="16" name="Shape 11"/>
           <p:cNvSpPr/>
           <p:nvPr/>
         </p:nvSpPr>
@@ -5400,7 +5284,7 @@
       </p:sp>
       <p:sp>
         <p:nvSpPr>
-          <p:cNvPr id="17" name="Shape 13"/>
+          <p:cNvPr id="17" name="Shape 12"/>
           <p:cNvSpPr/>
           <p:nvPr/>
         </p:nvSpPr>
@@ -5425,7 +5309,7 @@
       </p:sp>
       <p:sp>
         <p:nvSpPr>
-          <p:cNvPr id="18" name="Text 14"/>
+          <p:cNvPr id="18" name="Text 13"/>
           <p:cNvSpPr txBox="1"/>
           <p:nvPr/>
         </p:nvSpPr>
@@ -5464,7 +5348,7 @@
       </p:sp>
       <p:sp>
         <p:nvSpPr>
-          <p:cNvPr id="19" name="Text 15"/>
+          <p:cNvPr id="19" name="Text 14"/>
           <p:cNvSpPr txBox="1"/>
           <p:nvPr/>
         </p:nvSpPr>
@@ -5506,7 +5390,7 @@
       </p:sp>
       <p:sp>
         <p:nvSpPr>
-          <p:cNvPr id="20" name="Text 16"/>
+          <p:cNvPr id="20" name="Text 15"/>
           <p:cNvSpPr txBox="1"/>
           <p:nvPr/>
         </p:nvSpPr>
@@ -5545,7 +5429,7 @@
       </p:sp>
       <p:sp>
         <p:nvSpPr>
-          <p:cNvPr id="21" name="Shape 17"/>
+          <p:cNvPr id="21" name="Shape 16"/>
           <p:cNvSpPr/>
           <p:nvPr/>
         </p:nvSpPr>
@@ -5568,7 +5452,7 @@
       </p:sp>
       <p:sp>
         <p:nvSpPr>
-          <p:cNvPr id="22" name="Text 18"/>
+          <p:cNvPr id="22" name="Text 17"/>
           <p:cNvSpPr txBox="1"/>
           <p:nvPr/>
         </p:nvSpPr>
@@ -5607,7 +5491,7 @@
       </p:sp>
       <p:sp>
         <p:nvSpPr>
-          <p:cNvPr id="23" name="Shape 19"/>
+          <p:cNvPr id="23" name="Shape 18"/>
           <p:cNvSpPr/>
           <p:nvPr/>
         </p:nvSpPr>
@@ -5630,7 +5514,7 @@
       </p:sp>
       <p:sp>
         <p:nvSpPr>
-          <p:cNvPr id="24" name="Shape 20"/>
+          <p:cNvPr id="24" name="Shape 19"/>
           <p:cNvSpPr/>
           <p:nvPr/>
         </p:nvSpPr>
@@ -5657,7 +5541,7 @@
       </p:sp>
       <p:sp>
         <p:nvSpPr>
-          <p:cNvPr id="25" name="Shape 21"/>
+          <p:cNvPr id="25" name="Shape 20"/>
           <p:cNvSpPr/>
           <p:nvPr/>
         </p:nvSpPr>
@@ -5682,7 +5566,7 @@
       </p:sp>
       <p:sp>
         <p:nvSpPr>
-          <p:cNvPr id="26" name="Text 22"/>
+          <p:cNvPr id="26" name="Text 21"/>
           <p:cNvSpPr txBox="1"/>
           <p:nvPr/>
         </p:nvSpPr>
@@ -5721,7 +5605,7 @@
       </p:sp>
       <p:sp>
         <p:nvSpPr>
-          <p:cNvPr id="27" name="Text 23"/>
+          <p:cNvPr id="27" name="Text 22"/>
           <p:cNvSpPr txBox="1"/>
           <p:nvPr/>
         </p:nvSpPr>
@@ -5763,7 +5647,7 @@
       </p:sp>
       <p:sp>
         <p:nvSpPr>
-          <p:cNvPr id="28" name="Text 24"/>
+          <p:cNvPr id="28" name="Text 23"/>
           <p:cNvSpPr txBox="1"/>
           <p:nvPr/>
         </p:nvSpPr>
@@ -5802,7 +5686,7 @@
       </p:sp>
       <p:sp>
         <p:nvSpPr>
-          <p:cNvPr id="29" name="Shape 25"/>
+          <p:cNvPr id="29" name="Shape 24"/>
           <p:cNvSpPr/>
           <p:nvPr/>
         </p:nvSpPr>
@@ -5825,7 +5709,7 @@
       </p:sp>
       <p:sp>
         <p:nvSpPr>
-          <p:cNvPr id="30" name="Text 26"/>
+          <p:cNvPr id="30" name="Text 25"/>
           <p:cNvSpPr txBox="1"/>
           <p:nvPr/>
         </p:nvSpPr>
@@ -5864,7 +5748,7 @@
       </p:sp>
       <p:sp>
         <p:nvSpPr>
-          <p:cNvPr id="31" name="Shape 27"/>
+          <p:cNvPr id="31" name="Shape 26"/>
           <p:cNvSpPr/>
           <p:nvPr/>
         </p:nvSpPr>
@@ -5910,62 +5794,9 @@
           <a:chExt cx="0" cy="0"/>
         </a:xfrm>
       </p:grpSpPr>
-      <p:sp>
-        <p:nvSpPr>
-          <p:cNvPr id="3" name="Text 0"/>
-          <p:cNvSpPr txBox="1"/>
-          <p:nvPr/>
-        </p:nvSpPr>
-        <p:spPr>
-          <a:xfrm>
-            <a:off x="548640" y="274320"/>
-            <a:ext cx="2926080" cy="731520"/>
-          </a:xfrm>
-          <a:prstGeom prst="rect">
-            <a:avLst/>
-          </a:prstGeom>
-          <a:noFill/>
-          <a:ln/>
-        </p:spPr>
-        <p:txBody>
-          <a:bodyPr wrap="square" lIns="0" tIns="0" rIns="0" bIns="0" rtlCol="0" anchor="ctr"/>
-          <a:lstStyle/>
-          <a:p>
-            <a:pPr indent="0" marL="0">
-              <a:buNone/>
-            </a:pPr>
-            <a:r>
-              <a:rPr lang="en-US" sz="3000" b="1" dirty="0">
-                <a:solidFill>
-                  <a:srgbClr val="475BA6"/>
-                </a:solidFill>
-                <a:latin typeface="Poppins" pitchFamily="34" charset="0"/>
-                <a:ea typeface="Poppins" pitchFamily="34" charset="-122"/>
-                <a:cs typeface="Poppins" pitchFamily="34" charset="-120"/>
-              </a:rPr>
-              <a:t>clever</a:t>
-            </a:r>
-            <a:pPr indent="0" marL="0">
-              <a:buNone/>
-            </a:pPr>
-            <a:r>
-              <a:rPr lang="en-US" sz="3000" b="1" dirty="0">
-                <a:solidFill>
-                  <a:srgbClr val="36448A"/>
-                </a:solidFill>
-                <a:latin typeface="Poppins" pitchFamily="34" charset="0"/>
-                <a:ea typeface="Poppins" pitchFamily="34" charset="-122"/>
-                <a:cs typeface="Poppins" pitchFamily="34" charset="-120"/>
-              </a:rPr>
-              <a:t>box</a:t>
-            </a:r>
-            <a:endParaRPr lang="en-US" sz="3000" dirty="0"/>
-          </a:p>
-        </p:txBody>
-      </p:sp>
       <p:pic>
         <p:nvPicPr>
-          <p:cNvPr id="4" name="Image 0" descr="QR-Code zu www.cleverbox.co.at">    </p:cNvPr>
+          <p:cNvPr id="3" name="Image 0" descr="cleverbox – modern. kostenlos. lehrreich.">    </p:cNvPr>
           <p:cNvPicPr>
             <a:picLocks noChangeAspect="1"/>
           </p:cNvPicPr>
@@ -5979,6 +5810,30 @@
         </p:blipFill>
         <p:spPr>
           <a:xfrm>
+            <a:off x="548640" y="201168"/>
+            <a:ext cx="2331720" cy="864835"/>
+          </a:xfrm>
+          <a:prstGeom prst="rect">
+            <a:avLst/>
+          </a:prstGeom>
+        </p:spPr>
+      </p:pic>
+      <p:pic>
+        <p:nvPicPr>
+          <p:cNvPr id="4" name="Image 1" descr="QR-Code zu www.cleverbox.co.at">    </p:cNvPr>
+          <p:cNvPicPr>
+            <a:picLocks noChangeAspect="1"/>
+          </p:cNvPicPr>
+          <p:nvPr/>
+        </p:nvPicPr>
+        <p:blipFill>
+          <a:blip r:embed="rId2"/>
+          <a:stretch>
+            <a:fillRect/>
+          </a:stretch>
+        </p:blipFill>
+        <p:spPr>
+          <a:xfrm>
             <a:off x="6144768" y="228600"/>
             <a:ext cx="868680" cy="868680"/>
           </a:xfrm>
@@ -5989,7 +5844,7 @@
       </p:pic>
       <p:sp>
         <p:nvSpPr>
-          <p:cNvPr id="5" name="Text 1"/>
+          <p:cNvPr id="5" name="Text 0"/>
           <p:cNvSpPr txBox="1"/>
           <p:nvPr/>
         </p:nvSpPr>
@@ -6051,7 +5906,7 @@
       </p:sp>
       <p:sp>
         <p:nvSpPr>
-          <p:cNvPr id="6" name="Shape 2"/>
+          <p:cNvPr id="6" name="Shape 1"/>
           <p:cNvSpPr/>
           <p:nvPr/>
         </p:nvSpPr>
@@ -6074,7 +5929,7 @@
       </p:sp>
       <p:sp>
         <p:nvSpPr>
-          <p:cNvPr id="7" name="Text 3"/>
+          <p:cNvPr id="7" name="Text 2"/>
           <p:cNvSpPr txBox="1"/>
           <p:nvPr/>
         </p:nvSpPr>
@@ -6113,7 +5968,7 @@
       </p:sp>
       <p:sp>
         <p:nvSpPr>
-          <p:cNvPr id="8" name="Shape 4"/>
+          <p:cNvPr id="8" name="Shape 3"/>
           <p:cNvSpPr/>
           <p:nvPr/>
         </p:nvSpPr>
@@ -6140,7 +5995,7 @@
       </p:sp>
       <p:sp>
         <p:nvSpPr>
-          <p:cNvPr id="9" name="Shape 5"/>
+          <p:cNvPr id="9" name="Shape 4"/>
           <p:cNvSpPr/>
           <p:nvPr/>
         </p:nvSpPr>
@@ -6165,7 +6020,7 @@
       </p:sp>
       <p:sp>
         <p:nvSpPr>
-          <p:cNvPr id="10" name="Text 6"/>
+          <p:cNvPr id="10" name="Text 5"/>
           <p:cNvSpPr txBox="1"/>
           <p:nvPr/>
         </p:nvSpPr>
@@ -6204,7 +6059,7 @@
       </p:sp>
       <p:sp>
         <p:nvSpPr>
-          <p:cNvPr id="11" name="Text 7"/>
+          <p:cNvPr id="11" name="Text 6"/>
           <p:cNvSpPr txBox="1"/>
           <p:nvPr/>
         </p:nvSpPr>
@@ -6286,7 +6141,7 @@
       </p:sp>
       <p:sp>
         <p:nvSpPr>
-          <p:cNvPr id="12" name="Text 8"/>
+          <p:cNvPr id="12" name="Text 7"/>
           <p:cNvSpPr txBox="1"/>
           <p:nvPr/>
         </p:nvSpPr>
@@ -6325,7 +6180,7 @@
       </p:sp>
       <p:sp>
         <p:nvSpPr>
-          <p:cNvPr id="13" name="Shape 9"/>
+          <p:cNvPr id="13" name="Shape 8"/>
           <p:cNvSpPr/>
           <p:nvPr/>
         </p:nvSpPr>
@@ -6348,7 +6203,7 @@
       </p:sp>
       <p:sp>
         <p:nvSpPr>
-          <p:cNvPr id="14" name="Text 10"/>
+          <p:cNvPr id="14" name="Text 9"/>
           <p:cNvSpPr txBox="1"/>
           <p:nvPr/>
         </p:nvSpPr>
@@ -6387,7 +6242,7 @@
       </p:sp>
       <p:sp>
         <p:nvSpPr>
-          <p:cNvPr id="15" name="Shape 11"/>
+          <p:cNvPr id="15" name="Shape 10"/>
           <p:cNvSpPr/>
           <p:nvPr/>
         </p:nvSpPr>
@@ -6410,7 +6265,7 @@
       </p:sp>
       <p:sp>
         <p:nvSpPr>
-          <p:cNvPr id="16" name="Text 12"/>
+          <p:cNvPr id="16" name="Text 11"/>
           <p:cNvSpPr txBox="1"/>
           <p:nvPr/>
         </p:nvSpPr>
@@ -6449,7 +6304,7 @@
       </p:sp>
       <p:sp>
         <p:nvSpPr>
-          <p:cNvPr id="17" name="Shape 13"/>
+          <p:cNvPr id="17" name="Shape 12"/>
           <p:cNvSpPr/>
           <p:nvPr/>
         </p:nvSpPr>
@@ -6472,7 +6327,7 @@
       </p:sp>
       <p:sp>
         <p:nvSpPr>
-          <p:cNvPr id="18" name="Shape 14"/>
+          <p:cNvPr id="18" name="Shape 13"/>
           <p:cNvSpPr/>
           <p:nvPr/>
         </p:nvSpPr>
@@ -6499,7 +6354,7 @@
       </p:sp>
       <p:sp>
         <p:nvSpPr>
-          <p:cNvPr id="19" name="Shape 15"/>
+          <p:cNvPr id="19" name="Shape 14"/>
           <p:cNvSpPr/>
           <p:nvPr/>
         </p:nvSpPr>
@@ -6524,7 +6379,7 @@
       </p:sp>
       <p:sp>
         <p:nvSpPr>
-          <p:cNvPr id="20" name="Text 16"/>
+          <p:cNvPr id="20" name="Text 15"/>
           <p:cNvSpPr txBox="1"/>
           <p:nvPr/>
         </p:nvSpPr>
@@ -6563,7 +6418,7 @@
       </p:sp>
       <p:sp>
         <p:nvSpPr>
-          <p:cNvPr id="21" name="Text 17"/>
+          <p:cNvPr id="21" name="Text 16"/>
           <p:cNvSpPr txBox="1"/>
           <p:nvPr/>
         </p:nvSpPr>
@@ -6605,7 +6460,7 @@
       </p:sp>
       <p:sp>
         <p:nvSpPr>
-          <p:cNvPr id="22" name="Text 18"/>
+          <p:cNvPr id="22" name="Text 17"/>
           <p:cNvSpPr txBox="1"/>
           <p:nvPr/>
         </p:nvSpPr>
@@ -6644,7 +6499,7 @@
       </p:sp>
       <p:sp>
         <p:nvSpPr>
-          <p:cNvPr id="23" name="Shape 19"/>
+          <p:cNvPr id="23" name="Shape 18"/>
           <p:cNvSpPr/>
           <p:nvPr/>
         </p:nvSpPr>
@@ -6667,7 +6522,7 @@
       </p:sp>
       <p:sp>
         <p:nvSpPr>
-          <p:cNvPr id="24" name="Text 20"/>
+          <p:cNvPr id="24" name="Text 19"/>
           <p:cNvSpPr txBox="1"/>
           <p:nvPr/>
         </p:nvSpPr>
@@ -6706,7 +6561,7 @@
       </p:sp>
       <p:sp>
         <p:nvSpPr>
-          <p:cNvPr id="25" name="Shape 21"/>
+          <p:cNvPr id="25" name="Shape 20"/>
           <p:cNvSpPr/>
           <p:nvPr/>
         </p:nvSpPr>
@@ -6729,7 +6584,7 @@
       </p:sp>
       <p:sp>
         <p:nvSpPr>
-          <p:cNvPr id="26" name="Shape 22"/>
+          <p:cNvPr id="26" name="Shape 21"/>
           <p:cNvSpPr/>
           <p:nvPr/>
         </p:nvSpPr>
@@ -6756,7 +6611,7 @@
       </p:sp>
       <p:sp>
         <p:nvSpPr>
-          <p:cNvPr id="27" name="Shape 23"/>
+          <p:cNvPr id="27" name="Shape 22"/>
           <p:cNvSpPr/>
           <p:nvPr/>
         </p:nvSpPr>
@@ -6781,7 +6636,7 @@
       </p:sp>
       <p:sp>
         <p:nvSpPr>
-          <p:cNvPr id="28" name="Text 24"/>
+          <p:cNvPr id="28" name="Text 23"/>
           <p:cNvSpPr txBox="1"/>
           <p:nvPr/>
         </p:nvSpPr>
@@ -6820,7 +6675,7 @@
       </p:sp>
       <p:sp>
         <p:nvSpPr>
-          <p:cNvPr id="29" name="Text 25"/>
+          <p:cNvPr id="29" name="Text 24"/>
           <p:cNvSpPr txBox="1"/>
           <p:nvPr/>
         </p:nvSpPr>
@@ -6862,7 +6717,7 @@
       </p:sp>
       <p:sp>
         <p:nvSpPr>
-          <p:cNvPr id="30" name="Text 26"/>
+          <p:cNvPr id="30" name="Text 25"/>
           <p:cNvSpPr txBox="1"/>
           <p:nvPr/>
         </p:nvSpPr>
@@ -6901,7 +6756,7 @@
       </p:sp>
       <p:sp>
         <p:nvSpPr>
-          <p:cNvPr id="31" name="Shape 27"/>
+          <p:cNvPr id="31" name="Shape 26"/>
           <p:cNvSpPr/>
           <p:nvPr/>
         </p:nvSpPr>
@@ -6924,7 +6779,7 @@
       </p:sp>
       <p:sp>
         <p:nvSpPr>
-          <p:cNvPr id="32" name="Text 28"/>
+          <p:cNvPr id="32" name="Text 27"/>
           <p:cNvSpPr txBox="1"/>
           <p:nvPr/>
         </p:nvSpPr>
@@ -6963,7 +6818,7 @@
       </p:sp>
       <p:sp>
         <p:nvSpPr>
-          <p:cNvPr id="33" name="Shape 29"/>
+          <p:cNvPr id="33" name="Shape 28"/>
           <p:cNvSpPr/>
           <p:nvPr/>
         </p:nvSpPr>

</xml_diff>